<commit_message>
Week 7: add a fully graphical transformer-block slide
One slide, one diagram, no cards. The lesson is carried by two contrasting
shapes you can read in a second: attention is a MESH (every word connected to
every other, with the lines into 'charged' picked out), feed-forward is PARALLEL
LANES (nothing crosses). Each token is drawn as a stacked bar, so you watch
'charged' stop being one solid colour and start carrying pieces of 'twice' and
'seats'. A dashed box marks one block, stacked 12 times.

Visual language follows the standard explainers (Alammar, Transformer Explainer,
nn-visual): attention routes information between tokens, the MLP refines each
token independently. Deck is 19 slides, still 60 min teaching + 30 discussion.

Co-Authored-By: Claude Opus 4.8 <noreply@anthropic.com>
</commit_message>
<xml_diff>
--- a/Week 7/L13_Support_Copilot_v3_discussion.pptx
+++ b/Week 7/L13_Support_Copilot_v3_discussion.pptx
@@ -23,6 +23,7 @@
     <p:sldId id="271" r:id="rId22"/>
     <p:sldId id="272" r:id="rId23"/>
     <p:sldId id="273" r:id="rId24"/>
+    <p:sldId id="274" r:id="rId25"/>
   </p:sldIdLst>
   <p:sldSz cx="12191695" cy="6858000" type="screen4x3"/>
   <p:notesSz cx="6858000" cy="9144000"/>
@@ -3735,7 +3736,7 @@
         <p:spPr>
           <a:xfrm>
             <a:off x="640080" y="758952"/>
-            <a:ext cx="7680960" cy="704088"/>
+            <a:ext cx="7680960" cy="1179576"/>
           </a:xfrm>
           <a:prstGeom prst="rect">
             <a:avLst/>
@@ -3750,55 +3751,20 @@
           <a:p>
             <a:pPr algn="l"/>
             <a:r>
-              <a:rPr sz="2450" b="1" i="0">
+              <a:rPr sz="2900" b="1" i="0">
                 <a:solidFill>
                   <a:srgbClr val="0F172A"/>
                 </a:solidFill>
                 <a:latin typeface="Helvetica Neue"/>
               </a:rPr>
-              <a:t>It is not a classifier. It is a fact-checker.</a:t>
-            </a:r>
-          </a:p>
-        </p:txBody>
-      </p:sp>
-      <p:sp>
-        <p:nvSpPr>
-          <p:cNvPr id="4" name="TextBox 3"/>
-          <p:cNvSpPr txBox="1"/>
-          <p:nvPr/>
-        </p:nvSpPr>
-        <p:spPr>
-          <a:xfrm>
-            <a:off x="640080" y="1417320"/>
-            <a:ext cx="10424160" cy="457200"/>
-          </a:xfrm>
-          <a:prstGeom prst="rect">
-            <a:avLst/>
-          </a:prstGeom>
-          <a:noFill/>
-        </p:spPr>
-        <p:txBody>
-          <a:bodyPr wrap="square" lIns="0" rIns="0" tIns="0" bIns="0">
-            <a:spAutoFit/>
-          </a:bodyPr>
-          <a:lstStyle/>
-          <a:p>
-            <a:pPr algn="l"/>
-            <a:r>
-              <a:rPr sz="1500" b="0" i="0">
-                <a:solidFill>
-                  <a:srgbClr val="475569"/>
-                </a:solidFill>
-                <a:latin typeface="Helvetica Neue"/>
-              </a:rPr>
-              <a:t>The model judges whether a sentence YOU wrote is true of the ticket.</a:t>
-            </a:r>
-          </a:p>
-        </p:txBody>
-      </p:sp>
-      <p:sp>
-        <p:nvSpPr>
-          <p:cNvPr id="5" name="Rounded Rectangle 4"/>
+              <a:t>Sort the inbox with no training data at all.</a:t>
+            </a:r>
+          </a:p>
+        </p:txBody>
+      </p:sp>
+      <p:sp>
+        <p:nvSpPr>
+          <p:cNvPr id="4" name="Rounded Rectangle 3"/>
           <p:cNvSpPr/>
           <p:nvPr/>
         </p:nvSpPr>
@@ -3841,7 +3807,7 @@
       </p:sp>
       <p:sp>
         <p:nvSpPr>
-          <p:cNvPr id="6" name="Rounded Rectangle 5"/>
+          <p:cNvPr id="5" name="Rounded Rectangle 4"/>
           <p:cNvSpPr/>
           <p:nvPr/>
         </p:nvSpPr>
@@ -3886,7 +3852,7 @@
       </p:sp>
       <p:sp>
         <p:nvSpPr>
-          <p:cNvPr id="7" name="TextBox 6"/>
+          <p:cNvPr id="6" name="TextBox 5"/>
           <p:cNvSpPr txBox="1"/>
           <p:nvPr/>
         </p:nvSpPr>
@@ -3921,7 +3887,7 @@
       </p:sp>
       <p:sp>
         <p:nvSpPr>
-          <p:cNvPr id="8" name="Rounded Rectangle 7"/>
+          <p:cNvPr id="7" name="Rounded Rectangle 6"/>
           <p:cNvSpPr/>
           <p:nvPr/>
         </p:nvSpPr>
@@ -3966,7 +3932,7 @@
       </p:sp>
       <p:sp>
         <p:nvSpPr>
-          <p:cNvPr id="9" name="TextBox 8"/>
+          <p:cNvPr id="8" name="TextBox 7"/>
           <p:cNvSpPr txBox="1"/>
           <p:nvPr/>
         </p:nvSpPr>
@@ -4001,7 +3967,7 @@
       </p:sp>
       <p:sp>
         <p:nvSpPr>
-          <p:cNvPr id="10" name="Rounded Rectangle 9"/>
+          <p:cNvPr id="9" name="Rounded Rectangle 8"/>
           <p:cNvSpPr/>
           <p:nvPr/>
         </p:nvSpPr>
@@ -4046,7 +4012,7 @@
       </p:sp>
       <p:sp>
         <p:nvSpPr>
-          <p:cNvPr id="11" name="TextBox 10"/>
+          <p:cNvPr id="10" name="TextBox 9"/>
           <p:cNvSpPr txBox="1"/>
           <p:nvPr/>
         </p:nvSpPr>
@@ -4081,7 +4047,7 @@
       </p:sp>
       <p:sp>
         <p:nvSpPr>
-          <p:cNvPr id="12" name="Rounded Rectangle 11"/>
+          <p:cNvPr id="11" name="Rounded Rectangle 10"/>
           <p:cNvSpPr/>
           <p:nvPr/>
         </p:nvSpPr>
@@ -4126,7 +4092,7 @@
       </p:sp>
       <p:sp>
         <p:nvSpPr>
-          <p:cNvPr id="13" name="TextBox 12"/>
+          <p:cNvPr id="12" name="TextBox 11"/>
           <p:cNvSpPr txBox="1"/>
           <p:nvPr/>
         </p:nvSpPr>
@@ -4161,7 +4127,7 @@
       </p:sp>
       <p:sp>
         <p:nvSpPr>
-          <p:cNvPr id="14" name="TextBox 13"/>
+          <p:cNvPr id="13" name="TextBox 12"/>
           <p:cNvSpPr txBox="1"/>
           <p:nvPr/>
         </p:nvSpPr>
@@ -4196,7 +4162,7 @@
       </p:sp>
       <p:pic>
         <p:nvPicPr>
-          <p:cNvPr id="15" name="Picture 14" descr="d_nli.png"/>
+          <p:cNvPr id="14" name="Picture 13" descr="d_zs.png"/>
           <p:cNvPicPr>
             <a:picLocks noChangeAspect="1"/>
           </p:cNvPicPr>
@@ -4210,8 +4176,8 @@
         </p:blipFill>
         <p:spPr>
           <a:xfrm>
-            <a:off x="518007" y="2596680"/>
-            <a:ext cx="11155680" cy="2350438"/>
+            <a:off x="1473370" y="1965960"/>
+            <a:ext cx="9244954" cy="4297679"/>
           </a:xfrm>
           <a:prstGeom prst="rect">
             <a:avLst/>
@@ -4220,14 +4186,14 @@
       </p:pic>
       <p:sp>
         <p:nvSpPr>
-          <p:cNvPr id="16" name="Rounded Rectangle 15"/>
+          <p:cNvPr id="15" name="Rounded Rectangle 14"/>
           <p:cNvSpPr/>
           <p:nvPr/>
         </p:nvSpPr>
         <p:spPr>
           <a:xfrm>
-            <a:off x="7306056" y="6345936"/>
-            <a:ext cx="4245559" cy="365760"/>
+            <a:off x="6505041" y="6345936"/>
+            <a:ext cx="5046573" cy="365760"/>
           </a:xfrm>
           <a:prstGeom prst="roundRect">
             <a:avLst>
@@ -4265,13 +4231,13 @@
       </p:sp>
       <p:sp>
         <p:nvSpPr>
-          <p:cNvPr id="17" name="Rounded Rectangle 16"/>
+          <p:cNvPr id="16" name="Rounded Rectangle 15"/>
           <p:cNvSpPr/>
           <p:nvPr/>
         </p:nvSpPr>
         <p:spPr>
           <a:xfrm>
-            <a:off x="8348472" y="6396228"/>
+            <a:off x="7547457" y="6396228"/>
             <a:ext cx="754380" cy="265176"/>
           </a:xfrm>
           <a:prstGeom prst="roundRect">
@@ -4310,14 +4276,49 @@
       </p:sp>
       <p:sp>
         <p:nvSpPr>
+          <p:cNvPr id="17" name="TextBox 16"/>
+          <p:cNvSpPr txBox="1"/>
+          <p:nvPr/>
+        </p:nvSpPr>
+        <p:spPr>
+          <a:xfrm>
+            <a:off x="6660489" y="6460236"/>
+            <a:ext cx="914400" cy="219456"/>
+          </a:xfrm>
+          <a:prstGeom prst="rect">
+            <a:avLst/>
+          </a:prstGeom>
+          <a:noFill/>
+        </p:spPr>
+        <p:txBody>
+          <a:bodyPr wrap="none" lIns="0" rIns="0" tIns="0" bIns="0">
+            <a:spAutoFit/>
+          </a:bodyPr>
+          <a:lstStyle/>
+          <a:p>
+            <a:pPr algn="l"/>
+            <a:r>
+              <a:rPr sz="950" b="1" i="0">
+                <a:solidFill>
+                  <a:srgbClr val="A7F3D0"/>
+                </a:solidFill>
+                <a:latin typeface="Helvetica Neue"/>
+              </a:rPr>
+              <a:t>▶ NOTEBOOK</a:t>
+            </a:r>
+          </a:p>
+        </p:txBody>
+      </p:sp>
+      <p:sp>
+        <p:nvSpPr>
           <p:cNvPr id="18" name="TextBox 17"/>
           <p:cNvSpPr txBox="1"/>
           <p:nvPr/>
         </p:nvSpPr>
         <p:spPr>
           <a:xfrm>
-            <a:off x="7461504" y="6460236"/>
-            <a:ext cx="914400" cy="219456"/>
+            <a:off x="7547457" y="6451092"/>
+            <a:ext cx="754380" cy="219456"/>
           </a:xfrm>
           <a:prstGeom prst="rect">
             <a:avLst/>
@@ -4330,120 +4331,50 @@
           </a:bodyPr>
           <a:lstStyle/>
           <a:p>
+            <a:pPr algn="ctr"/>
+            <a:r>
+              <a:rPr sz="1100" b="1" i="0">
+                <a:solidFill>
+                  <a:srgbClr val="FFFFFF"/>
+                </a:solidFill>
+                <a:latin typeface="Helvetica Neue"/>
+              </a:rPr>
+              <a:t>STEP 13</a:t>
+            </a:r>
+          </a:p>
+        </p:txBody>
+      </p:sp>
+      <p:sp>
+        <p:nvSpPr>
+          <p:cNvPr id="19" name="TextBox 18"/>
+          <p:cNvSpPr txBox="1"/>
+          <p:nvPr/>
+        </p:nvSpPr>
+        <p:spPr>
+          <a:xfrm>
+            <a:off x="8420709" y="6460236"/>
+            <a:ext cx="3030321" cy="219456"/>
+          </a:xfrm>
+          <a:prstGeom prst="rect">
+            <a:avLst/>
+          </a:prstGeom>
+          <a:noFill/>
+        </p:spPr>
+        <p:txBody>
+          <a:bodyPr wrap="none" lIns="0" rIns="0" tIns="0" bIns="0">
+            <a:spAutoFit/>
+          </a:bodyPr>
+          <a:lstStyle/>
+          <a:p>
             <a:pPr algn="l"/>
             <a:r>
-              <a:rPr sz="950" b="1" i="0">
-                <a:solidFill>
-                  <a:srgbClr val="A7F3D0"/>
-                </a:solidFill>
-                <a:latin typeface="Helvetica Neue"/>
-              </a:rPr>
-              <a:t>▶ NOTEBOOK</a:t>
-            </a:r>
-          </a:p>
-        </p:txBody>
-      </p:sp>
-      <p:sp>
-        <p:nvSpPr>
-          <p:cNvPr id="19" name="TextBox 18"/>
-          <p:cNvSpPr txBox="1"/>
-          <p:nvPr/>
-        </p:nvSpPr>
-        <p:spPr>
-          <a:xfrm>
-            <a:off x="8348472" y="6451092"/>
-            <a:ext cx="754380" cy="219456"/>
-          </a:xfrm>
-          <a:prstGeom prst="rect">
-            <a:avLst/>
-          </a:prstGeom>
-          <a:noFill/>
-        </p:spPr>
-        <p:txBody>
-          <a:bodyPr wrap="none" lIns="0" rIns="0" tIns="0" bIns="0">
-            <a:spAutoFit/>
-          </a:bodyPr>
-          <a:lstStyle/>
-          <a:p>
-            <a:pPr algn="ctr"/>
-            <a:r>
-              <a:rPr sz="1100" b="1" i="0">
+              <a:rPr sz="1000" b="1" i="0">
                 <a:solidFill>
                   <a:srgbClr val="FFFFFF"/>
                 </a:solidFill>
                 <a:latin typeface="Helvetica Neue"/>
               </a:rPr>
-              <a:t>STEP 17</a:t>
-            </a:r>
-          </a:p>
-        </p:txBody>
-      </p:sp>
-      <p:sp>
-        <p:nvSpPr>
-          <p:cNvPr id="20" name="TextBox 19"/>
-          <p:cNvSpPr txBox="1"/>
-          <p:nvPr/>
-        </p:nvSpPr>
-        <p:spPr>
-          <a:xfrm>
-            <a:off x="9221724" y="6460236"/>
-            <a:ext cx="2229307" cy="219456"/>
-          </a:xfrm>
-          <a:prstGeom prst="rect">
-            <a:avLst/>
-          </a:prstGeom>
-          <a:noFill/>
-        </p:spPr>
-        <p:txBody>
-          <a:bodyPr wrap="none" lIns="0" rIns="0" tIns="0" bIns="0">
-            <a:spAutoFit/>
-          </a:bodyPr>
-          <a:lstStyle/>
-          <a:p>
-            <a:pPr algn="l"/>
-            <a:r>
-              <a:rPr sz="1000" b="1" i="0">
-                <a:solidFill>
-                  <a:srgbClr val="FFFFFF"/>
-                </a:solidFill>
-                <a:latin typeface="Helvetica Neue"/>
-              </a:rPr>
-              <a:t>See the entailment scores</a:t>
-            </a:r>
-          </a:p>
-        </p:txBody>
-      </p:sp>
-      <p:sp>
-        <p:nvSpPr>
-          <p:cNvPr id="21" name="TextBox 20"/>
-          <p:cNvSpPr txBox="1"/>
-          <p:nvPr/>
-        </p:nvSpPr>
-        <p:spPr>
-          <a:xfrm>
-            <a:off x="640080" y="5532120"/>
-            <a:ext cx="10881360" cy="640080"/>
-          </a:xfrm>
-          <a:prstGeom prst="rect">
-            <a:avLst/>
-          </a:prstGeom>
-          <a:noFill/>
-        </p:spPr>
-        <p:txBody>
-          <a:bodyPr wrap="square" lIns="0" rIns="0" tIns="0" bIns="0">
-            <a:spAutoFit/>
-          </a:bodyPr>
-          <a:lstStyle/>
-          <a:p>
-            <a:pPr algn="ctr"/>
-            <a:r>
-              <a:rPr sz="1500" b="0" i="1">
-                <a:solidFill>
-                  <a:srgbClr val="475569"/>
-                </a:solidFill>
-                <a:latin typeface="Helvetica Neue"/>
-              </a:rPr>
-              <a:t>Every category becomes a sentence: "This example is {your description}." The model scores all eight and picks whichever it most believes.</a:t>
+              <a:t>Route the inbox with no training data</a:t>
             </a:r>
           </a:p>
         </p:txBody>
@@ -4510,7 +4441,7 @@
         <p:spPr>
           <a:xfrm>
             <a:off x="640080" y="758952"/>
-            <a:ext cx="7680960" cy="1179576"/>
+            <a:ext cx="7680960" cy="704088"/>
           </a:xfrm>
           <a:prstGeom prst="rect">
             <a:avLst/>
@@ -4525,20 +4456,55 @@
           <a:p>
             <a:pPr algn="l"/>
             <a:r>
-              <a:rPr sz="2900" b="1" i="0">
+              <a:rPr sz="2450" b="1" i="0">
                 <a:solidFill>
                   <a:srgbClr val="0F172A"/>
                 </a:solidFill>
                 <a:latin typeface="Helvetica Neue"/>
               </a:rPr>
-              <a:t>The descriptions you write ARE the program.</a:t>
-            </a:r>
-          </a:p>
-        </p:txBody>
-      </p:sp>
-      <p:sp>
-        <p:nvSpPr>
-          <p:cNvPr id="4" name="Rounded Rectangle 3"/>
+              <a:t>It is not a classifier. It is a fact-checker.</a:t>
+            </a:r>
+          </a:p>
+        </p:txBody>
+      </p:sp>
+      <p:sp>
+        <p:nvSpPr>
+          <p:cNvPr id="4" name="TextBox 3"/>
+          <p:cNvSpPr txBox="1"/>
+          <p:nvPr/>
+        </p:nvSpPr>
+        <p:spPr>
+          <a:xfrm>
+            <a:off x="640080" y="1417320"/>
+            <a:ext cx="10424160" cy="457200"/>
+          </a:xfrm>
+          <a:prstGeom prst="rect">
+            <a:avLst/>
+          </a:prstGeom>
+          <a:noFill/>
+        </p:spPr>
+        <p:txBody>
+          <a:bodyPr wrap="square" lIns="0" rIns="0" tIns="0" bIns="0">
+            <a:spAutoFit/>
+          </a:bodyPr>
+          <a:lstStyle/>
+          <a:p>
+            <a:pPr algn="l"/>
+            <a:r>
+              <a:rPr sz="1500" b="0" i="0">
+                <a:solidFill>
+                  <a:srgbClr val="475569"/>
+                </a:solidFill>
+                <a:latin typeface="Helvetica Neue"/>
+              </a:rPr>
+              <a:t>The model judges whether a sentence YOU wrote is true of the ticket.</a:t>
+            </a:r>
+          </a:p>
+        </p:txBody>
+      </p:sp>
+      <p:sp>
+        <p:nvSpPr>
+          <p:cNvPr id="5" name="Rounded Rectangle 4"/>
           <p:cNvSpPr/>
           <p:nvPr/>
         </p:nvSpPr>
@@ -4581,7 +4547,7 @@
       </p:sp>
       <p:sp>
         <p:nvSpPr>
-          <p:cNvPr id="5" name="Rounded Rectangle 4"/>
+          <p:cNvPr id="6" name="Rounded Rectangle 5"/>
           <p:cNvSpPr/>
           <p:nvPr/>
         </p:nvSpPr>
@@ -4626,7 +4592,7 @@
       </p:sp>
       <p:sp>
         <p:nvSpPr>
-          <p:cNvPr id="6" name="TextBox 5"/>
+          <p:cNvPr id="7" name="TextBox 6"/>
           <p:cNvSpPr txBox="1"/>
           <p:nvPr/>
         </p:nvSpPr>
@@ -4661,7 +4627,7 @@
       </p:sp>
       <p:sp>
         <p:nvSpPr>
-          <p:cNvPr id="7" name="Rounded Rectangle 6"/>
+          <p:cNvPr id="8" name="Rounded Rectangle 7"/>
           <p:cNvSpPr/>
           <p:nvPr/>
         </p:nvSpPr>
@@ -4706,7 +4672,7 @@
       </p:sp>
       <p:sp>
         <p:nvSpPr>
-          <p:cNvPr id="8" name="TextBox 7"/>
+          <p:cNvPr id="9" name="TextBox 8"/>
           <p:cNvSpPr txBox="1"/>
           <p:nvPr/>
         </p:nvSpPr>
@@ -4741,7 +4707,7 @@
       </p:sp>
       <p:sp>
         <p:nvSpPr>
-          <p:cNvPr id="9" name="Rounded Rectangle 8"/>
+          <p:cNvPr id="10" name="Rounded Rectangle 9"/>
           <p:cNvSpPr/>
           <p:nvPr/>
         </p:nvSpPr>
@@ -4786,7 +4752,7 @@
       </p:sp>
       <p:sp>
         <p:nvSpPr>
-          <p:cNvPr id="10" name="TextBox 9"/>
+          <p:cNvPr id="11" name="TextBox 10"/>
           <p:cNvSpPr txBox="1"/>
           <p:nvPr/>
         </p:nvSpPr>
@@ -4821,7 +4787,7 @@
       </p:sp>
       <p:sp>
         <p:nvSpPr>
-          <p:cNvPr id="11" name="Rounded Rectangle 10"/>
+          <p:cNvPr id="12" name="Rounded Rectangle 11"/>
           <p:cNvSpPr/>
           <p:nvPr/>
         </p:nvSpPr>
@@ -4866,7 +4832,7 @@
       </p:sp>
       <p:sp>
         <p:nvSpPr>
-          <p:cNvPr id="12" name="TextBox 11"/>
+          <p:cNvPr id="13" name="TextBox 12"/>
           <p:cNvSpPr txBox="1"/>
           <p:nvPr/>
         </p:nvSpPr>
@@ -4901,7 +4867,7 @@
       </p:sp>
       <p:sp>
         <p:nvSpPr>
-          <p:cNvPr id="13" name="TextBox 12"/>
+          <p:cNvPr id="14" name="TextBox 13"/>
           <p:cNvSpPr txBox="1"/>
           <p:nvPr/>
         </p:nvSpPr>
@@ -4936,7 +4902,7 @@
       </p:sp>
       <p:pic>
         <p:nvPicPr>
-          <p:cNvPr id="14" name="Picture 13" descr="d_wording.png"/>
+          <p:cNvPr id="15" name="Picture 14" descr="d_nli.png"/>
           <p:cNvPicPr>
             <a:picLocks noChangeAspect="1"/>
           </p:cNvPicPr>
@@ -4950,8 +4916,8 @@
         </p:blipFill>
         <p:spPr>
           <a:xfrm>
-            <a:off x="518007" y="2769342"/>
-            <a:ext cx="11155680" cy="2599474"/>
+            <a:off x="518007" y="2596680"/>
+            <a:ext cx="11155680" cy="2350438"/>
           </a:xfrm>
           <a:prstGeom prst="rect">
             <a:avLst/>
@@ -4960,14 +4926,14 @@
       </p:pic>
       <p:sp>
         <p:nvSpPr>
-          <p:cNvPr id="15" name="Rounded Rectangle 14"/>
+          <p:cNvPr id="16" name="Rounded Rectangle 15"/>
           <p:cNvSpPr/>
           <p:nvPr/>
         </p:nvSpPr>
         <p:spPr>
           <a:xfrm>
-            <a:off x="6638544" y="6345936"/>
-            <a:ext cx="4913071" cy="365760"/>
+            <a:off x="7306056" y="6345936"/>
+            <a:ext cx="4245559" cy="365760"/>
           </a:xfrm>
           <a:prstGeom prst="roundRect">
             <a:avLst>
@@ -5005,13 +4971,13 @@
       </p:sp>
       <p:sp>
         <p:nvSpPr>
-          <p:cNvPr id="16" name="Rounded Rectangle 15"/>
+          <p:cNvPr id="17" name="Rounded Rectangle 16"/>
           <p:cNvSpPr/>
           <p:nvPr/>
         </p:nvSpPr>
         <p:spPr>
           <a:xfrm>
-            <a:off x="7680960" y="6396228"/>
+            <a:off x="8348472" y="6396228"/>
             <a:ext cx="754380" cy="265176"/>
           </a:xfrm>
           <a:prstGeom prst="roundRect">
@@ -5050,13 +5016,13 @@
       </p:sp>
       <p:sp>
         <p:nvSpPr>
-          <p:cNvPr id="17" name="TextBox 16"/>
-          <p:cNvSpPr txBox="1"/>
-          <p:nvPr/>
-        </p:nvSpPr>
-        <p:spPr>
-          <a:xfrm>
-            <a:off x="6793992" y="6460236"/>
+          <p:cNvPr id="18" name="TextBox 17"/>
+          <p:cNvSpPr txBox="1"/>
+          <p:nvPr/>
+        </p:nvSpPr>
+        <p:spPr>
+          <a:xfrm>
+            <a:off x="7461504" y="6460236"/>
             <a:ext cx="914400" cy="219456"/>
           </a:xfrm>
           <a:prstGeom prst="rect">
@@ -5085,13 +5051,13 @@
       </p:sp>
       <p:sp>
         <p:nvSpPr>
-          <p:cNvPr id="18" name="TextBox 17"/>
-          <p:cNvSpPr txBox="1"/>
-          <p:nvPr/>
-        </p:nvSpPr>
-        <p:spPr>
-          <a:xfrm>
-            <a:off x="7680960" y="6451092"/>
+          <p:cNvPr id="19" name="TextBox 18"/>
+          <p:cNvSpPr txBox="1"/>
+          <p:nvPr/>
+        </p:nvSpPr>
+        <p:spPr>
+          <a:xfrm>
+            <a:off x="8348472" y="6451092"/>
             <a:ext cx="754380" cy="219456"/>
           </a:xfrm>
           <a:prstGeom prst="rect">
@@ -5113,21 +5079,21 @@
                 </a:solidFill>
                 <a:latin typeface="Helvetica Neue"/>
               </a:rPr>
-              <a:t>STEP 16</a:t>
-            </a:r>
-          </a:p>
-        </p:txBody>
-      </p:sp>
-      <p:sp>
-        <p:nvSpPr>
-          <p:cNvPr id="19" name="TextBox 18"/>
-          <p:cNvSpPr txBox="1"/>
-          <p:nvPr/>
-        </p:nvSpPr>
-        <p:spPr>
-          <a:xfrm>
-            <a:off x="8554212" y="6460236"/>
-            <a:ext cx="2896819" cy="219456"/>
+              <a:t>STEP 17</a:t>
+            </a:r>
+          </a:p>
+        </p:txBody>
+      </p:sp>
+      <p:sp>
+        <p:nvSpPr>
+          <p:cNvPr id="20" name="TextBox 19"/>
+          <p:cNvSpPr txBox="1"/>
+          <p:nvPr/>
+        </p:nvSpPr>
+        <p:spPr>
+          <a:xfrm>
+            <a:off x="9221724" y="6460236"/>
+            <a:ext cx="2229307" cy="219456"/>
           </a:xfrm>
           <a:prstGeom prst="rect">
             <a:avLst/>
@@ -5148,7 +5114,42 @@
                 </a:solidFill>
                 <a:latin typeface="Helvetica Neue"/>
               </a:rPr>
-              <a:t>YOUR KNOB: rewrite the descriptions</a:t>
+              <a:t>See the entailment scores</a:t>
+            </a:r>
+          </a:p>
+        </p:txBody>
+      </p:sp>
+      <p:sp>
+        <p:nvSpPr>
+          <p:cNvPr id="21" name="TextBox 20"/>
+          <p:cNvSpPr txBox="1"/>
+          <p:nvPr/>
+        </p:nvSpPr>
+        <p:spPr>
+          <a:xfrm>
+            <a:off x="640080" y="5532120"/>
+            <a:ext cx="10881360" cy="640080"/>
+          </a:xfrm>
+          <a:prstGeom prst="rect">
+            <a:avLst/>
+          </a:prstGeom>
+          <a:noFill/>
+        </p:spPr>
+        <p:txBody>
+          <a:bodyPr wrap="square" lIns="0" rIns="0" tIns="0" bIns="0">
+            <a:spAutoFit/>
+          </a:bodyPr>
+          <a:lstStyle/>
+          <a:p>
+            <a:pPr algn="ctr"/>
+            <a:r>
+              <a:rPr sz="1500" b="0" i="1">
+                <a:solidFill>
+                  <a:srgbClr val="475569"/>
+                </a:solidFill>
+                <a:latin typeface="Helvetica Neue"/>
+              </a:rPr>
+              <a:t>Every category becomes a sentence: "This example is {your description}." The model scores all eight and picks whichever it most believes.</a:t>
             </a:r>
           </a:p>
         </p:txBody>
@@ -5197,11 +5198,11 @@
             <a:r>
               <a:rPr sz="1250" b="1" i="0" spc="220">
                 <a:solidFill>
-                  <a:srgbClr val="059669"/>
-                </a:solidFill>
-                <a:latin typeface="Helvetica Neue"/>
-              </a:rPr>
-              <a:t>DECIDE</a:t>
+                  <a:srgbClr val="7C3AED"/>
+                </a:solidFill>
+                <a:latin typeface="Helvetica Neue"/>
+              </a:rPr>
+              <a:t>ROUTE</a:t>
             </a:r>
           </a:p>
         </p:txBody>
@@ -5215,7 +5216,7 @@
         <p:spPr>
           <a:xfrm>
             <a:off x="640080" y="758952"/>
-            <a:ext cx="7680960" cy="704088"/>
+            <a:ext cx="7680960" cy="1179576"/>
           </a:xfrm>
           <a:prstGeom prst="rect">
             <a:avLst/>
@@ -5230,55 +5231,20 @@
           <a:p>
             <a:pPr algn="l"/>
             <a:r>
-              <a:rPr sz="2650" b="1" i="0">
+              <a:rPr sz="2900" b="1" i="0">
                 <a:solidFill>
                   <a:srgbClr val="0F172A"/>
                 </a:solidFill>
                 <a:latin typeface="Helvetica Neue"/>
               </a:rPr>
-              <a:t>An average is a bad way to run a product.</a:t>
-            </a:r>
-          </a:p>
-        </p:txBody>
-      </p:sp>
-      <p:sp>
-        <p:nvSpPr>
-          <p:cNvPr id="4" name="TextBox 3"/>
-          <p:cNvSpPr txBox="1"/>
-          <p:nvPr/>
-        </p:nvSpPr>
-        <p:spPr>
-          <a:xfrm>
-            <a:off x="640080" y="1417320"/>
-            <a:ext cx="10424160" cy="457200"/>
-          </a:xfrm>
-          <a:prstGeom prst="rect">
-            <a:avLst/>
-          </a:prstGeom>
-          <a:noFill/>
-        </p:spPr>
-        <p:txBody>
-          <a:bodyPr wrap="square" lIns="0" rIns="0" tIns="0" bIns="0">
-            <a:spAutoFit/>
-          </a:bodyPr>
-          <a:lstStyle/>
-          <a:p>
-            <a:pPr algn="l"/>
-            <a:r>
-              <a:rPr sz="1500" b="0" i="0">
-                <a:solidFill>
-                  <a:srgbClr val="475569"/>
-                </a:solidFill>
-                <a:latin typeface="Helvetica Neue"/>
-              </a:rPr>
-              <a:t>Ask WHICH tickets it gets wrong. The weak buckets are the ones whose descriptions overlap.</a:t>
-            </a:r>
-          </a:p>
-        </p:txBody>
-      </p:sp>
-      <p:sp>
-        <p:nvSpPr>
-          <p:cNvPr id="5" name="Rounded Rectangle 4"/>
+              <a:t>The descriptions you write ARE the program.</a:t>
+            </a:r>
+          </a:p>
+        </p:txBody>
+      </p:sp>
+      <p:sp>
+        <p:nvSpPr>
+          <p:cNvPr id="4" name="Rounded Rectangle 3"/>
           <p:cNvSpPr/>
           <p:nvPr/>
         </p:nvSpPr>
@@ -5321,7 +5287,7 @@
       </p:sp>
       <p:sp>
         <p:nvSpPr>
-          <p:cNvPr id="6" name="Rounded Rectangle 5"/>
+          <p:cNvPr id="5" name="Rounded Rectangle 4"/>
           <p:cNvSpPr/>
           <p:nvPr/>
         </p:nvSpPr>
@@ -5366,7 +5332,7 @@
       </p:sp>
       <p:sp>
         <p:nvSpPr>
-          <p:cNvPr id="7" name="TextBox 6"/>
+          <p:cNvPr id="6" name="TextBox 5"/>
           <p:cNvSpPr txBox="1"/>
           <p:nvPr/>
         </p:nvSpPr>
@@ -5401,14 +5367,14 @@
       </p:sp>
       <p:sp>
         <p:nvSpPr>
-          <p:cNvPr id="8" name="Rounded Rectangle 7"/>
+          <p:cNvPr id="7" name="Rounded Rectangle 6"/>
           <p:cNvSpPr/>
           <p:nvPr/>
         </p:nvSpPr>
         <p:spPr>
           <a:xfrm>
-            <a:off x="9244584" y="475488"/>
-            <a:ext cx="256032" cy="256032"/>
+            <a:off x="9208008" y="438912"/>
+            <a:ext cx="329184" cy="329184"/>
           </a:xfrm>
           <a:prstGeom prst="roundRect">
             <a:avLst>
@@ -5446,14 +5412,14 @@
       </p:sp>
       <p:sp>
         <p:nvSpPr>
-          <p:cNvPr id="9" name="TextBox 8"/>
-          <p:cNvSpPr txBox="1"/>
-          <p:nvPr/>
-        </p:nvSpPr>
-        <p:spPr>
-          <a:xfrm>
-            <a:off x="9189719" y="475488"/>
-            <a:ext cx="365760" cy="256032"/>
+          <p:cNvPr id="8" name="TextBox 7"/>
+          <p:cNvSpPr txBox="1"/>
+          <p:nvPr/>
+        </p:nvSpPr>
+        <p:spPr>
+          <a:xfrm>
+            <a:off x="9153144" y="475488"/>
+            <a:ext cx="438912" cy="256032"/>
           </a:xfrm>
           <a:prstGeom prst="rect">
             <a:avLst/>
@@ -5468,7 +5434,7 @@
           <a:p>
             <a:pPr algn="ctr"/>
             <a:r>
-              <a:rPr sz="1050" b="1" i="0">
+              <a:rPr sz="1300" b="1" i="0">
                 <a:solidFill>
                   <a:srgbClr val="FFFFFF"/>
                 </a:solidFill>
@@ -5481,93 +5447,13 @@
       </p:sp>
       <p:sp>
         <p:nvSpPr>
-          <p:cNvPr id="10" name="Rounded Rectangle 9"/>
+          <p:cNvPr id="9" name="Rounded Rectangle 8"/>
           <p:cNvSpPr/>
           <p:nvPr/>
         </p:nvSpPr>
         <p:spPr>
           <a:xfrm>
-            <a:off x="9866376" y="438912"/>
-            <a:ext cx="329184" cy="329184"/>
-          </a:xfrm>
-          <a:prstGeom prst="roundRect">
-            <a:avLst>
-              <a:gd name="adj" fmla="val 32000"/>
-            </a:avLst>
-          </a:prstGeom>
-          <a:solidFill>
-            <a:srgbClr val="7C3AED"/>
-          </a:solidFill>
-          <a:ln>
-            <a:noFill/>
-          </a:ln>
-        </p:spPr>
-        <p:style>
-          <a:lnRef idx="1">
-            <a:schemeClr val="accent1"/>
-          </a:lnRef>
-          <a:fillRef idx="3">
-            <a:schemeClr val="accent1"/>
-          </a:fillRef>
-          <a:effectRef idx="2">
-            <a:schemeClr val="accent1"/>
-          </a:effectRef>
-          <a:fontRef idx="minor">
-            <a:schemeClr val="lt1"/>
-          </a:fontRef>
-        </p:style>
-        <p:txBody>
-          <a:bodyPr rtlCol="0" anchor="ctr"/>
-          <a:lstStyle/>
-          <a:p>
-            <a:pPr algn="ctr"/>
-          </a:p>
-        </p:txBody>
-      </p:sp>
-      <p:sp>
-        <p:nvSpPr>
-          <p:cNvPr id="11" name="TextBox 10"/>
-          <p:cNvSpPr txBox="1"/>
-          <p:nvPr/>
-        </p:nvSpPr>
-        <p:spPr>
-          <a:xfrm>
-            <a:off x="9811511" y="475488"/>
-            <a:ext cx="438912" cy="256032"/>
-          </a:xfrm>
-          <a:prstGeom prst="rect">
-            <a:avLst/>
-          </a:prstGeom>
-          <a:noFill/>
-        </p:spPr>
-        <p:txBody>
-          <a:bodyPr wrap="square" lIns="0" rIns="0" tIns="0" bIns="0">
-            <a:spAutoFit/>
-          </a:bodyPr>
-          <a:lstStyle/>
-          <a:p>
-            <a:pPr algn="ctr"/>
-            <a:r>
-              <a:rPr sz="1300" b="1" i="0">
-                <a:solidFill>
-                  <a:srgbClr val="FFFFFF"/>
-                </a:solidFill>
-                <a:latin typeface="Helvetica Neue"/>
-              </a:rPr>
-              <a:t>3</a:t>
-            </a:r>
-          </a:p>
-        </p:txBody>
-      </p:sp>
-      <p:sp>
-        <p:nvSpPr>
-          <p:cNvPr id="12" name="Rounded Rectangle 11"/>
-          <p:cNvSpPr/>
-          <p:nvPr/>
-        </p:nvSpPr>
-        <p:spPr>
-          <a:xfrm>
-            <a:off x="10561319" y="475488"/>
+            <a:off x="9902951" y="475488"/>
             <a:ext cx="256032" cy="256032"/>
           </a:xfrm>
           <a:prstGeom prst="roundRect">
@@ -5606,7 +5492,87 @@
       </p:sp>
       <p:sp>
         <p:nvSpPr>
-          <p:cNvPr id="13" name="TextBox 12"/>
+          <p:cNvPr id="10" name="TextBox 9"/>
+          <p:cNvSpPr txBox="1"/>
+          <p:nvPr/>
+        </p:nvSpPr>
+        <p:spPr>
+          <a:xfrm>
+            <a:off x="9848087" y="475488"/>
+            <a:ext cx="365760" cy="256032"/>
+          </a:xfrm>
+          <a:prstGeom prst="rect">
+            <a:avLst/>
+          </a:prstGeom>
+          <a:noFill/>
+        </p:spPr>
+        <p:txBody>
+          <a:bodyPr wrap="square" lIns="0" rIns="0" tIns="0" bIns="0">
+            <a:spAutoFit/>
+          </a:bodyPr>
+          <a:lstStyle/>
+          <a:p>
+            <a:pPr algn="ctr"/>
+            <a:r>
+              <a:rPr sz="1050" b="1" i="0">
+                <a:solidFill>
+                  <a:srgbClr val="AEB4BF"/>
+                </a:solidFill>
+                <a:latin typeface="Helvetica Neue"/>
+              </a:rPr>
+              <a:t>3</a:t>
+            </a:r>
+          </a:p>
+        </p:txBody>
+      </p:sp>
+      <p:sp>
+        <p:nvSpPr>
+          <p:cNvPr id="11" name="Rounded Rectangle 10"/>
+          <p:cNvSpPr/>
+          <p:nvPr/>
+        </p:nvSpPr>
+        <p:spPr>
+          <a:xfrm>
+            <a:off x="10561319" y="475488"/>
+            <a:ext cx="256032" cy="256032"/>
+          </a:xfrm>
+          <a:prstGeom prst="roundRect">
+            <a:avLst>
+              <a:gd name="adj" fmla="val 32000"/>
+            </a:avLst>
+          </a:prstGeom>
+          <a:solidFill>
+            <a:srgbClr val="E9EBF0"/>
+          </a:solidFill>
+          <a:ln>
+            <a:noFill/>
+          </a:ln>
+        </p:spPr>
+        <p:style>
+          <a:lnRef idx="1">
+            <a:schemeClr val="accent1"/>
+          </a:lnRef>
+          <a:fillRef idx="3">
+            <a:schemeClr val="accent1"/>
+          </a:fillRef>
+          <a:effectRef idx="2">
+            <a:schemeClr val="accent1"/>
+          </a:effectRef>
+          <a:fontRef idx="minor">
+            <a:schemeClr val="lt1"/>
+          </a:fontRef>
+        </p:style>
+        <p:txBody>
+          <a:bodyPr rtlCol="0" anchor="ctr"/>
+          <a:lstStyle/>
+          <a:p>
+            <a:pPr algn="ctr"/>
+          </a:p>
+        </p:txBody>
+      </p:sp>
+      <p:sp>
+        <p:nvSpPr>
+          <p:cNvPr id="12" name="TextBox 11"/>
           <p:cNvSpPr txBox="1"/>
           <p:nvPr/>
         </p:nvSpPr>
@@ -5641,7 +5607,7 @@
       </p:sp>
       <p:sp>
         <p:nvSpPr>
-          <p:cNvPr id="14" name="TextBox 13"/>
+          <p:cNvPr id="13" name="TextBox 12"/>
           <p:cNvSpPr txBox="1"/>
           <p:nvPr/>
         </p:nvSpPr>
@@ -5676,7 +5642,7 @@
       </p:sp>
       <p:pic>
         <p:nvPicPr>
-          <p:cNvPr id="15" name="Picture 14" descr="fig_recall.png"/>
+          <p:cNvPr id="14" name="Picture 13" descr="d_wording.png"/>
           <p:cNvPicPr>
             <a:picLocks noChangeAspect="1"/>
           </p:cNvPicPr>
@@ -5690,8 +5656,8 @@
         </p:blipFill>
         <p:spPr>
           <a:xfrm>
-            <a:off x="2205165" y="2057400"/>
-            <a:ext cx="7781363" cy="3977639"/>
+            <a:off x="518007" y="2769342"/>
+            <a:ext cx="11155680" cy="2599474"/>
           </a:xfrm>
           <a:prstGeom prst="rect">
             <a:avLst/>
@@ -5700,14 +5666,14 @@
       </p:pic>
       <p:sp>
         <p:nvSpPr>
-          <p:cNvPr id="16" name="Rounded Rectangle 15"/>
+          <p:cNvPr id="15" name="Rounded Rectangle 14"/>
           <p:cNvSpPr/>
           <p:nvPr/>
         </p:nvSpPr>
         <p:spPr>
           <a:xfrm>
-            <a:off x="7573060" y="6345936"/>
-            <a:ext cx="3978554" cy="365760"/>
+            <a:off x="6638544" y="6345936"/>
+            <a:ext cx="4913071" cy="365760"/>
           </a:xfrm>
           <a:prstGeom prst="roundRect">
             <a:avLst>
@@ -5745,13 +5711,13 @@
       </p:sp>
       <p:sp>
         <p:nvSpPr>
-          <p:cNvPr id="17" name="Rounded Rectangle 16"/>
+          <p:cNvPr id="16" name="Rounded Rectangle 15"/>
           <p:cNvSpPr/>
           <p:nvPr/>
         </p:nvSpPr>
         <p:spPr>
           <a:xfrm>
-            <a:off x="8615476" y="6396228"/>
+            <a:off x="7680960" y="6396228"/>
             <a:ext cx="754380" cy="265176"/>
           </a:xfrm>
           <a:prstGeom prst="roundRect">
@@ -5790,14 +5756,49 @@
       </p:sp>
       <p:sp>
         <p:nvSpPr>
+          <p:cNvPr id="17" name="TextBox 16"/>
+          <p:cNvSpPr txBox="1"/>
+          <p:nvPr/>
+        </p:nvSpPr>
+        <p:spPr>
+          <a:xfrm>
+            <a:off x="6793992" y="6460236"/>
+            <a:ext cx="914400" cy="219456"/>
+          </a:xfrm>
+          <a:prstGeom prst="rect">
+            <a:avLst/>
+          </a:prstGeom>
+          <a:noFill/>
+        </p:spPr>
+        <p:txBody>
+          <a:bodyPr wrap="none" lIns="0" rIns="0" tIns="0" bIns="0">
+            <a:spAutoFit/>
+          </a:bodyPr>
+          <a:lstStyle/>
+          <a:p>
+            <a:pPr algn="l"/>
+            <a:r>
+              <a:rPr sz="950" b="1" i="0">
+                <a:solidFill>
+                  <a:srgbClr val="A7F3D0"/>
+                </a:solidFill>
+                <a:latin typeface="Helvetica Neue"/>
+              </a:rPr>
+              <a:t>▶ NOTEBOOK</a:t>
+            </a:r>
+          </a:p>
+        </p:txBody>
+      </p:sp>
+      <p:sp>
+        <p:nvSpPr>
           <p:cNvPr id="18" name="TextBox 17"/>
           <p:cNvSpPr txBox="1"/>
           <p:nvPr/>
         </p:nvSpPr>
         <p:spPr>
           <a:xfrm>
-            <a:off x="7728508" y="6460236"/>
-            <a:ext cx="914400" cy="219456"/>
+            <a:off x="7680960" y="6451092"/>
+            <a:ext cx="754380" cy="219456"/>
           </a:xfrm>
           <a:prstGeom prst="rect">
             <a:avLst/>
@@ -5810,120 +5811,50 @@
           </a:bodyPr>
           <a:lstStyle/>
           <a:p>
+            <a:pPr algn="ctr"/>
+            <a:r>
+              <a:rPr sz="1100" b="1" i="0">
+                <a:solidFill>
+                  <a:srgbClr val="FFFFFF"/>
+                </a:solidFill>
+                <a:latin typeface="Helvetica Neue"/>
+              </a:rPr>
+              <a:t>STEP 16</a:t>
+            </a:r>
+          </a:p>
+        </p:txBody>
+      </p:sp>
+      <p:sp>
+        <p:nvSpPr>
+          <p:cNvPr id="19" name="TextBox 18"/>
+          <p:cNvSpPr txBox="1"/>
+          <p:nvPr/>
+        </p:nvSpPr>
+        <p:spPr>
+          <a:xfrm>
+            <a:off x="8554212" y="6460236"/>
+            <a:ext cx="2896819" cy="219456"/>
+          </a:xfrm>
+          <a:prstGeom prst="rect">
+            <a:avLst/>
+          </a:prstGeom>
+          <a:noFill/>
+        </p:spPr>
+        <p:txBody>
+          <a:bodyPr wrap="none" lIns="0" rIns="0" tIns="0" bIns="0">
+            <a:spAutoFit/>
+          </a:bodyPr>
+          <a:lstStyle/>
+          <a:p>
             <a:pPr algn="l"/>
             <a:r>
-              <a:rPr sz="950" b="1" i="0">
-                <a:solidFill>
-                  <a:srgbClr val="A7F3D0"/>
-                </a:solidFill>
-                <a:latin typeface="Helvetica Neue"/>
-              </a:rPr>
-              <a:t>▶ NOTEBOOK</a:t>
-            </a:r>
-          </a:p>
-        </p:txBody>
-      </p:sp>
-      <p:sp>
-        <p:nvSpPr>
-          <p:cNvPr id="19" name="TextBox 18"/>
-          <p:cNvSpPr txBox="1"/>
-          <p:nvPr/>
-        </p:nvSpPr>
-        <p:spPr>
-          <a:xfrm>
-            <a:off x="8615476" y="6451092"/>
-            <a:ext cx="754380" cy="219456"/>
-          </a:xfrm>
-          <a:prstGeom prst="rect">
-            <a:avLst/>
-          </a:prstGeom>
-          <a:noFill/>
-        </p:spPr>
-        <p:txBody>
-          <a:bodyPr wrap="none" lIns="0" rIns="0" tIns="0" bIns="0">
-            <a:spAutoFit/>
-          </a:bodyPr>
-          <a:lstStyle/>
-          <a:p>
-            <a:pPr algn="ctr"/>
-            <a:r>
-              <a:rPr sz="1100" b="1" i="0">
+              <a:rPr sz="1000" b="1" i="0">
                 <a:solidFill>
                   <a:srgbClr val="FFFFFF"/>
                 </a:solidFill>
                 <a:latin typeface="Helvetica Neue"/>
               </a:rPr>
-              <a:t>STEP 18</a:t>
-            </a:r>
-          </a:p>
-        </p:txBody>
-      </p:sp>
-      <p:sp>
-        <p:nvSpPr>
-          <p:cNvPr id="20" name="TextBox 19"/>
-          <p:cNvSpPr txBox="1"/>
-          <p:nvPr/>
-        </p:nvSpPr>
-        <p:spPr>
-          <a:xfrm>
-            <a:off x="9488728" y="6460236"/>
-            <a:ext cx="1962302" cy="219456"/>
-          </a:xfrm>
-          <a:prstGeom prst="rect">
-            <a:avLst/>
-          </a:prstGeom>
-          <a:noFill/>
-        </p:spPr>
-        <p:txBody>
-          <a:bodyPr wrap="none" lIns="0" rIns="0" tIns="0" bIns="0">
-            <a:spAutoFit/>
-          </a:bodyPr>
-          <a:lstStyle/>
-          <a:p>
-            <a:pPr algn="l"/>
-            <a:r>
-              <a:rPr sz="1000" b="1" i="0">
-                <a:solidFill>
-                  <a:srgbClr val="FFFFFF"/>
-                </a:solidFill>
-                <a:latin typeface="Helvetica Neue"/>
-              </a:rPr>
-              <a:t>Find the weak buckets</a:t>
-            </a:r>
-          </a:p>
-        </p:txBody>
-      </p:sp>
-      <p:sp>
-        <p:nvSpPr>
-          <p:cNvPr id="21" name="TextBox 20"/>
-          <p:cNvSpPr txBox="1"/>
-          <p:nvPr/>
-        </p:nvSpPr>
-        <p:spPr>
-          <a:xfrm>
-            <a:off x="640080" y="6080760"/>
-            <a:ext cx="10881360" cy="365760"/>
-          </a:xfrm>
-          <a:prstGeom prst="rect">
-            <a:avLst/>
-          </a:prstGeom>
-          <a:noFill/>
-        </p:spPr>
-        <p:txBody>
-          <a:bodyPr wrap="square" lIns="0" rIns="0" tIns="0" bIns="0">
-            <a:spAutoFit/>
-          </a:bodyPr>
-          <a:lstStyle/>
-          <a:p>
-            <a:pPr algn="ctr"/>
-            <a:r>
-              <a:rPr sz="1500" b="0" i="1">
-                <a:solidFill>
-                  <a:srgbClr val="475569"/>
-                </a:solidFill>
-                <a:latin typeface="Helvetica Neue"/>
-              </a:rPr>
-              <a:t>When a classifier underperforms, look at your taxonomy before you look at your model.</a:t>
+              <a:t>YOUR KNOB: rewrite the descriptions</a:t>
             </a:r>
           </a:p>
         </p:txBody>
@@ -6005,20 +5936,55 @@
           <a:p>
             <a:pPr algn="l"/>
             <a:r>
-              <a:rPr sz="2900" b="1" i="0">
+              <a:rPr sz="2650" b="1" i="0">
                 <a:solidFill>
                   <a:srgbClr val="0F172A"/>
                 </a:solidFill>
                 <a:latin typeface="Helvetica Neue"/>
               </a:rPr>
-              <a:t>Confident is not the same as correct.</a:t>
-            </a:r>
-          </a:p>
-        </p:txBody>
-      </p:sp>
-      <p:sp>
-        <p:nvSpPr>
-          <p:cNvPr id="4" name="Rounded Rectangle 3"/>
+              <a:t>An average is a bad way to run a product.</a:t>
+            </a:r>
+          </a:p>
+        </p:txBody>
+      </p:sp>
+      <p:sp>
+        <p:nvSpPr>
+          <p:cNvPr id="4" name="TextBox 3"/>
+          <p:cNvSpPr txBox="1"/>
+          <p:nvPr/>
+        </p:nvSpPr>
+        <p:spPr>
+          <a:xfrm>
+            <a:off x="640080" y="1417320"/>
+            <a:ext cx="10424160" cy="457200"/>
+          </a:xfrm>
+          <a:prstGeom prst="rect">
+            <a:avLst/>
+          </a:prstGeom>
+          <a:noFill/>
+        </p:spPr>
+        <p:txBody>
+          <a:bodyPr wrap="square" lIns="0" rIns="0" tIns="0" bIns="0">
+            <a:spAutoFit/>
+          </a:bodyPr>
+          <a:lstStyle/>
+          <a:p>
+            <a:pPr algn="l"/>
+            <a:r>
+              <a:rPr sz="1500" b="0" i="0">
+                <a:solidFill>
+                  <a:srgbClr val="475569"/>
+                </a:solidFill>
+                <a:latin typeface="Helvetica Neue"/>
+              </a:rPr>
+              <a:t>Ask WHICH tickets it gets wrong. The weak buckets are the ones whose descriptions overlap.</a:t>
+            </a:r>
+          </a:p>
+        </p:txBody>
+      </p:sp>
+      <p:sp>
+        <p:nvSpPr>
+          <p:cNvPr id="5" name="Rounded Rectangle 4"/>
           <p:cNvSpPr/>
           <p:nvPr/>
         </p:nvSpPr>
@@ -6061,7 +6027,7 @@
       </p:sp>
       <p:sp>
         <p:nvSpPr>
-          <p:cNvPr id="5" name="Rounded Rectangle 4"/>
+          <p:cNvPr id="6" name="Rounded Rectangle 5"/>
           <p:cNvSpPr/>
           <p:nvPr/>
         </p:nvSpPr>
@@ -6106,7 +6072,7 @@
       </p:sp>
       <p:sp>
         <p:nvSpPr>
-          <p:cNvPr id="6" name="TextBox 5"/>
+          <p:cNvPr id="7" name="TextBox 6"/>
           <p:cNvSpPr txBox="1"/>
           <p:nvPr/>
         </p:nvSpPr>
@@ -6141,7 +6107,7 @@
       </p:sp>
       <p:sp>
         <p:nvSpPr>
-          <p:cNvPr id="7" name="Rounded Rectangle 6"/>
+          <p:cNvPr id="8" name="Rounded Rectangle 7"/>
           <p:cNvSpPr/>
           <p:nvPr/>
         </p:nvSpPr>
@@ -6186,7 +6152,7 @@
       </p:sp>
       <p:sp>
         <p:nvSpPr>
-          <p:cNvPr id="8" name="TextBox 7"/>
+          <p:cNvPr id="9" name="TextBox 8"/>
           <p:cNvSpPr txBox="1"/>
           <p:nvPr/>
         </p:nvSpPr>
@@ -6221,7 +6187,7 @@
       </p:sp>
       <p:sp>
         <p:nvSpPr>
-          <p:cNvPr id="9" name="Rounded Rectangle 8"/>
+          <p:cNvPr id="10" name="Rounded Rectangle 9"/>
           <p:cNvSpPr/>
           <p:nvPr/>
         </p:nvSpPr>
@@ -6266,7 +6232,7 @@
       </p:sp>
       <p:sp>
         <p:nvSpPr>
-          <p:cNvPr id="10" name="TextBox 9"/>
+          <p:cNvPr id="11" name="TextBox 10"/>
           <p:cNvSpPr txBox="1"/>
           <p:nvPr/>
         </p:nvSpPr>
@@ -6301,7 +6267,7 @@
       </p:sp>
       <p:sp>
         <p:nvSpPr>
-          <p:cNvPr id="11" name="Rounded Rectangle 10"/>
+          <p:cNvPr id="12" name="Rounded Rectangle 11"/>
           <p:cNvSpPr/>
           <p:nvPr/>
         </p:nvSpPr>
@@ -6346,7 +6312,7 @@
       </p:sp>
       <p:sp>
         <p:nvSpPr>
-          <p:cNvPr id="12" name="TextBox 11"/>
+          <p:cNvPr id="13" name="TextBox 12"/>
           <p:cNvSpPr txBox="1"/>
           <p:nvPr/>
         </p:nvSpPr>
@@ -6381,7 +6347,7 @@
       </p:sp>
       <p:sp>
         <p:nvSpPr>
-          <p:cNvPr id="13" name="TextBox 12"/>
+          <p:cNvPr id="14" name="TextBox 13"/>
           <p:cNvSpPr txBox="1"/>
           <p:nvPr/>
         </p:nvSpPr>
@@ -6416,7 +6382,7 @@
       </p:sp>
       <p:pic>
         <p:nvPicPr>
-          <p:cNvPr id="14" name="Picture 13" descr="d_softmax.png"/>
+          <p:cNvPr id="15" name="Picture 14" descr="fig_recall.png"/>
           <p:cNvPicPr>
             <a:picLocks noChangeAspect="1"/>
           </p:cNvPicPr>
@@ -6430,8 +6396,8 @@
         </p:blipFill>
         <p:spPr>
           <a:xfrm>
-            <a:off x="518007" y="2197772"/>
-            <a:ext cx="11155680" cy="3834054"/>
+            <a:off x="2205165" y="2057400"/>
+            <a:ext cx="7781363" cy="3977639"/>
           </a:xfrm>
           <a:prstGeom prst="rect">
             <a:avLst/>
@@ -6440,14 +6406,14 @@
       </p:pic>
       <p:sp>
         <p:nvSpPr>
-          <p:cNvPr id="15" name="Rounded Rectangle 14"/>
+          <p:cNvPr id="16" name="Rounded Rectangle 15"/>
           <p:cNvSpPr/>
           <p:nvPr/>
         </p:nvSpPr>
         <p:spPr>
           <a:xfrm>
-            <a:off x="7172553" y="6345936"/>
-            <a:ext cx="4379061" cy="365760"/>
+            <a:off x="7573060" y="6345936"/>
+            <a:ext cx="3978554" cy="365760"/>
           </a:xfrm>
           <a:prstGeom prst="roundRect">
             <a:avLst>
@@ -6485,13 +6451,13 @@
       </p:sp>
       <p:sp>
         <p:nvSpPr>
-          <p:cNvPr id="16" name="Rounded Rectangle 15"/>
+          <p:cNvPr id="17" name="Rounded Rectangle 16"/>
           <p:cNvSpPr/>
           <p:nvPr/>
         </p:nvSpPr>
         <p:spPr>
           <a:xfrm>
-            <a:off x="8214969" y="6396228"/>
+            <a:off x="8615476" y="6396228"/>
             <a:ext cx="754380" cy="265176"/>
           </a:xfrm>
           <a:prstGeom prst="roundRect">
@@ -6530,13 +6496,13 @@
       </p:sp>
       <p:sp>
         <p:nvSpPr>
-          <p:cNvPr id="17" name="TextBox 16"/>
-          <p:cNvSpPr txBox="1"/>
-          <p:nvPr/>
-        </p:nvSpPr>
-        <p:spPr>
-          <a:xfrm>
-            <a:off x="7328001" y="6460236"/>
+          <p:cNvPr id="18" name="TextBox 17"/>
+          <p:cNvSpPr txBox="1"/>
+          <p:nvPr/>
+        </p:nvSpPr>
+        <p:spPr>
+          <a:xfrm>
+            <a:off x="7728508" y="6460236"/>
             <a:ext cx="914400" cy="219456"/>
           </a:xfrm>
           <a:prstGeom prst="rect">
@@ -6565,13 +6531,13 @@
       </p:sp>
       <p:sp>
         <p:nvSpPr>
-          <p:cNvPr id="18" name="TextBox 17"/>
-          <p:cNvSpPr txBox="1"/>
-          <p:nvPr/>
-        </p:nvSpPr>
-        <p:spPr>
-          <a:xfrm>
-            <a:off x="8214969" y="6451092"/>
+          <p:cNvPr id="19" name="TextBox 18"/>
+          <p:cNvSpPr txBox="1"/>
+          <p:nvPr/>
+        </p:nvSpPr>
+        <p:spPr>
+          <a:xfrm>
+            <a:off x="8615476" y="6451092"/>
             <a:ext cx="754380" cy="219456"/>
           </a:xfrm>
           <a:prstGeom prst="rect">
@@ -6593,21 +6559,21 @@
                 </a:solidFill>
                 <a:latin typeface="Helvetica Neue"/>
               </a:rPr>
-              <a:t>STEP 19</a:t>
-            </a:r>
-          </a:p>
-        </p:txBody>
-      </p:sp>
-      <p:sp>
-        <p:nvSpPr>
-          <p:cNvPr id="19" name="TextBox 18"/>
-          <p:cNvSpPr txBox="1"/>
-          <p:nvPr/>
-        </p:nvSpPr>
-        <p:spPr>
-          <a:xfrm>
-            <a:off x="9088221" y="6460236"/>
-            <a:ext cx="2362809" cy="219456"/>
+              <a:t>STEP 18</a:t>
+            </a:r>
+          </a:p>
+        </p:txBody>
+      </p:sp>
+      <p:sp>
+        <p:nvSpPr>
+          <p:cNvPr id="20" name="TextBox 19"/>
+          <p:cNvSpPr txBox="1"/>
+          <p:nvPr/>
+        </p:nvSpPr>
+        <p:spPr>
+          <a:xfrm>
+            <a:off x="9488728" y="6460236"/>
+            <a:ext cx="1962302" cy="219456"/>
           </a:xfrm>
           <a:prstGeom prst="rect">
             <a:avLst/>
@@ -6628,7 +6594,42 @@
                 </a:solidFill>
                 <a:latin typeface="Helvetica Neue"/>
               </a:rPr>
-              <a:t>Feed it an off-topic ticket</a:t>
+              <a:t>Find the weak buckets</a:t>
+            </a:r>
+          </a:p>
+        </p:txBody>
+      </p:sp>
+      <p:sp>
+        <p:nvSpPr>
+          <p:cNvPr id="21" name="TextBox 20"/>
+          <p:cNvSpPr txBox="1"/>
+          <p:nvPr/>
+        </p:nvSpPr>
+        <p:spPr>
+          <a:xfrm>
+            <a:off x="640080" y="6080760"/>
+            <a:ext cx="10881360" cy="365760"/>
+          </a:xfrm>
+          <a:prstGeom prst="rect">
+            <a:avLst/>
+          </a:prstGeom>
+          <a:noFill/>
+        </p:spPr>
+        <p:txBody>
+          <a:bodyPr wrap="square" lIns="0" rIns="0" tIns="0" bIns="0">
+            <a:spAutoFit/>
+          </a:bodyPr>
+          <a:lstStyle/>
+          <a:p>
+            <a:pPr algn="ctr"/>
+            <a:r>
+              <a:rPr sz="1500" b="0" i="1">
+                <a:solidFill>
+                  <a:srgbClr val="475569"/>
+                </a:solidFill>
+                <a:latin typeface="Helvetica Neue"/>
+              </a:rPr>
+              <a:t>When a classifier underperforms, look at your taxonomy before you look at your model.</a:t>
             </a:r>
           </a:p>
         </p:txBody>
@@ -6710,55 +6711,20 @@
           <a:p>
             <a:pPr algn="l"/>
             <a:r>
-              <a:rPr sz="2650" b="1" i="0">
+              <a:rPr sz="2900" b="1" i="0">
                 <a:solidFill>
                   <a:srgbClr val="0F172A"/>
                 </a:solidFill>
                 <a:latin typeface="Helvetica Neue"/>
               </a:rPr>
-              <a:t>What a mistake costs decides the setting.</a:t>
-            </a:r>
-          </a:p>
-        </p:txBody>
-      </p:sp>
-      <p:sp>
-        <p:nvSpPr>
-          <p:cNvPr id="4" name="TextBox 3"/>
-          <p:cNvSpPr txBox="1"/>
-          <p:nvPr/>
-        </p:nvSpPr>
-        <p:spPr>
-          <a:xfrm>
-            <a:off x="640080" y="1417320"/>
-            <a:ext cx="10424160" cy="457200"/>
-          </a:xfrm>
-          <a:prstGeom prst="rect">
-            <a:avLst/>
-          </a:prstGeom>
-          <a:noFill/>
-        </p:spPr>
-        <p:txBody>
-          <a:bodyPr wrap="square" lIns="0" rIns="0" tIns="0" bIns="0">
-            <a:spAutoFit/>
-          </a:bodyPr>
-          <a:lstStyle/>
-          <a:p>
-            <a:pPr algn="l"/>
-            <a:r>
-              <a:rPr sz="1500" b="0" i="0">
-                <a:solidFill>
-                  <a:srgbClr val="475569"/>
-                </a:solidFill>
-                <a:latin typeface="Helvetica Neue"/>
-              </a:rPr>
-              <a:t>Same copilot, same tickets, six companies. Ask your neighbour: for the hospital, high bar or low?</a:t>
-            </a:r>
-          </a:p>
-        </p:txBody>
-      </p:sp>
-      <p:sp>
-        <p:nvSpPr>
-          <p:cNvPr id="5" name="Rounded Rectangle 4"/>
+              <a:t>Confident is not the same as correct.</a:t>
+            </a:r>
+          </a:p>
+        </p:txBody>
+      </p:sp>
+      <p:sp>
+        <p:nvSpPr>
+          <p:cNvPr id="4" name="Rounded Rectangle 3"/>
           <p:cNvSpPr/>
           <p:nvPr/>
         </p:nvSpPr>
@@ -6801,7 +6767,7 @@
       </p:sp>
       <p:sp>
         <p:nvSpPr>
-          <p:cNvPr id="6" name="Rounded Rectangle 5"/>
+          <p:cNvPr id="5" name="Rounded Rectangle 4"/>
           <p:cNvSpPr/>
           <p:nvPr/>
         </p:nvSpPr>
@@ -6846,7 +6812,7 @@
       </p:sp>
       <p:sp>
         <p:nvSpPr>
-          <p:cNvPr id="7" name="TextBox 6"/>
+          <p:cNvPr id="6" name="TextBox 5"/>
           <p:cNvSpPr txBox="1"/>
           <p:nvPr/>
         </p:nvSpPr>
@@ -6881,7 +6847,7 @@
       </p:sp>
       <p:sp>
         <p:nvSpPr>
-          <p:cNvPr id="8" name="Rounded Rectangle 7"/>
+          <p:cNvPr id="7" name="Rounded Rectangle 6"/>
           <p:cNvSpPr/>
           <p:nvPr/>
         </p:nvSpPr>
@@ -6926,7 +6892,7 @@
       </p:sp>
       <p:sp>
         <p:nvSpPr>
-          <p:cNvPr id="9" name="TextBox 8"/>
+          <p:cNvPr id="8" name="TextBox 7"/>
           <p:cNvSpPr txBox="1"/>
           <p:nvPr/>
         </p:nvSpPr>
@@ -6961,14 +6927,14 @@
       </p:sp>
       <p:sp>
         <p:nvSpPr>
-          <p:cNvPr id="10" name="Rounded Rectangle 9"/>
+          <p:cNvPr id="9" name="Rounded Rectangle 8"/>
           <p:cNvSpPr/>
           <p:nvPr/>
         </p:nvSpPr>
         <p:spPr>
           <a:xfrm>
-            <a:off x="9902951" y="475488"/>
-            <a:ext cx="256032" cy="256032"/>
+            <a:off x="9866376" y="438912"/>
+            <a:ext cx="329184" cy="329184"/>
           </a:xfrm>
           <a:prstGeom prst="roundRect">
             <a:avLst>
@@ -7006,14 +6972,14 @@
       </p:sp>
       <p:sp>
         <p:nvSpPr>
-          <p:cNvPr id="11" name="TextBox 10"/>
-          <p:cNvSpPr txBox="1"/>
-          <p:nvPr/>
-        </p:nvSpPr>
-        <p:spPr>
-          <a:xfrm>
-            <a:off x="9848087" y="475488"/>
-            <a:ext cx="365760" cy="256032"/>
+          <p:cNvPr id="10" name="TextBox 9"/>
+          <p:cNvSpPr txBox="1"/>
+          <p:nvPr/>
+        </p:nvSpPr>
+        <p:spPr>
+          <a:xfrm>
+            <a:off x="9811511" y="475488"/>
+            <a:ext cx="438912" cy="256032"/>
           </a:xfrm>
           <a:prstGeom prst="rect">
             <a:avLst/>
@@ -7028,7 +6994,7 @@
           <a:p>
             <a:pPr algn="ctr"/>
             <a:r>
-              <a:rPr sz="1050" b="1" i="0">
+              <a:rPr sz="1300" b="1" i="0">
                 <a:solidFill>
                   <a:srgbClr val="FFFFFF"/>
                 </a:solidFill>
@@ -7041,14 +7007,14 @@
       </p:sp>
       <p:sp>
         <p:nvSpPr>
-          <p:cNvPr id="12" name="Rounded Rectangle 11"/>
+          <p:cNvPr id="11" name="Rounded Rectangle 10"/>
           <p:cNvSpPr/>
           <p:nvPr/>
         </p:nvSpPr>
         <p:spPr>
           <a:xfrm>
-            <a:off x="10524744" y="438912"/>
-            <a:ext cx="329184" cy="329184"/>
+            <a:off x="10561319" y="475488"/>
+            <a:ext cx="256032" cy="256032"/>
           </a:xfrm>
           <a:prstGeom prst="roundRect">
             <a:avLst>
@@ -7056,7 +7022,7 @@
             </a:avLst>
           </a:prstGeom>
           <a:solidFill>
-            <a:srgbClr val="059669"/>
+            <a:srgbClr val="E9EBF0"/>
           </a:solidFill>
           <a:ln>
             <a:noFill/>
@@ -7086,42 +7052,42 @@
       </p:sp>
       <p:sp>
         <p:nvSpPr>
+          <p:cNvPr id="12" name="TextBox 11"/>
+          <p:cNvSpPr txBox="1"/>
+          <p:nvPr/>
+        </p:nvSpPr>
+        <p:spPr>
+          <a:xfrm>
+            <a:off x="10506455" y="475488"/>
+            <a:ext cx="365760" cy="256032"/>
+          </a:xfrm>
+          <a:prstGeom prst="rect">
+            <a:avLst/>
+          </a:prstGeom>
+          <a:noFill/>
+        </p:spPr>
+        <p:txBody>
+          <a:bodyPr wrap="square" lIns="0" rIns="0" tIns="0" bIns="0">
+            <a:spAutoFit/>
+          </a:bodyPr>
+          <a:lstStyle/>
+          <a:p>
+            <a:pPr algn="ctr"/>
+            <a:r>
+              <a:rPr sz="1050" b="1" i="0">
+                <a:solidFill>
+                  <a:srgbClr val="AEB4BF"/>
+                </a:solidFill>
+                <a:latin typeface="Helvetica Neue"/>
+              </a:rPr>
+              <a:t>4</a:t>
+            </a:r>
+          </a:p>
+        </p:txBody>
+      </p:sp>
+      <p:sp>
+        <p:nvSpPr>
           <p:cNvPr id="13" name="TextBox 12"/>
-          <p:cNvSpPr txBox="1"/>
-          <p:nvPr/>
-        </p:nvSpPr>
-        <p:spPr>
-          <a:xfrm>
-            <a:off x="10469880" y="475488"/>
-            <a:ext cx="438912" cy="256032"/>
-          </a:xfrm>
-          <a:prstGeom prst="rect">
-            <a:avLst/>
-          </a:prstGeom>
-          <a:noFill/>
-        </p:spPr>
-        <p:txBody>
-          <a:bodyPr wrap="square" lIns="0" rIns="0" tIns="0" bIns="0">
-            <a:spAutoFit/>
-          </a:bodyPr>
-          <a:lstStyle/>
-          <a:p>
-            <a:pPr algn="ctr"/>
-            <a:r>
-              <a:rPr sz="1300" b="1" i="0">
-                <a:solidFill>
-                  <a:srgbClr val="FFFFFF"/>
-                </a:solidFill>
-                <a:latin typeface="Helvetica Neue"/>
-              </a:rPr>
-              <a:t>4</a:t>
-            </a:r>
-          </a:p>
-        </p:txBody>
-      </p:sp>
-      <p:sp>
-        <p:nvSpPr>
-          <p:cNvPr id="14" name="TextBox 13"/>
           <p:cNvSpPr txBox="1"/>
           <p:nvPr/>
         </p:nvSpPr>
@@ -7156,7 +7122,7 @@
       </p:sp>
       <p:pic>
         <p:nvPicPr>
-          <p:cNvPr id="15" name="Picture 14" descr="fig_game.png"/>
+          <p:cNvPr id="14" name="Picture 13" descr="d_softmax.png"/>
           <p:cNvPicPr>
             <a:picLocks noChangeAspect="1"/>
           </p:cNvPicPr>
@@ -7170,8 +7136,8 @@
         </p:blipFill>
         <p:spPr>
           <a:xfrm>
-            <a:off x="2207847" y="2011680"/>
-            <a:ext cx="7775999" cy="3931920"/>
+            <a:off x="518007" y="2197772"/>
+            <a:ext cx="11155680" cy="3834054"/>
           </a:xfrm>
           <a:prstGeom prst="rect">
             <a:avLst/>
@@ -7180,14 +7146,14 @@
       </p:pic>
       <p:sp>
         <p:nvSpPr>
-          <p:cNvPr id="16" name="Rounded Rectangle 15"/>
+          <p:cNvPr id="15" name="Rounded Rectangle 14"/>
           <p:cNvSpPr/>
           <p:nvPr/>
         </p:nvSpPr>
         <p:spPr>
           <a:xfrm>
-            <a:off x="7105802" y="6345936"/>
-            <a:ext cx="4445812" cy="365760"/>
+            <a:off x="7172553" y="6345936"/>
+            <a:ext cx="4379061" cy="365760"/>
           </a:xfrm>
           <a:prstGeom prst="roundRect">
             <a:avLst>
@@ -7225,13 +7191,13 @@
       </p:sp>
       <p:sp>
         <p:nvSpPr>
-          <p:cNvPr id="17" name="Rounded Rectangle 16"/>
+          <p:cNvPr id="16" name="Rounded Rectangle 15"/>
           <p:cNvSpPr/>
           <p:nvPr/>
         </p:nvSpPr>
         <p:spPr>
           <a:xfrm>
-            <a:off x="8148218" y="6396228"/>
+            <a:off x="8214969" y="6396228"/>
             <a:ext cx="754380" cy="265176"/>
           </a:xfrm>
           <a:prstGeom prst="roundRect">
@@ -7270,14 +7236,49 @@
       </p:sp>
       <p:sp>
         <p:nvSpPr>
+          <p:cNvPr id="17" name="TextBox 16"/>
+          <p:cNvSpPr txBox="1"/>
+          <p:nvPr/>
+        </p:nvSpPr>
+        <p:spPr>
+          <a:xfrm>
+            <a:off x="7328001" y="6460236"/>
+            <a:ext cx="914400" cy="219456"/>
+          </a:xfrm>
+          <a:prstGeom prst="rect">
+            <a:avLst/>
+          </a:prstGeom>
+          <a:noFill/>
+        </p:spPr>
+        <p:txBody>
+          <a:bodyPr wrap="none" lIns="0" rIns="0" tIns="0" bIns="0">
+            <a:spAutoFit/>
+          </a:bodyPr>
+          <a:lstStyle/>
+          <a:p>
+            <a:pPr algn="l"/>
+            <a:r>
+              <a:rPr sz="950" b="1" i="0">
+                <a:solidFill>
+                  <a:srgbClr val="A7F3D0"/>
+                </a:solidFill>
+                <a:latin typeface="Helvetica Neue"/>
+              </a:rPr>
+              <a:t>▶ NOTEBOOK</a:t>
+            </a:r>
+          </a:p>
+        </p:txBody>
+      </p:sp>
+      <p:sp>
+        <p:nvSpPr>
           <p:cNvPr id="18" name="TextBox 17"/>
           <p:cNvSpPr txBox="1"/>
           <p:nvPr/>
         </p:nvSpPr>
         <p:spPr>
           <a:xfrm>
-            <a:off x="7261250" y="6460236"/>
-            <a:ext cx="914400" cy="219456"/>
+            <a:off x="8214969" y="6451092"/>
+            <a:ext cx="754380" cy="219456"/>
           </a:xfrm>
           <a:prstGeom prst="rect">
             <a:avLst/>
@@ -7290,120 +7291,50 @@
           </a:bodyPr>
           <a:lstStyle/>
           <a:p>
+            <a:pPr algn="ctr"/>
+            <a:r>
+              <a:rPr sz="1100" b="1" i="0">
+                <a:solidFill>
+                  <a:srgbClr val="FFFFFF"/>
+                </a:solidFill>
+                <a:latin typeface="Helvetica Neue"/>
+              </a:rPr>
+              <a:t>STEP 19</a:t>
+            </a:r>
+          </a:p>
+        </p:txBody>
+      </p:sp>
+      <p:sp>
+        <p:nvSpPr>
+          <p:cNvPr id="19" name="TextBox 18"/>
+          <p:cNvSpPr txBox="1"/>
+          <p:nvPr/>
+        </p:nvSpPr>
+        <p:spPr>
+          <a:xfrm>
+            <a:off x="9088221" y="6460236"/>
+            <a:ext cx="2362809" cy="219456"/>
+          </a:xfrm>
+          <a:prstGeom prst="rect">
+            <a:avLst/>
+          </a:prstGeom>
+          <a:noFill/>
+        </p:spPr>
+        <p:txBody>
+          <a:bodyPr wrap="none" lIns="0" rIns="0" tIns="0" bIns="0">
+            <a:spAutoFit/>
+          </a:bodyPr>
+          <a:lstStyle/>
+          <a:p>
             <a:pPr algn="l"/>
             <a:r>
-              <a:rPr sz="950" b="1" i="0">
-                <a:solidFill>
-                  <a:srgbClr val="A7F3D0"/>
-                </a:solidFill>
-                <a:latin typeface="Helvetica Neue"/>
-              </a:rPr>
-              <a:t>▶ NOTEBOOK</a:t>
-            </a:r>
-          </a:p>
-        </p:txBody>
-      </p:sp>
-      <p:sp>
-        <p:nvSpPr>
-          <p:cNvPr id="19" name="TextBox 18"/>
-          <p:cNvSpPr txBox="1"/>
-          <p:nvPr/>
-        </p:nvSpPr>
-        <p:spPr>
-          <a:xfrm>
-            <a:off x="8148218" y="6451092"/>
-            <a:ext cx="754380" cy="219456"/>
-          </a:xfrm>
-          <a:prstGeom prst="rect">
-            <a:avLst/>
-          </a:prstGeom>
-          <a:noFill/>
-        </p:spPr>
-        <p:txBody>
-          <a:bodyPr wrap="none" lIns="0" rIns="0" tIns="0" bIns="0">
-            <a:spAutoFit/>
-          </a:bodyPr>
-          <a:lstStyle/>
-          <a:p>
-            <a:pPr algn="ctr"/>
-            <a:r>
-              <a:rPr sz="1100" b="1" i="0">
+              <a:rPr sz="1000" b="1" i="0">
                 <a:solidFill>
                   <a:srgbClr val="FFFFFF"/>
                 </a:solidFill>
                 <a:latin typeface="Helvetica Neue"/>
               </a:rPr>
-              <a:t>STEP 21</a:t>
-            </a:r>
-          </a:p>
-        </p:txBody>
-      </p:sp>
-      <p:sp>
-        <p:nvSpPr>
-          <p:cNvPr id="20" name="TextBox 19"/>
-          <p:cNvSpPr txBox="1"/>
-          <p:nvPr/>
-        </p:nvSpPr>
-        <p:spPr>
-          <a:xfrm>
-            <a:off x="9021470" y="6460236"/>
-            <a:ext cx="2429560" cy="219456"/>
-          </a:xfrm>
-          <a:prstGeom prst="rect">
-            <a:avLst/>
-          </a:prstGeom>
-          <a:noFill/>
-        </p:spPr>
-        <p:txBody>
-          <a:bodyPr wrap="none" lIns="0" rIns="0" tIns="0" bIns="0">
-            <a:spAutoFit/>
-          </a:bodyPr>
-          <a:lstStyle/>
-          <a:p>
-            <a:pPr algn="l"/>
-            <a:r>
-              <a:rPr sz="1000" b="1" i="0">
-                <a:solidFill>
-                  <a:srgbClr val="FFFFFF"/>
-                </a:solidFill>
-                <a:latin typeface="Helvetica Neue"/>
-              </a:rPr>
-              <a:t>YOUR KNOB: set the threshold</a:t>
-            </a:r>
-          </a:p>
-        </p:txBody>
-      </p:sp>
-      <p:sp>
-        <p:nvSpPr>
-          <p:cNvPr id="21" name="TextBox 20"/>
-          <p:cNvSpPr txBox="1"/>
-          <p:nvPr/>
-        </p:nvSpPr>
-        <p:spPr>
-          <a:xfrm>
-            <a:off x="640080" y="6016752"/>
-            <a:ext cx="10881360" cy="365760"/>
-          </a:xfrm>
-          <a:prstGeom prst="rect">
-            <a:avLst/>
-          </a:prstGeom>
-          <a:noFill/>
-        </p:spPr>
-        <p:txBody>
-          <a:bodyPr wrap="square" lIns="0" rIns="0" tIns="0" bIns="0">
-            <a:spAutoFit/>
-          </a:bodyPr>
-          <a:lstStyle/>
-          <a:p>
-            <a:pPr algn="ctr"/>
-            <a:r>
-              <a:rPr sz="1500" b="0" i="1">
-                <a:solidFill>
-                  <a:srgbClr val="475569"/>
-                </a:solidFill>
-                <a:latin typeface="Helvetica Neue"/>
-              </a:rPr>
-              <a:t>Accuracy is a property of the model. The right threshold is a property of the business.</a:t>
+              <a:t>Feed it an off-topic ticket</a:t>
             </a:r>
           </a:p>
         </p:txBody>
@@ -7452,11 +7383,11 @@
             <a:r>
               <a:rPr sz="1250" b="1" i="0" spc="220">
                 <a:solidFill>
-                  <a:srgbClr val="4F46E5"/>
-                </a:solidFill>
-                <a:latin typeface="Helvetica Neue"/>
-              </a:rPr>
-              <a:t>FULL CIRCLE</a:t>
+                  <a:srgbClr val="059669"/>
+                </a:solidFill>
+                <a:latin typeface="Helvetica Neue"/>
+              </a:rPr>
+              <a:t>DECIDE</a:t>
             </a:r>
           </a:p>
         </p:txBody>
@@ -7470,7 +7401,7 @@
         <p:spPr>
           <a:xfrm>
             <a:off x="640080" y="758952"/>
-            <a:ext cx="10972800" cy="704088"/>
+            <a:ext cx="7680960" cy="704088"/>
           </a:xfrm>
           <a:prstGeom prst="rect">
             <a:avLst/>
@@ -7485,13 +7416,13 @@
           <a:p>
             <a:pPr algn="l"/>
             <a:r>
-              <a:rPr sz="2900" b="1" i="0">
+              <a:rPr sz="2650" b="1" i="0">
                 <a:solidFill>
                   <a:srgbClr val="0F172A"/>
                 </a:solidFill>
                 <a:latin typeface="Helvetica Neue"/>
               </a:rPr>
-              <a:t>What we shipped today, for $0.</a:t>
+              <a:t>What a mistake costs decides the setting.</a:t>
             </a:r>
           </a:p>
         </p:txBody>
@@ -7526,14 +7457,377 @@
                 </a:solidFill>
                 <a:latin typeface="Helvetica Neue"/>
               </a:rPr>
-              <a:t>No training data. No training run. No GPU bill. One afternoon.</a:t>
-            </a:r>
-          </a:p>
-        </p:txBody>
-      </p:sp>
-      <p:sp>
-        <p:nvSpPr>
-          <p:cNvPr id="5" name="TextBox 4"/>
+              <a:t>Same copilot, same tickets, six companies. Ask your neighbour: for the hospital, high bar or low?</a:t>
+            </a:r>
+          </a:p>
+        </p:txBody>
+      </p:sp>
+      <p:sp>
+        <p:nvSpPr>
+          <p:cNvPr id="5" name="Rounded Rectangle 4"/>
+          <p:cNvSpPr/>
+          <p:nvPr/>
+        </p:nvSpPr>
+        <p:spPr>
+          <a:xfrm>
+            <a:off x="8705088" y="591616"/>
+            <a:ext cx="1975104" cy="23774"/>
+          </a:xfrm>
+          <a:prstGeom prst="roundRect">
+            <a:avLst/>
+          </a:prstGeom>
+          <a:solidFill>
+            <a:srgbClr val="E9EBF0"/>
+          </a:solidFill>
+          <a:ln>
+            <a:noFill/>
+          </a:ln>
+        </p:spPr>
+        <p:style>
+          <a:lnRef idx="1">
+            <a:schemeClr val="accent1"/>
+          </a:lnRef>
+          <a:fillRef idx="3">
+            <a:schemeClr val="accent1"/>
+          </a:fillRef>
+          <a:effectRef idx="2">
+            <a:schemeClr val="accent1"/>
+          </a:effectRef>
+          <a:fontRef idx="minor">
+            <a:schemeClr val="lt1"/>
+          </a:fontRef>
+        </p:style>
+        <p:txBody>
+          <a:bodyPr rtlCol="0" anchor="ctr"/>
+          <a:lstStyle/>
+          <a:p>
+            <a:pPr algn="ctr"/>
+          </a:p>
+        </p:txBody>
+      </p:sp>
+      <p:sp>
+        <p:nvSpPr>
+          <p:cNvPr id="6" name="Rounded Rectangle 5"/>
+          <p:cNvSpPr/>
+          <p:nvPr/>
+        </p:nvSpPr>
+        <p:spPr>
+          <a:xfrm>
+            <a:off x="8586215" y="475488"/>
+            <a:ext cx="256032" cy="256032"/>
+          </a:xfrm>
+          <a:prstGeom prst="roundRect">
+            <a:avLst>
+              <a:gd name="adj" fmla="val 32000"/>
+            </a:avLst>
+          </a:prstGeom>
+          <a:solidFill>
+            <a:srgbClr val="0EA5E9"/>
+          </a:solidFill>
+          <a:ln>
+            <a:noFill/>
+          </a:ln>
+        </p:spPr>
+        <p:style>
+          <a:lnRef idx="1">
+            <a:schemeClr val="accent1"/>
+          </a:lnRef>
+          <a:fillRef idx="3">
+            <a:schemeClr val="accent1"/>
+          </a:fillRef>
+          <a:effectRef idx="2">
+            <a:schemeClr val="accent1"/>
+          </a:effectRef>
+          <a:fontRef idx="minor">
+            <a:schemeClr val="lt1"/>
+          </a:fontRef>
+        </p:style>
+        <p:txBody>
+          <a:bodyPr rtlCol="0" anchor="ctr"/>
+          <a:lstStyle/>
+          <a:p>
+            <a:pPr algn="ctr"/>
+          </a:p>
+        </p:txBody>
+      </p:sp>
+      <p:sp>
+        <p:nvSpPr>
+          <p:cNvPr id="7" name="TextBox 6"/>
+          <p:cNvSpPr txBox="1"/>
+          <p:nvPr/>
+        </p:nvSpPr>
+        <p:spPr>
+          <a:xfrm>
+            <a:off x="8531351" y="475488"/>
+            <a:ext cx="365760" cy="256032"/>
+          </a:xfrm>
+          <a:prstGeom prst="rect">
+            <a:avLst/>
+          </a:prstGeom>
+          <a:noFill/>
+        </p:spPr>
+        <p:txBody>
+          <a:bodyPr wrap="square" lIns="0" rIns="0" tIns="0" bIns="0">
+            <a:spAutoFit/>
+          </a:bodyPr>
+          <a:lstStyle/>
+          <a:p>
+            <a:pPr algn="ctr"/>
+            <a:r>
+              <a:rPr sz="1050" b="1" i="0">
+                <a:solidFill>
+                  <a:srgbClr val="FFFFFF"/>
+                </a:solidFill>
+                <a:latin typeface="Helvetica Neue"/>
+              </a:rPr>
+              <a:t>1</a:t>
+            </a:r>
+          </a:p>
+        </p:txBody>
+      </p:sp>
+      <p:sp>
+        <p:nvSpPr>
+          <p:cNvPr id="8" name="Rounded Rectangle 7"/>
+          <p:cNvSpPr/>
+          <p:nvPr/>
+        </p:nvSpPr>
+        <p:spPr>
+          <a:xfrm>
+            <a:off x="9244584" y="475488"/>
+            <a:ext cx="256032" cy="256032"/>
+          </a:xfrm>
+          <a:prstGeom prst="roundRect">
+            <a:avLst>
+              <a:gd name="adj" fmla="val 32000"/>
+            </a:avLst>
+          </a:prstGeom>
+          <a:solidFill>
+            <a:srgbClr val="D97706"/>
+          </a:solidFill>
+          <a:ln>
+            <a:noFill/>
+          </a:ln>
+        </p:spPr>
+        <p:style>
+          <a:lnRef idx="1">
+            <a:schemeClr val="accent1"/>
+          </a:lnRef>
+          <a:fillRef idx="3">
+            <a:schemeClr val="accent1"/>
+          </a:fillRef>
+          <a:effectRef idx="2">
+            <a:schemeClr val="accent1"/>
+          </a:effectRef>
+          <a:fontRef idx="minor">
+            <a:schemeClr val="lt1"/>
+          </a:fontRef>
+        </p:style>
+        <p:txBody>
+          <a:bodyPr rtlCol="0" anchor="ctr"/>
+          <a:lstStyle/>
+          <a:p>
+            <a:pPr algn="ctr"/>
+          </a:p>
+        </p:txBody>
+      </p:sp>
+      <p:sp>
+        <p:nvSpPr>
+          <p:cNvPr id="9" name="TextBox 8"/>
+          <p:cNvSpPr txBox="1"/>
+          <p:nvPr/>
+        </p:nvSpPr>
+        <p:spPr>
+          <a:xfrm>
+            <a:off x="9189719" y="475488"/>
+            <a:ext cx="365760" cy="256032"/>
+          </a:xfrm>
+          <a:prstGeom prst="rect">
+            <a:avLst/>
+          </a:prstGeom>
+          <a:noFill/>
+        </p:spPr>
+        <p:txBody>
+          <a:bodyPr wrap="square" lIns="0" rIns="0" tIns="0" bIns="0">
+            <a:spAutoFit/>
+          </a:bodyPr>
+          <a:lstStyle/>
+          <a:p>
+            <a:pPr algn="ctr"/>
+            <a:r>
+              <a:rPr sz="1050" b="1" i="0">
+                <a:solidFill>
+                  <a:srgbClr val="FFFFFF"/>
+                </a:solidFill>
+                <a:latin typeface="Helvetica Neue"/>
+              </a:rPr>
+              <a:t>2</a:t>
+            </a:r>
+          </a:p>
+        </p:txBody>
+      </p:sp>
+      <p:sp>
+        <p:nvSpPr>
+          <p:cNvPr id="10" name="Rounded Rectangle 9"/>
+          <p:cNvSpPr/>
+          <p:nvPr/>
+        </p:nvSpPr>
+        <p:spPr>
+          <a:xfrm>
+            <a:off x="9902951" y="475488"/>
+            <a:ext cx="256032" cy="256032"/>
+          </a:xfrm>
+          <a:prstGeom prst="roundRect">
+            <a:avLst>
+              <a:gd name="adj" fmla="val 32000"/>
+            </a:avLst>
+          </a:prstGeom>
+          <a:solidFill>
+            <a:srgbClr val="7C3AED"/>
+          </a:solidFill>
+          <a:ln>
+            <a:noFill/>
+          </a:ln>
+        </p:spPr>
+        <p:style>
+          <a:lnRef idx="1">
+            <a:schemeClr val="accent1"/>
+          </a:lnRef>
+          <a:fillRef idx="3">
+            <a:schemeClr val="accent1"/>
+          </a:fillRef>
+          <a:effectRef idx="2">
+            <a:schemeClr val="accent1"/>
+          </a:effectRef>
+          <a:fontRef idx="minor">
+            <a:schemeClr val="lt1"/>
+          </a:fontRef>
+        </p:style>
+        <p:txBody>
+          <a:bodyPr rtlCol="0" anchor="ctr"/>
+          <a:lstStyle/>
+          <a:p>
+            <a:pPr algn="ctr"/>
+          </a:p>
+        </p:txBody>
+      </p:sp>
+      <p:sp>
+        <p:nvSpPr>
+          <p:cNvPr id="11" name="TextBox 10"/>
+          <p:cNvSpPr txBox="1"/>
+          <p:nvPr/>
+        </p:nvSpPr>
+        <p:spPr>
+          <a:xfrm>
+            <a:off x="9848087" y="475488"/>
+            <a:ext cx="365760" cy="256032"/>
+          </a:xfrm>
+          <a:prstGeom prst="rect">
+            <a:avLst/>
+          </a:prstGeom>
+          <a:noFill/>
+        </p:spPr>
+        <p:txBody>
+          <a:bodyPr wrap="square" lIns="0" rIns="0" tIns="0" bIns="0">
+            <a:spAutoFit/>
+          </a:bodyPr>
+          <a:lstStyle/>
+          <a:p>
+            <a:pPr algn="ctr"/>
+            <a:r>
+              <a:rPr sz="1050" b="1" i="0">
+                <a:solidFill>
+                  <a:srgbClr val="FFFFFF"/>
+                </a:solidFill>
+                <a:latin typeface="Helvetica Neue"/>
+              </a:rPr>
+              <a:t>3</a:t>
+            </a:r>
+          </a:p>
+        </p:txBody>
+      </p:sp>
+      <p:sp>
+        <p:nvSpPr>
+          <p:cNvPr id="12" name="Rounded Rectangle 11"/>
+          <p:cNvSpPr/>
+          <p:nvPr/>
+        </p:nvSpPr>
+        <p:spPr>
+          <a:xfrm>
+            <a:off x="10524744" y="438912"/>
+            <a:ext cx="329184" cy="329184"/>
+          </a:xfrm>
+          <a:prstGeom prst="roundRect">
+            <a:avLst>
+              <a:gd name="adj" fmla="val 32000"/>
+            </a:avLst>
+          </a:prstGeom>
+          <a:solidFill>
+            <a:srgbClr val="059669"/>
+          </a:solidFill>
+          <a:ln>
+            <a:noFill/>
+          </a:ln>
+        </p:spPr>
+        <p:style>
+          <a:lnRef idx="1">
+            <a:schemeClr val="accent1"/>
+          </a:lnRef>
+          <a:fillRef idx="3">
+            <a:schemeClr val="accent1"/>
+          </a:fillRef>
+          <a:effectRef idx="2">
+            <a:schemeClr val="accent1"/>
+          </a:effectRef>
+          <a:fontRef idx="minor">
+            <a:schemeClr val="lt1"/>
+          </a:fontRef>
+        </p:style>
+        <p:txBody>
+          <a:bodyPr rtlCol="0" anchor="ctr"/>
+          <a:lstStyle/>
+          <a:p>
+            <a:pPr algn="ctr"/>
+          </a:p>
+        </p:txBody>
+      </p:sp>
+      <p:sp>
+        <p:nvSpPr>
+          <p:cNvPr id="13" name="TextBox 12"/>
+          <p:cNvSpPr txBox="1"/>
+          <p:nvPr/>
+        </p:nvSpPr>
+        <p:spPr>
+          <a:xfrm>
+            <a:off x="10469880" y="475488"/>
+            <a:ext cx="438912" cy="256032"/>
+          </a:xfrm>
+          <a:prstGeom prst="rect">
+            <a:avLst/>
+          </a:prstGeom>
+          <a:noFill/>
+        </p:spPr>
+        <p:txBody>
+          <a:bodyPr wrap="square" lIns="0" rIns="0" tIns="0" bIns="0">
+            <a:spAutoFit/>
+          </a:bodyPr>
+          <a:lstStyle/>
+          <a:p>
+            <a:pPr algn="ctr"/>
+            <a:r>
+              <a:rPr sz="1300" b="1" i="0">
+                <a:solidFill>
+                  <a:srgbClr val="FFFFFF"/>
+                </a:solidFill>
+                <a:latin typeface="Helvetica Neue"/>
+              </a:rPr>
+              <a:t>4</a:t>
+            </a:r>
+          </a:p>
+        </p:txBody>
+      </p:sp>
+      <p:sp>
+        <p:nvSpPr>
+          <p:cNvPr id="14" name="TextBox 13"/>
           <p:cNvSpPr txBox="1"/>
           <p:nvPr/>
         </p:nvSpPr>
@@ -7568,7 +7862,7 @@
       </p:sp>
       <p:pic>
         <p:nvPicPr>
-          <p:cNvPr id="6" name="Picture 5" descr="d_shipped.png"/>
+          <p:cNvPr id="15" name="Picture 14" descr="fig_game.png"/>
           <p:cNvPicPr>
             <a:picLocks noChangeAspect="1"/>
           </p:cNvPicPr>
@@ -7582,8 +7876,8 @@
         </p:blipFill>
         <p:spPr>
           <a:xfrm>
-            <a:off x="518007" y="2943310"/>
-            <a:ext cx="11155680" cy="1885778"/>
+            <a:off x="2207847" y="2011680"/>
+            <a:ext cx="7775999" cy="3931920"/>
           </a:xfrm>
           <a:prstGeom prst="rect">
             <a:avLst/>
@@ -7592,14 +7886,209 @@
       </p:pic>
       <p:sp>
         <p:nvSpPr>
-          <p:cNvPr id="7" name="TextBox 6"/>
-          <p:cNvSpPr txBox="1"/>
-          <p:nvPr/>
-        </p:nvSpPr>
-        <p:spPr>
-          <a:xfrm>
-            <a:off x="640080" y="5760720"/>
-            <a:ext cx="10881360" cy="457200"/>
+          <p:cNvPr id="16" name="Rounded Rectangle 15"/>
+          <p:cNvSpPr/>
+          <p:nvPr/>
+        </p:nvSpPr>
+        <p:spPr>
+          <a:xfrm>
+            <a:off x="7105802" y="6345936"/>
+            <a:ext cx="4445812" cy="365760"/>
+          </a:xfrm>
+          <a:prstGeom prst="roundRect">
+            <a:avLst>
+              <a:gd name="adj" fmla="val 44000"/>
+            </a:avLst>
+          </a:prstGeom>
+          <a:solidFill>
+            <a:srgbClr val="059669"/>
+          </a:solidFill>
+          <a:ln>
+            <a:noFill/>
+          </a:ln>
+        </p:spPr>
+        <p:style>
+          <a:lnRef idx="1">
+            <a:schemeClr val="accent1"/>
+          </a:lnRef>
+          <a:fillRef idx="3">
+            <a:schemeClr val="accent1"/>
+          </a:fillRef>
+          <a:effectRef idx="2">
+            <a:schemeClr val="accent1"/>
+          </a:effectRef>
+          <a:fontRef idx="minor">
+            <a:schemeClr val="lt1"/>
+          </a:fontRef>
+        </p:style>
+        <p:txBody>
+          <a:bodyPr rtlCol="0" anchor="ctr"/>
+          <a:lstStyle/>
+          <a:p>
+            <a:pPr algn="ctr"/>
+          </a:p>
+        </p:txBody>
+      </p:sp>
+      <p:sp>
+        <p:nvSpPr>
+          <p:cNvPr id="17" name="Rounded Rectangle 16"/>
+          <p:cNvSpPr/>
+          <p:nvPr/>
+        </p:nvSpPr>
+        <p:spPr>
+          <a:xfrm>
+            <a:off x="8148218" y="6396228"/>
+            <a:ext cx="754380" cy="265176"/>
+          </a:xfrm>
+          <a:prstGeom prst="roundRect">
+            <a:avLst>
+              <a:gd name="adj" fmla="val 44000"/>
+            </a:avLst>
+          </a:prstGeom>
+          <a:solidFill>
+            <a:srgbClr val="064E3B"/>
+          </a:solidFill>
+          <a:ln>
+            <a:noFill/>
+          </a:ln>
+        </p:spPr>
+        <p:style>
+          <a:lnRef idx="1">
+            <a:schemeClr val="accent1"/>
+          </a:lnRef>
+          <a:fillRef idx="3">
+            <a:schemeClr val="accent1"/>
+          </a:fillRef>
+          <a:effectRef idx="2">
+            <a:schemeClr val="accent1"/>
+          </a:effectRef>
+          <a:fontRef idx="minor">
+            <a:schemeClr val="lt1"/>
+          </a:fontRef>
+        </p:style>
+        <p:txBody>
+          <a:bodyPr rtlCol="0" anchor="ctr"/>
+          <a:lstStyle/>
+          <a:p>
+            <a:pPr algn="ctr"/>
+          </a:p>
+        </p:txBody>
+      </p:sp>
+      <p:sp>
+        <p:nvSpPr>
+          <p:cNvPr id="18" name="TextBox 17"/>
+          <p:cNvSpPr txBox="1"/>
+          <p:nvPr/>
+        </p:nvSpPr>
+        <p:spPr>
+          <a:xfrm>
+            <a:off x="7261250" y="6460236"/>
+            <a:ext cx="914400" cy="219456"/>
+          </a:xfrm>
+          <a:prstGeom prst="rect">
+            <a:avLst/>
+          </a:prstGeom>
+          <a:noFill/>
+        </p:spPr>
+        <p:txBody>
+          <a:bodyPr wrap="none" lIns="0" rIns="0" tIns="0" bIns="0">
+            <a:spAutoFit/>
+          </a:bodyPr>
+          <a:lstStyle/>
+          <a:p>
+            <a:pPr algn="l"/>
+            <a:r>
+              <a:rPr sz="950" b="1" i="0">
+                <a:solidFill>
+                  <a:srgbClr val="A7F3D0"/>
+                </a:solidFill>
+                <a:latin typeface="Helvetica Neue"/>
+              </a:rPr>
+              <a:t>▶ NOTEBOOK</a:t>
+            </a:r>
+          </a:p>
+        </p:txBody>
+      </p:sp>
+      <p:sp>
+        <p:nvSpPr>
+          <p:cNvPr id="19" name="TextBox 18"/>
+          <p:cNvSpPr txBox="1"/>
+          <p:nvPr/>
+        </p:nvSpPr>
+        <p:spPr>
+          <a:xfrm>
+            <a:off x="8148218" y="6451092"/>
+            <a:ext cx="754380" cy="219456"/>
+          </a:xfrm>
+          <a:prstGeom prst="rect">
+            <a:avLst/>
+          </a:prstGeom>
+          <a:noFill/>
+        </p:spPr>
+        <p:txBody>
+          <a:bodyPr wrap="none" lIns="0" rIns="0" tIns="0" bIns="0">
+            <a:spAutoFit/>
+          </a:bodyPr>
+          <a:lstStyle/>
+          <a:p>
+            <a:pPr algn="ctr"/>
+            <a:r>
+              <a:rPr sz="1100" b="1" i="0">
+                <a:solidFill>
+                  <a:srgbClr val="FFFFFF"/>
+                </a:solidFill>
+                <a:latin typeface="Helvetica Neue"/>
+              </a:rPr>
+              <a:t>STEP 21</a:t>
+            </a:r>
+          </a:p>
+        </p:txBody>
+      </p:sp>
+      <p:sp>
+        <p:nvSpPr>
+          <p:cNvPr id="20" name="TextBox 19"/>
+          <p:cNvSpPr txBox="1"/>
+          <p:nvPr/>
+        </p:nvSpPr>
+        <p:spPr>
+          <a:xfrm>
+            <a:off x="9021470" y="6460236"/>
+            <a:ext cx="2429560" cy="219456"/>
+          </a:xfrm>
+          <a:prstGeom prst="rect">
+            <a:avLst/>
+          </a:prstGeom>
+          <a:noFill/>
+        </p:spPr>
+        <p:txBody>
+          <a:bodyPr wrap="none" lIns="0" rIns="0" tIns="0" bIns="0">
+            <a:spAutoFit/>
+          </a:bodyPr>
+          <a:lstStyle/>
+          <a:p>
+            <a:pPr algn="l"/>
+            <a:r>
+              <a:rPr sz="1000" b="1" i="0">
+                <a:solidFill>
+                  <a:srgbClr val="FFFFFF"/>
+                </a:solidFill>
+                <a:latin typeface="Helvetica Neue"/>
+              </a:rPr>
+              <a:t>YOUR KNOB: set the threshold</a:t>
+            </a:r>
+          </a:p>
+        </p:txBody>
+      </p:sp>
+      <p:sp>
+        <p:nvSpPr>
+          <p:cNvPr id="21" name="TextBox 20"/>
+          <p:cNvSpPr txBox="1"/>
+          <p:nvPr/>
+        </p:nvSpPr>
+        <p:spPr>
+          <a:xfrm>
+            <a:off x="640080" y="6016752"/>
+            <a:ext cx="10881360" cy="365760"/>
           </a:xfrm>
           <a:prstGeom prst="rect">
             <a:avLst/>
@@ -7614,13 +8103,13 @@
           <a:p>
             <a:pPr algn="ctr"/>
             <a:r>
-              <a:rPr sz="1600" b="0" i="1">
-                <a:solidFill>
-                  <a:srgbClr val="0F172A"/>
-                </a:solidFill>
-                <a:latin typeface="Helvetica Neue"/>
-              </a:rPr>
-              <a:t>Someone else already spent millions teaching a model to read English. Your job is to point it at your problem, cheaply, and know where it breaks.</a:t>
+              <a:rPr sz="1500" b="0" i="1">
+                <a:solidFill>
+                  <a:srgbClr val="475569"/>
+                </a:solidFill>
+                <a:latin typeface="Helvetica Neue"/>
+              </a:rPr>
+              <a:t>Accuracy is a property of the model. The right threshold is a property of the business.</a:t>
             </a:r>
           </a:p>
         </p:txBody>
@@ -7673,7 +8162,7 @@
                 </a:solidFill>
                 <a:latin typeface="Helvetica Neue"/>
               </a:rPr>
-              <a:t>BEFORE WE OPEN IT UP</a:t>
+              <a:t>FULL CIRCLE</a:t>
             </a:r>
           </a:p>
         </p:txBody>
@@ -7708,7 +8197,7 @@
                 </a:solidFill>
                 <a:latin typeface="Helvetica Neue"/>
               </a:rPr>
-              <a:t>What you actually saw tonight.</a:t>
+              <a:t>What we shipped today, for $0.</a:t>
             </a:r>
           </a:p>
         </p:txBody>
@@ -7743,7 +8232,7 @@
                 </a:solidFill>
                 <a:latin typeface="Helvetica Neue"/>
               </a:rPr>
-              <a:t>Hold both columns in your head. We are about to need them.</a:t>
+              <a:t>No training data. No training run. No GPU bill. One afternoon.</a:t>
             </a:r>
           </a:p>
         </p:txBody>
@@ -7785,7 +8274,7 @@
       </p:sp>
       <p:pic>
         <p:nvPicPr>
-          <p:cNvPr id="6" name="Picture 5" descr="d_saw.png"/>
+          <p:cNvPr id="6" name="Picture 5" descr="d_shipped.png"/>
           <p:cNvPicPr>
             <a:picLocks noChangeAspect="1"/>
           </p:cNvPicPr>
@@ -7799,14 +8288,49 @@
         </p:blipFill>
         <p:spPr>
           <a:xfrm>
-            <a:off x="518007" y="3252244"/>
-            <a:ext cx="11155680" cy="1862271"/>
+            <a:off x="518007" y="2943310"/>
+            <a:ext cx="11155680" cy="1885778"/>
           </a:xfrm>
           <a:prstGeom prst="rect">
             <a:avLst/>
           </a:prstGeom>
         </p:spPr>
       </p:pic>
+      <p:sp>
+        <p:nvSpPr>
+          <p:cNvPr id="7" name="TextBox 6"/>
+          <p:cNvSpPr txBox="1"/>
+          <p:nvPr/>
+        </p:nvSpPr>
+        <p:spPr>
+          <a:xfrm>
+            <a:off x="640080" y="5760720"/>
+            <a:ext cx="10881360" cy="457200"/>
+          </a:xfrm>
+          <a:prstGeom prst="rect">
+            <a:avLst/>
+          </a:prstGeom>
+          <a:noFill/>
+        </p:spPr>
+        <p:txBody>
+          <a:bodyPr wrap="square" lIns="0" rIns="0" tIns="0" bIns="0">
+            <a:spAutoFit/>
+          </a:bodyPr>
+          <a:lstStyle/>
+          <a:p>
+            <a:pPr algn="ctr"/>
+            <a:r>
+              <a:rPr sz="1600" b="0" i="1">
+                <a:solidFill>
+                  <a:srgbClr val="0F172A"/>
+                </a:solidFill>
+                <a:latin typeface="Helvetica Neue"/>
+              </a:rPr>
+              <a:t>Someone else already spent millions teaching a model to read English. Your job is to point it at your problem, cheaply, and know where it breaks.</a:t>
+            </a:r>
+          </a:p>
+        </p:txBody>
+      </p:sp>
     </p:spTree>
   </p:cSld>
   <p:clrMapOvr>
@@ -7851,11 +8375,11 @@
             <a:r>
               <a:rPr sz="1250" b="1" i="0" spc="220">
                 <a:solidFill>
-                  <a:srgbClr val="E11D48"/>
-                </a:solidFill>
-                <a:latin typeface="Helvetica Neue"/>
-              </a:rPr>
-              <a:t>DISCUSSION</a:t>
+                  <a:srgbClr val="4F46E5"/>
+                </a:solidFill>
+                <a:latin typeface="Helvetica Neue"/>
+              </a:rPr>
+              <a:t>BEFORE WE OPEN IT UP</a:t>
             </a:r>
           </a:p>
         </p:txBody>
@@ -7890,7 +8414,7 @@
                 </a:solidFill>
                 <a:latin typeface="Helvetica Neue"/>
               </a:rPr>
-              <a:t>Last week, a model did this on its own.</a:t>
+              <a:t>What you actually saw tonight.</a:t>
             </a:r>
           </a:p>
         </p:txBody>
@@ -7925,7 +8449,7 @@
                 </a:solidFill>
                 <a:latin typeface="Helvetica Neue"/>
               </a:rPr>
-              <a:t>Not a thought experiment. This happened between the 16th and the 21st of July, six days ago.</a:t>
+              <a:t>Hold both columns in your head. We are about to need them.</a:t>
             </a:r>
           </a:p>
         </p:txBody>
@@ -7967,7 +8491,7 @@
       </p:sp>
       <p:pic>
         <p:nvPicPr>
-          <p:cNvPr id="6" name="Picture 5" descr="d_incident.png"/>
+          <p:cNvPr id="6" name="Picture 5" descr="d_saw.png"/>
           <p:cNvPicPr>
             <a:picLocks noChangeAspect="1"/>
           </p:cNvPicPr>
@@ -7981,49 +8505,14 @@
         </p:blipFill>
         <p:spPr>
           <a:xfrm>
-            <a:off x="518007" y="2056061"/>
-            <a:ext cx="11155680" cy="3934597"/>
+            <a:off x="518007" y="3252244"/>
+            <a:ext cx="11155680" cy="1862271"/>
           </a:xfrm>
           <a:prstGeom prst="rect">
             <a:avLst/>
           </a:prstGeom>
         </p:spPr>
       </p:pic>
-      <p:sp>
-        <p:nvSpPr>
-          <p:cNvPr id="7" name="TextBox 6"/>
-          <p:cNvSpPr txBox="1"/>
-          <p:nvPr/>
-        </p:nvSpPr>
-        <p:spPr>
-          <a:xfrm>
-            <a:off x="640080" y="6108192"/>
-            <a:ext cx="10881360" cy="365760"/>
-          </a:xfrm>
-          <a:prstGeom prst="rect">
-            <a:avLst/>
-          </a:prstGeom>
-          <a:noFill/>
-        </p:spPr>
-        <p:txBody>
-          <a:bodyPr wrap="square" lIns="0" rIns="0" tIns="0" bIns="0">
-            <a:spAutoFit/>
-          </a:bodyPr>
-          <a:lstStyle/>
-          <a:p>
-            <a:pPr algn="ctr"/>
-            <a:r>
-              <a:rPr sz="1100" b="0" i="0">
-                <a:solidFill>
-                  <a:srgbClr val="BCC1CC"/>
-                </a:solidFill>
-                <a:latin typeface="Helvetica Neue"/>
-              </a:rPr>
-              <a:t>Sources: OpenAI incident report - Hugging Face disclosure - CNBC, Axios, The Hacker News, 21-22 July 2026</a:t>
-            </a:r>
-          </a:p>
-        </p:txBody>
-      </p:sp>
     </p:spTree>
   </p:cSld>
   <p:clrMapOvr>
@@ -8033,6 +8522,223 @@
 </file>
 
 <file path=ppt/slides/slide18.xml><?xml version="1.0" encoding="utf-8"?>
+<p:sld xmlns:a="http://schemas.openxmlformats.org/drawingml/2006/main" xmlns:p="http://schemas.openxmlformats.org/presentationml/2006/main" xmlns:r="http://schemas.openxmlformats.org/officeDocument/2006/relationships">
+  <p:cSld>
+    <p:spTree>
+      <p:nvGrpSpPr>
+        <p:cNvPr id="1" name=""/>
+        <p:cNvGrpSpPr/>
+        <p:nvPr/>
+      </p:nvGrpSpPr>
+      <p:grpSpPr/>
+      <p:sp>
+        <p:nvSpPr>
+          <p:cNvPr id="2" name="TextBox 1"/>
+          <p:cNvSpPr txBox="1"/>
+          <p:nvPr/>
+        </p:nvSpPr>
+        <p:spPr>
+          <a:xfrm>
+            <a:off x="640080" y="457200"/>
+            <a:ext cx="6766560" cy="274320"/>
+          </a:xfrm>
+          <a:prstGeom prst="rect">
+            <a:avLst/>
+          </a:prstGeom>
+          <a:noFill/>
+        </p:spPr>
+        <p:txBody>
+          <a:bodyPr wrap="square" lIns="0" rIns="0" tIns="0" bIns="0">
+            <a:spAutoFit/>
+          </a:bodyPr>
+          <a:lstStyle/>
+          <a:p>
+            <a:pPr algn="l"/>
+            <a:r>
+              <a:rPr sz="1250" b="1" i="0" spc="220">
+                <a:solidFill>
+                  <a:srgbClr val="E11D48"/>
+                </a:solidFill>
+                <a:latin typeface="Helvetica Neue"/>
+              </a:rPr>
+              <a:t>DISCUSSION</a:t>
+            </a:r>
+          </a:p>
+        </p:txBody>
+      </p:sp>
+      <p:sp>
+        <p:nvSpPr>
+          <p:cNvPr id="3" name="TextBox 2"/>
+          <p:cNvSpPr txBox="1"/>
+          <p:nvPr/>
+        </p:nvSpPr>
+        <p:spPr>
+          <a:xfrm>
+            <a:off x="640080" y="758952"/>
+            <a:ext cx="10972800" cy="704088"/>
+          </a:xfrm>
+          <a:prstGeom prst="rect">
+            <a:avLst/>
+          </a:prstGeom>
+          <a:noFill/>
+        </p:spPr>
+        <p:txBody>
+          <a:bodyPr wrap="square" lIns="0" rIns="0" tIns="0" bIns="0">
+            <a:spAutoFit/>
+          </a:bodyPr>
+          <a:lstStyle/>
+          <a:p>
+            <a:pPr algn="l"/>
+            <a:r>
+              <a:rPr sz="2900" b="1" i="0">
+                <a:solidFill>
+                  <a:srgbClr val="0F172A"/>
+                </a:solidFill>
+                <a:latin typeface="Helvetica Neue"/>
+              </a:rPr>
+              <a:t>Last week, a model did this on its own.</a:t>
+            </a:r>
+          </a:p>
+        </p:txBody>
+      </p:sp>
+      <p:sp>
+        <p:nvSpPr>
+          <p:cNvPr id="4" name="TextBox 3"/>
+          <p:cNvSpPr txBox="1"/>
+          <p:nvPr/>
+        </p:nvSpPr>
+        <p:spPr>
+          <a:xfrm>
+            <a:off x="640080" y="1417320"/>
+            <a:ext cx="10424160" cy="457200"/>
+          </a:xfrm>
+          <a:prstGeom prst="rect">
+            <a:avLst/>
+          </a:prstGeom>
+          <a:noFill/>
+        </p:spPr>
+        <p:txBody>
+          <a:bodyPr wrap="square" lIns="0" rIns="0" tIns="0" bIns="0">
+            <a:spAutoFit/>
+          </a:bodyPr>
+          <a:lstStyle/>
+          <a:p>
+            <a:pPr algn="l"/>
+            <a:r>
+              <a:rPr sz="1500" b="0" i="0">
+                <a:solidFill>
+                  <a:srgbClr val="475569"/>
+                </a:solidFill>
+                <a:latin typeface="Helvetica Neue"/>
+              </a:rPr>
+              <a:t>Not a thought experiment. This happened between the 16th and the 21st of July, six days ago.</a:t>
+            </a:r>
+          </a:p>
+        </p:txBody>
+      </p:sp>
+      <p:sp>
+        <p:nvSpPr>
+          <p:cNvPr id="5" name="TextBox 4"/>
+          <p:cNvSpPr txBox="1"/>
+          <p:nvPr/>
+        </p:nvSpPr>
+        <p:spPr>
+          <a:xfrm>
+            <a:off x="640080" y="6492240"/>
+            <a:ext cx="8229600" cy="274320"/>
+          </a:xfrm>
+          <a:prstGeom prst="rect">
+            <a:avLst/>
+          </a:prstGeom>
+          <a:noFill/>
+        </p:spPr>
+        <p:txBody>
+          <a:bodyPr wrap="square" lIns="0" rIns="0" tIns="0" bIns="0">
+            <a:spAutoFit/>
+          </a:bodyPr>
+          <a:lstStyle/>
+          <a:p>
+            <a:pPr algn="l"/>
+            <a:r>
+              <a:rPr sz="900" b="0" i="0">
+                <a:solidFill>
+                  <a:srgbClr val="BCC1CC"/>
+                </a:solidFill>
+                <a:latin typeface="Helvetica Neue"/>
+              </a:rPr>
+              <a:t>ISBA 2411 · Natural Language Processing &amp; AI · Summer 2026</a:t>
+            </a:r>
+          </a:p>
+        </p:txBody>
+      </p:sp>
+      <p:pic>
+        <p:nvPicPr>
+          <p:cNvPr id="6" name="Picture 5" descr="d_incident.png"/>
+          <p:cNvPicPr>
+            <a:picLocks noChangeAspect="1"/>
+          </p:cNvPicPr>
+          <p:nvPr/>
+        </p:nvPicPr>
+        <p:blipFill>
+          <a:blip r:embed="rId2"/>
+          <a:stretch>
+            <a:fillRect/>
+          </a:stretch>
+        </p:blipFill>
+        <p:spPr>
+          <a:xfrm>
+            <a:off x="518007" y="2056061"/>
+            <a:ext cx="11155680" cy="3934597"/>
+          </a:xfrm>
+          <a:prstGeom prst="rect">
+            <a:avLst/>
+          </a:prstGeom>
+        </p:spPr>
+      </p:pic>
+      <p:sp>
+        <p:nvSpPr>
+          <p:cNvPr id="7" name="TextBox 6"/>
+          <p:cNvSpPr txBox="1"/>
+          <p:nvPr/>
+        </p:nvSpPr>
+        <p:spPr>
+          <a:xfrm>
+            <a:off x="640080" y="6108192"/>
+            <a:ext cx="10881360" cy="365760"/>
+          </a:xfrm>
+          <a:prstGeom prst="rect">
+            <a:avLst/>
+          </a:prstGeom>
+          <a:noFill/>
+        </p:spPr>
+        <p:txBody>
+          <a:bodyPr wrap="square" lIns="0" rIns="0" tIns="0" bIns="0">
+            <a:spAutoFit/>
+          </a:bodyPr>
+          <a:lstStyle/>
+          <a:p>
+            <a:pPr algn="ctr"/>
+            <a:r>
+              <a:rPr sz="1100" b="0" i="0">
+                <a:solidFill>
+                  <a:srgbClr val="BCC1CC"/>
+                </a:solidFill>
+                <a:latin typeface="Helvetica Neue"/>
+              </a:rPr>
+              <a:t>Sources: OpenAI incident report - Hugging Face disclosure - CNBC, Axios, The Hacker News, 21-22 July 2026</a:t>
+            </a:r>
+          </a:p>
+        </p:txBody>
+      </p:sp>
+    </p:spTree>
+  </p:cSld>
+  <p:clrMapOvr>
+    <a:masterClrMapping/>
+  </p:clrMapOvr>
+</p:sld>
+</file>
+
+<file path=ppt/slides/slide19.xml><?xml version="1.0" encoding="utf-8"?>
 <p:sld xmlns:a="http://schemas.openxmlformats.org/drawingml/2006/main" xmlns:p="http://schemas.openxmlformats.org/presentationml/2006/main" xmlns:r="http://schemas.openxmlformats.org/officeDocument/2006/relationships">
   <p:cSld>
     <p:spTree>
@@ -12207,11 +12913,11 @@
             <a:r>
               <a:rPr sz="1250" b="1" i="0" spc="220">
                 <a:solidFill>
-                  <a:srgbClr val="7C3AED"/>
-                </a:solidFill>
-                <a:latin typeface="Helvetica Neue"/>
-              </a:rPr>
-              <a:t>ROUTE</a:t>
+                  <a:srgbClr val="0EA5E9"/>
+                </a:solidFill>
+                <a:latin typeface="Helvetica Neue"/>
+              </a:rPr>
+              <a:t>RETRIEVE</a:t>
             </a:r>
           </a:p>
         </p:txBody>
@@ -12225,7 +12931,7 @@
         <p:spPr>
           <a:xfrm>
             <a:off x="640080" y="758952"/>
-            <a:ext cx="7680960" cy="1179576"/>
+            <a:ext cx="7680960" cy="704088"/>
           </a:xfrm>
           <a:prstGeom prst="rect">
             <a:avLst/>
@@ -12246,7 +12952,7 @@
                 </a:solidFill>
                 <a:latin typeface="Helvetica Neue"/>
               </a:rPr>
-              <a:t>Sort the inbox with no training data at all.</a:t>
+              <a:t>How the meaning gets in there.</a:t>
             </a:r>
           </a:p>
         </p:txBody>
@@ -12302,8 +13008,8 @@
         </p:nvSpPr>
         <p:spPr>
           <a:xfrm>
-            <a:off x="8586215" y="475488"/>
-            <a:ext cx="256032" cy="256032"/>
+            <a:off x="8549640" y="438912"/>
+            <a:ext cx="329184" cy="329184"/>
           </a:xfrm>
           <a:prstGeom prst="roundRect">
             <a:avLst>
@@ -12347,8 +13053,8 @@
         </p:nvSpPr>
         <p:spPr>
           <a:xfrm>
-            <a:off x="8531351" y="475488"/>
-            <a:ext cx="365760" cy="256032"/>
+            <a:off x="8494776" y="475488"/>
+            <a:ext cx="438912" cy="256032"/>
           </a:xfrm>
           <a:prstGeom prst="rect">
             <a:avLst/>
@@ -12363,7 +13069,7 @@
           <a:p>
             <a:pPr algn="ctr"/>
             <a:r>
-              <a:rPr sz="1050" b="1" i="0">
+              <a:rPr sz="1300" b="1" i="0">
                 <a:solidFill>
                   <a:srgbClr val="FFFFFF"/>
                 </a:solidFill>
@@ -12382,87 +13088,7 @@
         </p:nvSpPr>
         <p:spPr>
           <a:xfrm>
-            <a:off x="9208008" y="438912"/>
-            <a:ext cx="329184" cy="329184"/>
-          </a:xfrm>
-          <a:prstGeom prst="roundRect">
-            <a:avLst>
-              <a:gd name="adj" fmla="val 32000"/>
-            </a:avLst>
-          </a:prstGeom>
-          <a:solidFill>
-            <a:srgbClr val="D97706"/>
-          </a:solidFill>
-          <a:ln>
-            <a:noFill/>
-          </a:ln>
-        </p:spPr>
-        <p:style>
-          <a:lnRef idx="1">
-            <a:schemeClr val="accent1"/>
-          </a:lnRef>
-          <a:fillRef idx="3">
-            <a:schemeClr val="accent1"/>
-          </a:fillRef>
-          <a:effectRef idx="2">
-            <a:schemeClr val="accent1"/>
-          </a:effectRef>
-          <a:fontRef idx="minor">
-            <a:schemeClr val="lt1"/>
-          </a:fontRef>
-        </p:style>
-        <p:txBody>
-          <a:bodyPr rtlCol="0" anchor="ctr"/>
-          <a:lstStyle/>
-          <a:p>
-            <a:pPr algn="ctr"/>
-          </a:p>
-        </p:txBody>
-      </p:sp>
-      <p:sp>
-        <p:nvSpPr>
-          <p:cNvPr id="8" name="TextBox 7"/>
-          <p:cNvSpPr txBox="1"/>
-          <p:nvPr/>
-        </p:nvSpPr>
-        <p:spPr>
-          <a:xfrm>
-            <a:off x="9153144" y="475488"/>
-            <a:ext cx="438912" cy="256032"/>
-          </a:xfrm>
-          <a:prstGeom prst="rect">
-            <a:avLst/>
-          </a:prstGeom>
-          <a:noFill/>
-        </p:spPr>
-        <p:txBody>
-          <a:bodyPr wrap="square" lIns="0" rIns="0" tIns="0" bIns="0">
-            <a:spAutoFit/>
-          </a:bodyPr>
-          <a:lstStyle/>
-          <a:p>
-            <a:pPr algn="ctr"/>
-            <a:r>
-              <a:rPr sz="1300" b="1" i="0">
-                <a:solidFill>
-                  <a:srgbClr val="FFFFFF"/>
-                </a:solidFill>
-                <a:latin typeface="Helvetica Neue"/>
-              </a:rPr>
-              <a:t>2</a:t>
-            </a:r>
-          </a:p>
-        </p:txBody>
-      </p:sp>
-      <p:sp>
-        <p:nvSpPr>
-          <p:cNvPr id="9" name="Rounded Rectangle 8"/>
-          <p:cNvSpPr/>
-          <p:nvPr/>
-        </p:nvSpPr>
-        <p:spPr>
-          <a:xfrm>
-            <a:off x="9902951" y="475488"/>
+            <a:off x="9244584" y="475488"/>
             <a:ext cx="256032" cy="256032"/>
           </a:xfrm>
           <a:prstGeom prst="roundRect">
@@ -12501,13 +13127,13 @@
       </p:sp>
       <p:sp>
         <p:nvSpPr>
-          <p:cNvPr id="10" name="TextBox 9"/>
-          <p:cNvSpPr txBox="1"/>
-          <p:nvPr/>
-        </p:nvSpPr>
-        <p:spPr>
-          <a:xfrm>
-            <a:off x="9848087" y="475488"/>
+          <p:cNvPr id="8" name="TextBox 7"/>
+          <p:cNvSpPr txBox="1"/>
+          <p:nvPr/>
+        </p:nvSpPr>
+        <p:spPr>
+          <a:xfrm>
+            <a:off x="9189719" y="475488"/>
             <a:ext cx="365760" cy="256032"/>
           </a:xfrm>
           <a:prstGeom prst="rect">
@@ -12529,20 +13155,20 @@
                 </a:solidFill>
                 <a:latin typeface="Helvetica Neue"/>
               </a:rPr>
-              <a:t>3</a:t>
-            </a:r>
-          </a:p>
-        </p:txBody>
-      </p:sp>
-      <p:sp>
-        <p:nvSpPr>
-          <p:cNvPr id="11" name="Rounded Rectangle 10"/>
+              <a:t>2</a:t>
+            </a:r>
+          </a:p>
+        </p:txBody>
+      </p:sp>
+      <p:sp>
+        <p:nvSpPr>
+          <p:cNvPr id="9" name="Rounded Rectangle 8"/>
           <p:cNvSpPr/>
           <p:nvPr/>
         </p:nvSpPr>
         <p:spPr>
           <a:xfrm>
-            <a:off x="10561319" y="475488"/>
+            <a:off x="9902951" y="475488"/>
             <a:ext cx="256032" cy="256032"/>
           </a:xfrm>
           <a:prstGeom prst="roundRect">
@@ -12581,6 +13207,86 @@
       </p:sp>
       <p:sp>
         <p:nvSpPr>
+          <p:cNvPr id="10" name="TextBox 9"/>
+          <p:cNvSpPr txBox="1"/>
+          <p:nvPr/>
+        </p:nvSpPr>
+        <p:spPr>
+          <a:xfrm>
+            <a:off x="9848087" y="475488"/>
+            <a:ext cx="365760" cy="256032"/>
+          </a:xfrm>
+          <a:prstGeom prst="rect">
+            <a:avLst/>
+          </a:prstGeom>
+          <a:noFill/>
+        </p:spPr>
+        <p:txBody>
+          <a:bodyPr wrap="square" lIns="0" rIns="0" tIns="0" bIns="0">
+            <a:spAutoFit/>
+          </a:bodyPr>
+          <a:lstStyle/>
+          <a:p>
+            <a:pPr algn="ctr"/>
+            <a:r>
+              <a:rPr sz="1050" b="1" i="0">
+                <a:solidFill>
+                  <a:srgbClr val="AEB4BF"/>
+                </a:solidFill>
+                <a:latin typeface="Helvetica Neue"/>
+              </a:rPr>
+              <a:t>3</a:t>
+            </a:r>
+          </a:p>
+        </p:txBody>
+      </p:sp>
+      <p:sp>
+        <p:nvSpPr>
+          <p:cNvPr id="11" name="Rounded Rectangle 10"/>
+          <p:cNvSpPr/>
+          <p:nvPr/>
+        </p:nvSpPr>
+        <p:spPr>
+          <a:xfrm>
+            <a:off x="10561319" y="475488"/>
+            <a:ext cx="256032" cy="256032"/>
+          </a:xfrm>
+          <a:prstGeom prst="roundRect">
+            <a:avLst>
+              <a:gd name="adj" fmla="val 32000"/>
+            </a:avLst>
+          </a:prstGeom>
+          <a:solidFill>
+            <a:srgbClr val="E9EBF0"/>
+          </a:solidFill>
+          <a:ln>
+            <a:noFill/>
+          </a:ln>
+        </p:spPr>
+        <p:style>
+          <a:lnRef idx="1">
+            <a:schemeClr val="accent1"/>
+          </a:lnRef>
+          <a:fillRef idx="3">
+            <a:schemeClr val="accent1"/>
+          </a:fillRef>
+          <a:effectRef idx="2">
+            <a:schemeClr val="accent1"/>
+          </a:effectRef>
+          <a:fontRef idx="minor">
+            <a:schemeClr val="lt1"/>
+          </a:fontRef>
+        </p:style>
+        <p:txBody>
+          <a:bodyPr rtlCol="0" anchor="ctr"/>
+          <a:lstStyle/>
+          <a:p>
+            <a:pPr algn="ctr"/>
+          </a:p>
+        </p:txBody>
+      </p:sp>
+      <p:sp>
+        <p:nvSpPr>
           <p:cNvPr id="12" name="TextBox 11"/>
           <p:cNvSpPr txBox="1"/>
           <p:nvPr/>
@@ -12651,7 +13357,7 @@
       </p:sp>
       <p:pic>
         <p:nvPicPr>
-          <p:cNvPr id="14" name="Picture 13" descr="d_zs.png"/>
+          <p:cNvPr id="14" name="Picture 13" descr="fig_blockflow.png"/>
           <p:cNvPicPr>
             <a:picLocks noChangeAspect="1"/>
           </p:cNvPicPr>
@@ -12665,8 +13371,8 @@
         </p:blipFill>
         <p:spPr>
           <a:xfrm>
-            <a:off x="1473370" y="1965960"/>
-            <a:ext cx="9244954" cy="4297679"/>
+            <a:off x="621096" y="1632204"/>
+            <a:ext cx="10949502" cy="4315968"/>
           </a:xfrm>
           <a:prstGeom prst="rect">
             <a:avLst/>
@@ -12675,14 +13381,49 @@
       </p:pic>
       <p:sp>
         <p:nvSpPr>
-          <p:cNvPr id="15" name="Rounded Rectangle 14"/>
+          <p:cNvPr id="15" name="TextBox 14"/>
+          <p:cNvSpPr txBox="1"/>
+          <p:nvPr/>
+        </p:nvSpPr>
+        <p:spPr>
+          <a:xfrm>
+            <a:off x="640080" y="6035040"/>
+            <a:ext cx="10881360" cy="320040"/>
+          </a:xfrm>
+          <a:prstGeom prst="rect">
+            <a:avLst/>
+          </a:prstGeom>
+          <a:noFill/>
+        </p:spPr>
+        <p:txBody>
+          <a:bodyPr wrap="square" lIns="0" rIns="0" tIns="0" bIns="0">
+            <a:spAutoFit/>
+          </a:bodyPr>
+          <a:lstStyle/>
+          <a:p>
+            <a:pPr algn="ctr"/>
+            <a:r>
+              <a:rPr sz="1500" b="0" i="1">
+                <a:solidFill>
+                  <a:srgbClr val="475569"/>
+                </a:solidFill>
+                <a:latin typeface="Helvetica Neue"/>
+              </a:rPr>
+              <a:t>You built this in Lecture 11. Tonight you only need the shape of it.</a:t>
+            </a:r>
+          </a:p>
+        </p:txBody>
+      </p:sp>
+      <p:sp>
+        <p:nvSpPr>
+          <p:cNvPr id="16" name="Rounded Rectangle 15"/>
           <p:cNvSpPr/>
           <p:nvPr/>
         </p:nvSpPr>
         <p:spPr>
           <a:xfrm>
-            <a:off x="6505041" y="6345936"/>
-            <a:ext cx="5046573" cy="365760"/>
+            <a:off x="7105802" y="6345936"/>
+            <a:ext cx="4445812" cy="365760"/>
           </a:xfrm>
           <a:prstGeom prst="roundRect">
             <a:avLst>
@@ -12720,14 +13461,14 @@
       </p:sp>
       <p:sp>
         <p:nvSpPr>
-          <p:cNvPr id="16" name="Rounded Rectangle 15"/>
+          <p:cNvPr id="17" name="Rounded Rectangle 16"/>
           <p:cNvSpPr/>
           <p:nvPr/>
         </p:nvSpPr>
         <p:spPr>
           <a:xfrm>
-            <a:off x="7547457" y="6396228"/>
-            <a:ext cx="754380" cy="265176"/>
+            <a:off x="8148218" y="6396228"/>
+            <a:ext cx="685800" cy="265176"/>
           </a:xfrm>
           <a:prstGeom prst="roundRect">
             <a:avLst>
@@ -12765,13 +13506,13 @@
       </p:sp>
       <p:sp>
         <p:nvSpPr>
-          <p:cNvPr id="17" name="TextBox 16"/>
-          <p:cNvSpPr txBox="1"/>
-          <p:nvPr/>
-        </p:nvSpPr>
-        <p:spPr>
-          <a:xfrm>
-            <a:off x="6660489" y="6460236"/>
+          <p:cNvPr id="18" name="TextBox 17"/>
+          <p:cNvSpPr txBox="1"/>
+          <p:nvPr/>
+        </p:nvSpPr>
+        <p:spPr>
+          <a:xfrm>
+            <a:off x="7261250" y="6460236"/>
             <a:ext cx="914400" cy="219456"/>
           </a:xfrm>
           <a:prstGeom prst="rect">
@@ -12800,14 +13541,14 @@
       </p:sp>
       <p:sp>
         <p:nvSpPr>
-          <p:cNvPr id="18" name="TextBox 17"/>
-          <p:cNvSpPr txBox="1"/>
-          <p:nvPr/>
-        </p:nvSpPr>
-        <p:spPr>
-          <a:xfrm>
-            <a:off x="7547457" y="6451092"/>
-            <a:ext cx="754380" cy="219456"/>
+          <p:cNvPr id="19" name="TextBox 18"/>
+          <p:cNvSpPr txBox="1"/>
+          <p:nvPr/>
+        </p:nvSpPr>
+        <p:spPr>
+          <a:xfrm>
+            <a:off x="8148218" y="6451092"/>
+            <a:ext cx="685800" cy="219456"/>
           </a:xfrm>
           <a:prstGeom prst="rect">
             <a:avLst/>
@@ -12828,21 +13569,21 @@
                 </a:solidFill>
                 <a:latin typeface="Helvetica Neue"/>
               </a:rPr>
-              <a:t>STEP 13</a:t>
-            </a:r>
-          </a:p>
-        </p:txBody>
-      </p:sp>
-      <p:sp>
-        <p:nvSpPr>
-          <p:cNvPr id="19" name="TextBox 18"/>
-          <p:cNvSpPr txBox="1"/>
-          <p:nvPr/>
-        </p:nvSpPr>
-        <p:spPr>
-          <a:xfrm>
-            <a:off x="8420709" y="6460236"/>
-            <a:ext cx="3030321" cy="219456"/>
+              <a:t>STEP 9</a:t>
+            </a:r>
+          </a:p>
+        </p:txBody>
+      </p:sp>
+      <p:sp>
+        <p:nvSpPr>
+          <p:cNvPr id="20" name="TextBox 19"/>
+          <p:cNvSpPr txBox="1"/>
+          <p:nvPr/>
+        </p:nvSpPr>
+        <p:spPr>
+          <a:xfrm>
+            <a:off x="8952890" y="6460236"/>
+            <a:ext cx="2498140" cy="219456"/>
           </a:xfrm>
           <a:prstGeom prst="rect">
             <a:avLst/>
@@ -12863,7 +13604,7 @@
                 </a:solidFill>
                 <a:latin typeface="Helvetica Neue"/>
               </a:rPr>
-              <a:t>Route the inbox with no training data</a:t>
+              <a:t>Watch attention change a word</a:t>
             </a:r>
           </a:p>
         </p:txBody>

</xml_diff>

<commit_message>
Week 7: open up the attention band on the block slide, flip the flow top-down
The block diagram now runs in at the top, out at the bottom, with attention above
feed-forward. Adds the data objects and the steps:
  * Q/K/V chips under every input token, so you see one vector spawn three
  * the four numbered operations that produce the mesh: Q dot K, divide by root
    64, softmax, times V, each with a plain-English gloss
  * a note that step 4 is the ONLY place information moves between words
  * two thirds of the weights live in the feed-forward band, not attention

Shapes and the scaling figure were pulled from a live bert-base forward pass
rather than written from memory. Still 19 slides, 60 + 30 minutes.

Co-Authored-By: Claude Opus 4.8 <noreply@anthropic.com>
</commit_message>
<xml_diff>
--- a/Week 7/L13_Support_Copilot_v3_discussion.pptx
+++ b/Week 7/L13_Support_Copilot_v3_discussion.pptx
@@ -13371,8 +13371,8 @@
         </p:blipFill>
         <p:spPr>
           <a:xfrm>
-            <a:off x="621096" y="1632204"/>
-            <a:ext cx="10949502" cy="4315968"/>
+            <a:off x="607178" y="1632204"/>
+            <a:ext cx="10977337" cy="4315968"/>
           </a:xfrm>
           <a:prstGeom prst="rect">
             <a:avLst/>

</xml_diff>

<commit_message>
Week 7: add the 3Blue1Brown attention video to the transformer slide
Verified title and scope before labelling it: '3Blue1Brown, Attention in
transformers, step-by-step | Deep Learning Chapter 6', 26 minutes, covering
Q/K/V, multi-head, masking and context size. It is the deeper version of exactly
what slide 9 shows.

Present in every presentation artifact:
  deck      clickable hyperlink under the diagram
  slideshow red WATCH pill on slide 9, plus a W keyboard shortcut
  notes     WATCH / ASSIGN cue with the URL on the slide 9 page
  pptx      same cue in the presenter-view notes

Co-Authored-By: Claude Opus 4.8 <noreply@anthropic.com>
</commit_message>
<xml_diff>
--- a/Week 7/L13_Support_Copilot_v3_discussion.pptx
+++ b/Week 7/L13_Support_Copilot_v3_discussion.pptx
@@ -13388,28 +13388,38 @@
         <p:spPr>
           <a:xfrm>
             <a:off x="640080" y="6035040"/>
-            <a:ext cx="10881360" cy="320040"/>
-          </a:xfrm>
-          <a:prstGeom prst="rect">
-            <a:avLst/>
-          </a:prstGeom>
-          <a:noFill/>
-        </p:spPr>
-        <p:txBody>
-          <a:bodyPr wrap="square" lIns="0" rIns="0" tIns="0" bIns="0">
+            <a:ext cx="10881360" cy="310896"/>
+          </a:xfrm>
+          <a:prstGeom prst="rect">
+            <a:avLst/>
+          </a:prstGeom>
+          <a:noFill/>
+        </p:spPr>
+        <p:txBody>
+          <a:bodyPr wrap="square">
             <a:spAutoFit/>
           </a:bodyPr>
           <a:lstStyle/>
           <a:p>
             <a:pPr algn="ctr"/>
             <a:r>
-              <a:rPr sz="1500" b="0" i="1">
+              <a:rPr sz="1350" i="1">
                 <a:solidFill>
                   <a:srgbClr val="475569"/>
                 </a:solidFill>
                 <a:latin typeface="Helvetica Neue"/>
               </a:rPr>
-              <a:t>You built this in Lecture 11. Tonight you only need the shape of it.</a:t>
+              <a:t>You built this in Lecture 11.     Go deeper:  </a:t>
+            </a:r>
+            <a:r>
+              <a:rPr sz="1350" b="1" u="sng">
+                <a:solidFill>
+                  <a:srgbClr val="1D4ED8"/>
+                </a:solidFill>
+                <a:latin typeface="Helvetica Neue"/>
+                <a:hlinkClick r:id="rId3"/>
+              </a:rPr>
+              <a:t>3Blue1Brown, Attention in transformers (26 min)</a:t>
             </a:r>
           </a:p>
         </p:txBody>

</xml_diff>

<commit_message>
Week 7: fold the video clip into the lecture and match the notebook to it
Slide 8 is now a video handoff: play 3Blue1Brown 0:00 to 8:00 (which stops right
after Queries, before the GPT-3 parameter counting), then return to the block
diagram as the compressed version in our own vocabulary. The inbox-map slide is
cut to pay for the 8 minutes; its notebook STEP 5 stays as self-study.

The notebook gains a matching section before STEP 9 with the watch range and a
table linking the video's examples to what students already saw: his 'mole' to
our 'plan', his query/key vectors to our Q/K/V chips, his grid to our mesh.

18 slides, still 60 teaching + 30 discussion. All 21 notebook cells verified.

Co-Authored-By: Claude Opus 4.8 <noreply@anthropic.com>
</commit_message>
<xml_diff>
--- a/Week 7/L13_Support_Copilot_v3_discussion.pptx
+++ b/Week 7/L13_Support_Copilot_v3_discussion.pptx
@@ -23,7 +23,6 @@
     <p:sldId id="271" r:id="rId22"/>
     <p:sldId id="272" r:id="rId23"/>
     <p:sldId id="273" r:id="rId24"/>
-    <p:sldId id="274" r:id="rId25"/>
   </p:sldIdLst>
   <p:sldSz cx="12191695" cy="6858000" type="screen4x3"/>
   <p:notesSz cx="6858000" cy="9144000"/>
@@ -3736,7 +3735,7 @@
         <p:spPr>
           <a:xfrm>
             <a:off x="640080" y="758952"/>
-            <a:ext cx="7680960" cy="1179576"/>
+            <a:ext cx="7680960" cy="704088"/>
           </a:xfrm>
           <a:prstGeom prst="rect">
             <a:avLst/>
@@ -3751,20 +3750,55 @@
           <a:p>
             <a:pPr algn="l"/>
             <a:r>
-              <a:rPr sz="2900" b="1" i="0">
+              <a:rPr sz="2450" b="1" i="0">
                 <a:solidFill>
                   <a:srgbClr val="0F172A"/>
                 </a:solidFill>
                 <a:latin typeface="Helvetica Neue"/>
               </a:rPr>
-              <a:t>Sort the inbox with no training data at all.</a:t>
-            </a:r>
-          </a:p>
-        </p:txBody>
-      </p:sp>
-      <p:sp>
-        <p:nvSpPr>
-          <p:cNvPr id="4" name="Rounded Rectangle 3"/>
+              <a:t>It is not a classifier. It is a fact-checker.</a:t>
+            </a:r>
+          </a:p>
+        </p:txBody>
+      </p:sp>
+      <p:sp>
+        <p:nvSpPr>
+          <p:cNvPr id="4" name="TextBox 3"/>
+          <p:cNvSpPr txBox="1"/>
+          <p:nvPr/>
+        </p:nvSpPr>
+        <p:spPr>
+          <a:xfrm>
+            <a:off x="640080" y="1417320"/>
+            <a:ext cx="10424160" cy="457200"/>
+          </a:xfrm>
+          <a:prstGeom prst="rect">
+            <a:avLst/>
+          </a:prstGeom>
+          <a:noFill/>
+        </p:spPr>
+        <p:txBody>
+          <a:bodyPr wrap="square" lIns="0" rIns="0" tIns="0" bIns="0">
+            <a:spAutoFit/>
+          </a:bodyPr>
+          <a:lstStyle/>
+          <a:p>
+            <a:pPr algn="l"/>
+            <a:r>
+              <a:rPr sz="1500" b="0" i="0">
+                <a:solidFill>
+                  <a:srgbClr val="475569"/>
+                </a:solidFill>
+                <a:latin typeface="Helvetica Neue"/>
+              </a:rPr>
+              <a:t>The model judges whether a sentence YOU wrote is true of the ticket.</a:t>
+            </a:r>
+          </a:p>
+        </p:txBody>
+      </p:sp>
+      <p:sp>
+        <p:nvSpPr>
+          <p:cNvPr id="5" name="Rounded Rectangle 4"/>
           <p:cNvSpPr/>
           <p:nvPr/>
         </p:nvSpPr>
@@ -3807,7 +3841,7 @@
       </p:sp>
       <p:sp>
         <p:nvSpPr>
-          <p:cNvPr id="5" name="Rounded Rectangle 4"/>
+          <p:cNvPr id="6" name="Rounded Rectangle 5"/>
           <p:cNvSpPr/>
           <p:nvPr/>
         </p:nvSpPr>
@@ -3852,7 +3886,7 @@
       </p:sp>
       <p:sp>
         <p:nvSpPr>
-          <p:cNvPr id="6" name="TextBox 5"/>
+          <p:cNvPr id="7" name="TextBox 6"/>
           <p:cNvSpPr txBox="1"/>
           <p:nvPr/>
         </p:nvSpPr>
@@ -3887,7 +3921,7 @@
       </p:sp>
       <p:sp>
         <p:nvSpPr>
-          <p:cNvPr id="7" name="Rounded Rectangle 6"/>
+          <p:cNvPr id="8" name="Rounded Rectangle 7"/>
           <p:cNvSpPr/>
           <p:nvPr/>
         </p:nvSpPr>
@@ -3932,7 +3966,7 @@
       </p:sp>
       <p:sp>
         <p:nvSpPr>
-          <p:cNvPr id="8" name="TextBox 7"/>
+          <p:cNvPr id="9" name="TextBox 8"/>
           <p:cNvSpPr txBox="1"/>
           <p:nvPr/>
         </p:nvSpPr>
@@ -3967,7 +4001,7 @@
       </p:sp>
       <p:sp>
         <p:nvSpPr>
-          <p:cNvPr id="9" name="Rounded Rectangle 8"/>
+          <p:cNvPr id="10" name="Rounded Rectangle 9"/>
           <p:cNvSpPr/>
           <p:nvPr/>
         </p:nvSpPr>
@@ -4012,7 +4046,7 @@
       </p:sp>
       <p:sp>
         <p:nvSpPr>
-          <p:cNvPr id="10" name="TextBox 9"/>
+          <p:cNvPr id="11" name="TextBox 10"/>
           <p:cNvSpPr txBox="1"/>
           <p:nvPr/>
         </p:nvSpPr>
@@ -4047,7 +4081,7 @@
       </p:sp>
       <p:sp>
         <p:nvSpPr>
-          <p:cNvPr id="11" name="Rounded Rectangle 10"/>
+          <p:cNvPr id="12" name="Rounded Rectangle 11"/>
           <p:cNvSpPr/>
           <p:nvPr/>
         </p:nvSpPr>
@@ -4092,7 +4126,7 @@
       </p:sp>
       <p:sp>
         <p:nvSpPr>
-          <p:cNvPr id="12" name="TextBox 11"/>
+          <p:cNvPr id="13" name="TextBox 12"/>
           <p:cNvSpPr txBox="1"/>
           <p:nvPr/>
         </p:nvSpPr>
@@ -4127,7 +4161,7 @@
       </p:sp>
       <p:sp>
         <p:nvSpPr>
-          <p:cNvPr id="13" name="TextBox 12"/>
+          <p:cNvPr id="14" name="TextBox 13"/>
           <p:cNvSpPr txBox="1"/>
           <p:nvPr/>
         </p:nvSpPr>
@@ -4162,7 +4196,7 @@
       </p:sp>
       <p:pic>
         <p:nvPicPr>
-          <p:cNvPr id="14" name="Picture 13" descr="d_zs.png"/>
+          <p:cNvPr id="15" name="Picture 14" descr="d_nli.png"/>
           <p:cNvPicPr>
             <a:picLocks noChangeAspect="1"/>
           </p:cNvPicPr>
@@ -4176,8 +4210,8 @@
         </p:blipFill>
         <p:spPr>
           <a:xfrm>
-            <a:off x="1473370" y="1965960"/>
-            <a:ext cx="9244954" cy="4297679"/>
+            <a:off x="518007" y="2596680"/>
+            <a:ext cx="11155680" cy="2350438"/>
           </a:xfrm>
           <a:prstGeom prst="rect">
             <a:avLst/>
@@ -4186,14 +4220,14 @@
       </p:pic>
       <p:sp>
         <p:nvSpPr>
-          <p:cNvPr id="15" name="Rounded Rectangle 14"/>
+          <p:cNvPr id="16" name="Rounded Rectangle 15"/>
           <p:cNvSpPr/>
           <p:nvPr/>
         </p:nvSpPr>
         <p:spPr>
           <a:xfrm>
-            <a:off x="6505041" y="6345936"/>
-            <a:ext cx="5046573" cy="365760"/>
+            <a:off x="7306056" y="6345936"/>
+            <a:ext cx="4245559" cy="365760"/>
           </a:xfrm>
           <a:prstGeom prst="roundRect">
             <a:avLst>
@@ -4231,13 +4265,13 @@
       </p:sp>
       <p:sp>
         <p:nvSpPr>
-          <p:cNvPr id="16" name="Rounded Rectangle 15"/>
+          <p:cNvPr id="17" name="Rounded Rectangle 16"/>
           <p:cNvSpPr/>
           <p:nvPr/>
         </p:nvSpPr>
         <p:spPr>
           <a:xfrm>
-            <a:off x="7547457" y="6396228"/>
+            <a:off x="8348472" y="6396228"/>
             <a:ext cx="754380" cy="265176"/>
           </a:xfrm>
           <a:prstGeom prst="roundRect">
@@ -4276,13 +4310,13 @@
       </p:sp>
       <p:sp>
         <p:nvSpPr>
-          <p:cNvPr id="17" name="TextBox 16"/>
-          <p:cNvSpPr txBox="1"/>
-          <p:nvPr/>
-        </p:nvSpPr>
-        <p:spPr>
-          <a:xfrm>
-            <a:off x="6660489" y="6460236"/>
+          <p:cNvPr id="18" name="TextBox 17"/>
+          <p:cNvSpPr txBox="1"/>
+          <p:nvPr/>
+        </p:nvSpPr>
+        <p:spPr>
+          <a:xfrm>
+            <a:off x="7461504" y="6460236"/>
             <a:ext cx="914400" cy="219456"/>
           </a:xfrm>
           <a:prstGeom prst="rect">
@@ -4311,13 +4345,13 @@
       </p:sp>
       <p:sp>
         <p:nvSpPr>
-          <p:cNvPr id="18" name="TextBox 17"/>
-          <p:cNvSpPr txBox="1"/>
-          <p:nvPr/>
-        </p:nvSpPr>
-        <p:spPr>
-          <a:xfrm>
-            <a:off x="7547457" y="6451092"/>
+          <p:cNvPr id="19" name="TextBox 18"/>
+          <p:cNvSpPr txBox="1"/>
+          <p:nvPr/>
+        </p:nvSpPr>
+        <p:spPr>
+          <a:xfrm>
+            <a:off x="8348472" y="6451092"/>
             <a:ext cx="754380" cy="219456"/>
           </a:xfrm>
           <a:prstGeom prst="rect">
@@ -4339,21 +4373,21 @@
                 </a:solidFill>
                 <a:latin typeface="Helvetica Neue"/>
               </a:rPr>
-              <a:t>STEP 13</a:t>
-            </a:r>
-          </a:p>
-        </p:txBody>
-      </p:sp>
-      <p:sp>
-        <p:nvSpPr>
-          <p:cNvPr id="19" name="TextBox 18"/>
-          <p:cNvSpPr txBox="1"/>
-          <p:nvPr/>
-        </p:nvSpPr>
-        <p:spPr>
-          <a:xfrm>
-            <a:off x="8420709" y="6460236"/>
-            <a:ext cx="3030321" cy="219456"/>
+              <a:t>STEP 17</a:t>
+            </a:r>
+          </a:p>
+        </p:txBody>
+      </p:sp>
+      <p:sp>
+        <p:nvSpPr>
+          <p:cNvPr id="20" name="TextBox 19"/>
+          <p:cNvSpPr txBox="1"/>
+          <p:nvPr/>
+        </p:nvSpPr>
+        <p:spPr>
+          <a:xfrm>
+            <a:off x="9221724" y="6460236"/>
+            <a:ext cx="2229307" cy="219456"/>
           </a:xfrm>
           <a:prstGeom prst="rect">
             <a:avLst/>
@@ -4374,7 +4408,42 @@
                 </a:solidFill>
                 <a:latin typeface="Helvetica Neue"/>
               </a:rPr>
-              <a:t>Route the inbox with no training data</a:t>
+              <a:t>See the entailment scores</a:t>
+            </a:r>
+          </a:p>
+        </p:txBody>
+      </p:sp>
+      <p:sp>
+        <p:nvSpPr>
+          <p:cNvPr id="21" name="TextBox 20"/>
+          <p:cNvSpPr txBox="1"/>
+          <p:nvPr/>
+        </p:nvSpPr>
+        <p:spPr>
+          <a:xfrm>
+            <a:off x="640080" y="5532120"/>
+            <a:ext cx="10881360" cy="640080"/>
+          </a:xfrm>
+          <a:prstGeom prst="rect">
+            <a:avLst/>
+          </a:prstGeom>
+          <a:noFill/>
+        </p:spPr>
+        <p:txBody>
+          <a:bodyPr wrap="square" lIns="0" rIns="0" tIns="0" bIns="0">
+            <a:spAutoFit/>
+          </a:bodyPr>
+          <a:lstStyle/>
+          <a:p>
+            <a:pPr algn="ctr"/>
+            <a:r>
+              <a:rPr sz="1500" b="0" i="1">
+                <a:solidFill>
+                  <a:srgbClr val="475569"/>
+                </a:solidFill>
+                <a:latin typeface="Helvetica Neue"/>
+              </a:rPr>
+              <a:t>Every category becomes a sentence: "This example is {your description}." The model scores all eight and picks whichever it most believes.</a:t>
             </a:r>
           </a:p>
         </p:txBody>
@@ -4441,7 +4510,7 @@
         <p:spPr>
           <a:xfrm>
             <a:off x="640080" y="758952"/>
-            <a:ext cx="7680960" cy="704088"/>
+            <a:ext cx="7680960" cy="1179576"/>
           </a:xfrm>
           <a:prstGeom prst="rect">
             <a:avLst/>
@@ -4456,55 +4525,20 @@
           <a:p>
             <a:pPr algn="l"/>
             <a:r>
-              <a:rPr sz="2450" b="1" i="0">
+              <a:rPr sz="2900" b="1" i="0">
                 <a:solidFill>
                   <a:srgbClr val="0F172A"/>
                 </a:solidFill>
                 <a:latin typeface="Helvetica Neue"/>
               </a:rPr>
-              <a:t>It is not a classifier. It is a fact-checker.</a:t>
-            </a:r>
-          </a:p>
-        </p:txBody>
-      </p:sp>
-      <p:sp>
-        <p:nvSpPr>
-          <p:cNvPr id="4" name="TextBox 3"/>
-          <p:cNvSpPr txBox="1"/>
-          <p:nvPr/>
-        </p:nvSpPr>
-        <p:spPr>
-          <a:xfrm>
-            <a:off x="640080" y="1417320"/>
-            <a:ext cx="10424160" cy="457200"/>
-          </a:xfrm>
-          <a:prstGeom prst="rect">
-            <a:avLst/>
-          </a:prstGeom>
-          <a:noFill/>
-        </p:spPr>
-        <p:txBody>
-          <a:bodyPr wrap="square" lIns="0" rIns="0" tIns="0" bIns="0">
-            <a:spAutoFit/>
-          </a:bodyPr>
-          <a:lstStyle/>
-          <a:p>
-            <a:pPr algn="l"/>
-            <a:r>
-              <a:rPr sz="1500" b="0" i="0">
-                <a:solidFill>
-                  <a:srgbClr val="475569"/>
-                </a:solidFill>
-                <a:latin typeface="Helvetica Neue"/>
-              </a:rPr>
-              <a:t>The model judges whether a sentence YOU wrote is true of the ticket.</a:t>
-            </a:r>
-          </a:p>
-        </p:txBody>
-      </p:sp>
-      <p:sp>
-        <p:nvSpPr>
-          <p:cNvPr id="5" name="Rounded Rectangle 4"/>
+              <a:t>The descriptions you write ARE the program.</a:t>
+            </a:r>
+          </a:p>
+        </p:txBody>
+      </p:sp>
+      <p:sp>
+        <p:nvSpPr>
+          <p:cNvPr id="4" name="Rounded Rectangle 3"/>
           <p:cNvSpPr/>
           <p:nvPr/>
         </p:nvSpPr>
@@ -4547,7 +4581,7 @@
       </p:sp>
       <p:sp>
         <p:nvSpPr>
-          <p:cNvPr id="6" name="Rounded Rectangle 5"/>
+          <p:cNvPr id="5" name="Rounded Rectangle 4"/>
           <p:cNvSpPr/>
           <p:nvPr/>
         </p:nvSpPr>
@@ -4592,7 +4626,7 @@
       </p:sp>
       <p:sp>
         <p:nvSpPr>
-          <p:cNvPr id="7" name="TextBox 6"/>
+          <p:cNvPr id="6" name="TextBox 5"/>
           <p:cNvSpPr txBox="1"/>
           <p:nvPr/>
         </p:nvSpPr>
@@ -4627,7 +4661,7 @@
       </p:sp>
       <p:sp>
         <p:nvSpPr>
-          <p:cNvPr id="8" name="Rounded Rectangle 7"/>
+          <p:cNvPr id="7" name="Rounded Rectangle 6"/>
           <p:cNvSpPr/>
           <p:nvPr/>
         </p:nvSpPr>
@@ -4672,7 +4706,7 @@
       </p:sp>
       <p:sp>
         <p:nvSpPr>
-          <p:cNvPr id="9" name="TextBox 8"/>
+          <p:cNvPr id="8" name="TextBox 7"/>
           <p:cNvSpPr txBox="1"/>
           <p:nvPr/>
         </p:nvSpPr>
@@ -4707,7 +4741,7 @@
       </p:sp>
       <p:sp>
         <p:nvSpPr>
-          <p:cNvPr id="10" name="Rounded Rectangle 9"/>
+          <p:cNvPr id="9" name="Rounded Rectangle 8"/>
           <p:cNvSpPr/>
           <p:nvPr/>
         </p:nvSpPr>
@@ -4752,7 +4786,7 @@
       </p:sp>
       <p:sp>
         <p:nvSpPr>
-          <p:cNvPr id="11" name="TextBox 10"/>
+          <p:cNvPr id="10" name="TextBox 9"/>
           <p:cNvSpPr txBox="1"/>
           <p:nvPr/>
         </p:nvSpPr>
@@ -4787,7 +4821,7 @@
       </p:sp>
       <p:sp>
         <p:nvSpPr>
-          <p:cNvPr id="12" name="Rounded Rectangle 11"/>
+          <p:cNvPr id="11" name="Rounded Rectangle 10"/>
           <p:cNvSpPr/>
           <p:nvPr/>
         </p:nvSpPr>
@@ -4832,7 +4866,7 @@
       </p:sp>
       <p:sp>
         <p:nvSpPr>
-          <p:cNvPr id="13" name="TextBox 12"/>
+          <p:cNvPr id="12" name="TextBox 11"/>
           <p:cNvSpPr txBox="1"/>
           <p:nvPr/>
         </p:nvSpPr>
@@ -4867,7 +4901,7 @@
       </p:sp>
       <p:sp>
         <p:nvSpPr>
-          <p:cNvPr id="14" name="TextBox 13"/>
+          <p:cNvPr id="13" name="TextBox 12"/>
           <p:cNvSpPr txBox="1"/>
           <p:nvPr/>
         </p:nvSpPr>
@@ -4902,7 +4936,7 @@
       </p:sp>
       <p:pic>
         <p:nvPicPr>
-          <p:cNvPr id="15" name="Picture 14" descr="d_nli.png"/>
+          <p:cNvPr id="14" name="Picture 13" descr="d_wording.png"/>
           <p:cNvPicPr>
             <a:picLocks noChangeAspect="1"/>
           </p:cNvPicPr>
@@ -4916,8 +4950,8 @@
         </p:blipFill>
         <p:spPr>
           <a:xfrm>
-            <a:off x="518007" y="2596680"/>
-            <a:ext cx="11155680" cy="2350438"/>
+            <a:off x="518007" y="2769342"/>
+            <a:ext cx="11155680" cy="2599474"/>
           </a:xfrm>
           <a:prstGeom prst="rect">
             <a:avLst/>
@@ -4926,14 +4960,14 @@
       </p:pic>
       <p:sp>
         <p:nvSpPr>
-          <p:cNvPr id="16" name="Rounded Rectangle 15"/>
+          <p:cNvPr id="15" name="Rounded Rectangle 14"/>
           <p:cNvSpPr/>
           <p:nvPr/>
         </p:nvSpPr>
         <p:spPr>
           <a:xfrm>
-            <a:off x="7306056" y="6345936"/>
-            <a:ext cx="4245559" cy="365760"/>
+            <a:off x="6638544" y="6345936"/>
+            <a:ext cx="4913071" cy="365760"/>
           </a:xfrm>
           <a:prstGeom prst="roundRect">
             <a:avLst>
@@ -4971,13 +5005,13 @@
       </p:sp>
       <p:sp>
         <p:nvSpPr>
-          <p:cNvPr id="17" name="Rounded Rectangle 16"/>
+          <p:cNvPr id="16" name="Rounded Rectangle 15"/>
           <p:cNvSpPr/>
           <p:nvPr/>
         </p:nvSpPr>
         <p:spPr>
           <a:xfrm>
-            <a:off x="8348472" y="6396228"/>
+            <a:off x="7680960" y="6396228"/>
             <a:ext cx="754380" cy="265176"/>
           </a:xfrm>
           <a:prstGeom prst="roundRect">
@@ -5016,14 +5050,49 @@
       </p:sp>
       <p:sp>
         <p:nvSpPr>
+          <p:cNvPr id="17" name="TextBox 16"/>
+          <p:cNvSpPr txBox="1"/>
+          <p:nvPr/>
+        </p:nvSpPr>
+        <p:spPr>
+          <a:xfrm>
+            <a:off x="6793992" y="6460236"/>
+            <a:ext cx="914400" cy="219456"/>
+          </a:xfrm>
+          <a:prstGeom prst="rect">
+            <a:avLst/>
+          </a:prstGeom>
+          <a:noFill/>
+        </p:spPr>
+        <p:txBody>
+          <a:bodyPr wrap="none" lIns="0" rIns="0" tIns="0" bIns="0">
+            <a:spAutoFit/>
+          </a:bodyPr>
+          <a:lstStyle/>
+          <a:p>
+            <a:pPr algn="l"/>
+            <a:r>
+              <a:rPr sz="950" b="1" i="0">
+                <a:solidFill>
+                  <a:srgbClr val="A7F3D0"/>
+                </a:solidFill>
+                <a:latin typeface="Helvetica Neue"/>
+              </a:rPr>
+              <a:t>▶ NOTEBOOK</a:t>
+            </a:r>
+          </a:p>
+        </p:txBody>
+      </p:sp>
+      <p:sp>
+        <p:nvSpPr>
           <p:cNvPr id="18" name="TextBox 17"/>
           <p:cNvSpPr txBox="1"/>
           <p:nvPr/>
         </p:nvSpPr>
         <p:spPr>
           <a:xfrm>
-            <a:off x="7461504" y="6460236"/>
-            <a:ext cx="914400" cy="219456"/>
+            <a:off x="7680960" y="6451092"/>
+            <a:ext cx="754380" cy="219456"/>
           </a:xfrm>
           <a:prstGeom prst="rect">
             <a:avLst/>
@@ -5036,120 +5105,50 @@
           </a:bodyPr>
           <a:lstStyle/>
           <a:p>
+            <a:pPr algn="ctr"/>
+            <a:r>
+              <a:rPr sz="1100" b="1" i="0">
+                <a:solidFill>
+                  <a:srgbClr val="FFFFFF"/>
+                </a:solidFill>
+                <a:latin typeface="Helvetica Neue"/>
+              </a:rPr>
+              <a:t>STEP 16</a:t>
+            </a:r>
+          </a:p>
+        </p:txBody>
+      </p:sp>
+      <p:sp>
+        <p:nvSpPr>
+          <p:cNvPr id="19" name="TextBox 18"/>
+          <p:cNvSpPr txBox="1"/>
+          <p:nvPr/>
+        </p:nvSpPr>
+        <p:spPr>
+          <a:xfrm>
+            <a:off x="8554212" y="6460236"/>
+            <a:ext cx="2896819" cy="219456"/>
+          </a:xfrm>
+          <a:prstGeom prst="rect">
+            <a:avLst/>
+          </a:prstGeom>
+          <a:noFill/>
+        </p:spPr>
+        <p:txBody>
+          <a:bodyPr wrap="none" lIns="0" rIns="0" tIns="0" bIns="0">
+            <a:spAutoFit/>
+          </a:bodyPr>
+          <a:lstStyle/>
+          <a:p>
             <a:pPr algn="l"/>
             <a:r>
-              <a:rPr sz="950" b="1" i="0">
-                <a:solidFill>
-                  <a:srgbClr val="A7F3D0"/>
-                </a:solidFill>
-                <a:latin typeface="Helvetica Neue"/>
-              </a:rPr>
-              <a:t>▶ NOTEBOOK</a:t>
-            </a:r>
-          </a:p>
-        </p:txBody>
-      </p:sp>
-      <p:sp>
-        <p:nvSpPr>
-          <p:cNvPr id="19" name="TextBox 18"/>
-          <p:cNvSpPr txBox="1"/>
-          <p:nvPr/>
-        </p:nvSpPr>
-        <p:spPr>
-          <a:xfrm>
-            <a:off x="8348472" y="6451092"/>
-            <a:ext cx="754380" cy="219456"/>
-          </a:xfrm>
-          <a:prstGeom prst="rect">
-            <a:avLst/>
-          </a:prstGeom>
-          <a:noFill/>
-        </p:spPr>
-        <p:txBody>
-          <a:bodyPr wrap="none" lIns="0" rIns="0" tIns="0" bIns="0">
-            <a:spAutoFit/>
-          </a:bodyPr>
-          <a:lstStyle/>
-          <a:p>
-            <a:pPr algn="ctr"/>
-            <a:r>
-              <a:rPr sz="1100" b="1" i="0">
+              <a:rPr sz="1000" b="1" i="0">
                 <a:solidFill>
                   <a:srgbClr val="FFFFFF"/>
                 </a:solidFill>
                 <a:latin typeface="Helvetica Neue"/>
               </a:rPr>
-              <a:t>STEP 17</a:t>
-            </a:r>
-          </a:p>
-        </p:txBody>
-      </p:sp>
-      <p:sp>
-        <p:nvSpPr>
-          <p:cNvPr id="20" name="TextBox 19"/>
-          <p:cNvSpPr txBox="1"/>
-          <p:nvPr/>
-        </p:nvSpPr>
-        <p:spPr>
-          <a:xfrm>
-            <a:off x="9221724" y="6460236"/>
-            <a:ext cx="2229307" cy="219456"/>
-          </a:xfrm>
-          <a:prstGeom prst="rect">
-            <a:avLst/>
-          </a:prstGeom>
-          <a:noFill/>
-        </p:spPr>
-        <p:txBody>
-          <a:bodyPr wrap="none" lIns="0" rIns="0" tIns="0" bIns="0">
-            <a:spAutoFit/>
-          </a:bodyPr>
-          <a:lstStyle/>
-          <a:p>
-            <a:pPr algn="l"/>
-            <a:r>
-              <a:rPr sz="1000" b="1" i="0">
-                <a:solidFill>
-                  <a:srgbClr val="FFFFFF"/>
-                </a:solidFill>
-                <a:latin typeface="Helvetica Neue"/>
-              </a:rPr>
-              <a:t>See the entailment scores</a:t>
-            </a:r>
-          </a:p>
-        </p:txBody>
-      </p:sp>
-      <p:sp>
-        <p:nvSpPr>
-          <p:cNvPr id="21" name="TextBox 20"/>
-          <p:cNvSpPr txBox="1"/>
-          <p:nvPr/>
-        </p:nvSpPr>
-        <p:spPr>
-          <a:xfrm>
-            <a:off x="640080" y="5532120"/>
-            <a:ext cx="10881360" cy="640080"/>
-          </a:xfrm>
-          <a:prstGeom prst="rect">
-            <a:avLst/>
-          </a:prstGeom>
-          <a:noFill/>
-        </p:spPr>
-        <p:txBody>
-          <a:bodyPr wrap="square" lIns="0" rIns="0" tIns="0" bIns="0">
-            <a:spAutoFit/>
-          </a:bodyPr>
-          <a:lstStyle/>
-          <a:p>
-            <a:pPr algn="ctr"/>
-            <a:r>
-              <a:rPr sz="1500" b="0" i="1">
-                <a:solidFill>
-                  <a:srgbClr val="475569"/>
-                </a:solidFill>
-                <a:latin typeface="Helvetica Neue"/>
-              </a:rPr>
-              <a:t>Every category becomes a sentence: "This example is {your description}." The model scores all eight and picks whichever it most believes.</a:t>
+              <a:t>YOUR KNOB: rewrite the descriptions</a:t>
             </a:r>
           </a:p>
         </p:txBody>
@@ -5198,11 +5197,11 @@
             <a:r>
               <a:rPr sz="1250" b="1" i="0" spc="220">
                 <a:solidFill>
-                  <a:srgbClr val="7C3AED"/>
-                </a:solidFill>
-                <a:latin typeface="Helvetica Neue"/>
-              </a:rPr>
-              <a:t>ROUTE</a:t>
+                  <a:srgbClr val="059669"/>
+                </a:solidFill>
+                <a:latin typeface="Helvetica Neue"/>
+              </a:rPr>
+              <a:t>DECIDE</a:t>
             </a:r>
           </a:p>
         </p:txBody>
@@ -5216,7 +5215,7 @@
         <p:spPr>
           <a:xfrm>
             <a:off x="640080" y="758952"/>
-            <a:ext cx="7680960" cy="1179576"/>
+            <a:ext cx="7680960" cy="704088"/>
           </a:xfrm>
           <a:prstGeom prst="rect">
             <a:avLst/>
@@ -5231,20 +5230,55 @@
           <a:p>
             <a:pPr algn="l"/>
             <a:r>
-              <a:rPr sz="2900" b="1" i="0">
+              <a:rPr sz="2650" b="1" i="0">
                 <a:solidFill>
                   <a:srgbClr val="0F172A"/>
                 </a:solidFill>
                 <a:latin typeface="Helvetica Neue"/>
               </a:rPr>
-              <a:t>The descriptions you write ARE the program.</a:t>
-            </a:r>
-          </a:p>
-        </p:txBody>
-      </p:sp>
-      <p:sp>
-        <p:nvSpPr>
-          <p:cNvPr id="4" name="Rounded Rectangle 3"/>
+              <a:t>An average is a bad way to run a product.</a:t>
+            </a:r>
+          </a:p>
+        </p:txBody>
+      </p:sp>
+      <p:sp>
+        <p:nvSpPr>
+          <p:cNvPr id="4" name="TextBox 3"/>
+          <p:cNvSpPr txBox="1"/>
+          <p:nvPr/>
+        </p:nvSpPr>
+        <p:spPr>
+          <a:xfrm>
+            <a:off x="640080" y="1417320"/>
+            <a:ext cx="10424160" cy="457200"/>
+          </a:xfrm>
+          <a:prstGeom prst="rect">
+            <a:avLst/>
+          </a:prstGeom>
+          <a:noFill/>
+        </p:spPr>
+        <p:txBody>
+          <a:bodyPr wrap="square" lIns="0" rIns="0" tIns="0" bIns="0">
+            <a:spAutoFit/>
+          </a:bodyPr>
+          <a:lstStyle/>
+          <a:p>
+            <a:pPr algn="l"/>
+            <a:r>
+              <a:rPr sz="1500" b="0" i="0">
+                <a:solidFill>
+                  <a:srgbClr val="475569"/>
+                </a:solidFill>
+                <a:latin typeface="Helvetica Neue"/>
+              </a:rPr>
+              <a:t>Ask WHICH tickets it gets wrong. The weak buckets are the ones whose descriptions overlap.</a:t>
+            </a:r>
+          </a:p>
+        </p:txBody>
+      </p:sp>
+      <p:sp>
+        <p:nvSpPr>
+          <p:cNvPr id="5" name="Rounded Rectangle 4"/>
           <p:cNvSpPr/>
           <p:nvPr/>
         </p:nvSpPr>
@@ -5287,7 +5321,7 @@
       </p:sp>
       <p:sp>
         <p:nvSpPr>
-          <p:cNvPr id="5" name="Rounded Rectangle 4"/>
+          <p:cNvPr id="6" name="Rounded Rectangle 5"/>
           <p:cNvSpPr/>
           <p:nvPr/>
         </p:nvSpPr>
@@ -5332,7 +5366,7 @@
       </p:sp>
       <p:sp>
         <p:nvSpPr>
-          <p:cNvPr id="6" name="TextBox 5"/>
+          <p:cNvPr id="7" name="TextBox 6"/>
           <p:cNvSpPr txBox="1"/>
           <p:nvPr/>
         </p:nvSpPr>
@@ -5367,14 +5401,14 @@
       </p:sp>
       <p:sp>
         <p:nvSpPr>
-          <p:cNvPr id="7" name="Rounded Rectangle 6"/>
+          <p:cNvPr id="8" name="Rounded Rectangle 7"/>
           <p:cNvSpPr/>
           <p:nvPr/>
         </p:nvSpPr>
         <p:spPr>
           <a:xfrm>
-            <a:off x="9208008" y="438912"/>
-            <a:ext cx="329184" cy="329184"/>
+            <a:off x="9244584" y="475488"/>
+            <a:ext cx="256032" cy="256032"/>
           </a:xfrm>
           <a:prstGeom prst="roundRect">
             <a:avLst>
@@ -5412,13 +5446,93 @@
       </p:sp>
       <p:sp>
         <p:nvSpPr>
-          <p:cNvPr id="8" name="TextBox 7"/>
-          <p:cNvSpPr txBox="1"/>
-          <p:nvPr/>
-        </p:nvSpPr>
-        <p:spPr>
-          <a:xfrm>
-            <a:off x="9153144" y="475488"/>
+          <p:cNvPr id="9" name="TextBox 8"/>
+          <p:cNvSpPr txBox="1"/>
+          <p:nvPr/>
+        </p:nvSpPr>
+        <p:spPr>
+          <a:xfrm>
+            <a:off x="9189719" y="475488"/>
+            <a:ext cx="365760" cy="256032"/>
+          </a:xfrm>
+          <a:prstGeom prst="rect">
+            <a:avLst/>
+          </a:prstGeom>
+          <a:noFill/>
+        </p:spPr>
+        <p:txBody>
+          <a:bodyPr wrap="square" lIns="0" rIns="0" tIns="0" bIns="0">
+            <a:spAutoFit/>
+          </a:bodyPr>
+          <a:lstStyle/>
+          <a:p>
+            <a:pPr algn="ctr"/>
+            <a:r>
+              <a:rPr sz="1050" b="1" i="0">
+                <a:solidFill>
+                  <a:srgbClr val="FFFFFF"/>
+                </a:solidFill>
+                <a:latin typeface="Helvetica Neue"/>
+              </a:rPr>
+              <a:t>2</a:t>
+            </a:r>
+          </a:p>
+        </p:txBody>
+      </p:sp>
+      <p:sp>
+        <p:nvSpPr>
+          <p:cNvPr id="10" name="Rounded Rectangle 9"/>
+          <p:cNvSpPr/>
+          <p:nvPr/>
+        </p:nvSpPr>
+        <p:spPr>
+          <a:xfrm>
+            <a:off x="9866376" y="438912"/>
+            <a:ext cx="329184" cy="329184"/>
+          </a:xfrm>
+          <a:prstGeom prst="roundRect">
+            <a:avLst>
+              <a:gd name="adj" fmla="val 32000"/>
+            </a:avLst>
+          </a:prstGeom>
+          <a:solidFill>
+            <a:srgbClr val="7C3AED"/>
+          </a:solidFill>
+          <a:ln>
+            <a:noFill/>
+          </a:ln>
+        </p:spPr>
+        <p:style>
+          <a:lnRef idx="1">
+            <a:schemeClr val="accent1"/>
+          </a:lnRef>
+          <a:fillRef idx="3">
+            <a:schemeClr val="accent1"/>
+          </a:fillRef>
+          <a:effectRef idx="2">
+            <a:schemeClr val="accent1"/>
+          </a:effectRef>
+          <a:fontRef idx="minor">
+            <a:schemeClr val="lt1"/>
+          </a:fontRef>
+        </p:style>
+        <p:txBody>
+          <a:bodyPr rtlCol="0" anchor="ctr"/>
+          <a:lstStyle/>
+          <a:p>
+            <a:pPr algn="ctr"/>
+          </a:p>
+        </p:txBody>
+      </p:sp>
+      <p:sp>
+        <p:nvSpPr>
+          <p:cNvPr id="11" name="TextBox 10"/>
+          <p:cNvSpPr txBox="1"/>
+          <p:nvPr/>
+        </p:nvSpPr>
+        <p:spPr>
+          <a:xfrm>
+            <a:off x="9811511" y="475488"/>
             <a:ext cx="438912" cy="256032"/>
           </a:xfrm>
           <a:prstGeom prst="rect">
@@ -5440,20 +5554,20 @@
                 </a:solidFill>
                 <a:latin typeface="Helvetica Neue"/>
               </a:rPr>
-              <a:t>2</a:t>
-            </a:r>
-          </a:p>
-        </p:txBody>
-      </p:sp>
-      <p:sp>
-        <p:nvSpPr>
-          <p:cNvPr id="9" name="Rounded Rectangle 8"/>
+              <a:t>3</a:t>
+            </a:r>
+          </a:p>
+        </p:txBody>
+      </p:sp>
+      <p:sp>
+        <p:nvSpPr>
+          <p:cNvPr id="12" name="Rounded Rectangle 11"/>
           <p:cNvSpPr/>
           <p:nvPr/>
         </p:nvSpPr>
         <p:spPr>
           <a:xfrm>
-            <a:off x="9902951" y="475488"/>
+            <a:off x="10561319" y="475488"/>
             <a:ext cx="256032" cy="256032"/>
           </a:xfrm>
           <a:prstGeom prst="roundRect">
@@ -5492,87 +5606,7 @@
       </p:sp>
       <p:sp>
         <p:nvSpPr>
-          <p:cNvPr id="10" name="TextBox 9"/>
-          <p:cNvSpPr txBox="1"/>
-          <p:nvPr/>
-        </p:nvSpPr>
-        <p:spPr>
-          <a:xfrm>
-            <a:off x="9848087" y="475488"/>
-            <a:ext cx="365760" cy="256032"/>
-          </a:xfrm>
-          <a:prstGeom prst="rect">
-            <a:avLst/>
-          </a:prstGeom>
-          <a:noFill/>
-        </p:spPr>
-        <p:txBody>
-          <a:bodyPr wrap="square" lIns="0" rIns="0" tIns="0" bIns="0">
-            <a:spAutoFit/>
-          </a:bodyPr>
-          <a:lstStyle/>
-          <a:p>
-            <a:pPr algn="ctr"/>
-            <a:r>
-              <a:rPr sz="1050" b="1" i="0">
-                <a:solidFill>
-                  <a:srgbClr val="AEB4BF"/>
-                </a:solidFill>
-                <a:latin typeface="Helvetica Neue"/>
-              </a:rPr>
-              <a:t>3</a:t>
-            </a:r>
-          </a:p>
-        </p:txBody>
-      </p:sp>
-      <p:sp>
-        <p:nvSpPr>
-          <p:cNvPr id="11" name="Rounded Rectangle 10"/>
-          <p:cNvSpPr/>
-          <p:nvPr/>
-        </p:nvSpPr>
-        <p:spPr>
-          <a:xfrm>
-            <a:off x="10561319" y="475488"/>
-            <a:ext cx="256032" cy="256032"/>
-          </a:xfrm>
-          <a:prstGeom prst="roundRect">
-            <a:avLst>
-              <a:gd name="adj" fmla="val 32000"/>
-            </a:avLst>
-          </a:prstGeom>
-          <a:solidFill>
-            <a:srgbClr val="E9EBF0"/>
-          </a:solidFill>
-          <a:ln>
-            <a:noFill/>
-          </a:ln>
-        </p:spPr>
-        <p:style>
-          <a:lnRef idx="1">
-            <a:schemeClr val="accent1"/>
-          </a:lnRef>
-          <a:fillRef idx="3">
-            <a:schemeClr val="accent1"/>
-          </a:fillRef>
-          <a:effectRef idx="2">
-            <a:schemeClr val="accent1"/>
-          </a:effectRef>
-          <a:fontRef idx="minor">
-            <a:schemeClr val="lt1"/>
-          </a:fontRef>
-        </p:style>
-        <p:txBody>
-          <a:bodyPr rtlCol="0" anchor="ctr"/>
-          <a:lstStyle/>
-          <a:p>
-            <a:pPr algn="ctr"/>
-          </a:p>
-        </p:txBody>
-      </p:sp>
-      <p:sp>
-        <p:nvSpPr>
-          <p:cNvPr id="12" name="TextBox 11"/>
+          <p:cNvPr id="13" name="TextBox 12"/>
           <p:cNvSpPr txBox="1"/>
           <p:nvPr/>
         </p:nvSpPr>
@@ -5607,7 +5641,7 @@
       </p:sp>
       <p:sp>
         <p:nvSpPr>
-          <p:cNvPr id="13" name="TextBox 12"/>
+          <p:cNvPr id="14" name="TextBox 13"/>
           <p:cNvSpPr txBox="1"/>
           <p:nvPr/>
         </p:nvSpPr>
@@ -5642,7 +5676,7 @@
       </p:sp>
       <p:pic>
         <p:nvPicPr>
-          <p:cNvPr id="14" name="Picture 13" descr="d_wording.png"/>
+          <p:cNvPr id="15" name="Picture 14" descr="fig_recall.png"/>
           <p:cNvPicPr>
             <a:picLocks noChangeAspect="1"/>
           </p:cNvPicPr>
@@ -5656,8 +5690,8 @@
         </p:blipFill>
         <p:spPr>
           <a:xfrm>
-            <a:off x="518007" y="2769342"/>
-            <a:ext cx="11155680" cy="2599474"/>
+            <a:off x="2205165" y="2057400"/>
+            <a:ext cx="7781363" cy="3977639"/>
           </a:xfrm>
           <a:prstGeom prst="rect">
             <a:avLst/>
@@ -5666,14 +5700,14 @@
       </p:pic>
       <p:sp>
         <p:nvSpPr>
-          <p:cNvPr id="15" name="Rounded Rectangle 14"/>
+          <p:cNvPr id="16" name="Rounded Rectangle 15"/>
           <p:cNvSpPr/>
           <p:nvPr/>
         </p:nvSpPr>
         <p:spPr>
           <a:xfrm>
-            <a:off x="6638544" y="6345936"/>
-            <a:ext cx="4913071" cy="365760"/>
+            <a:off x="7573060" y="6345936"/>
+            <a:ext cx="3978554" cy="365760"/>
           </a:xfrm>
           <a:prstGeom prst="roundRect">
             <a:avLst>
@@ -5711,13 +5745,13 @@
       </p:sp>
       <p:sp>
         <p:nvSpPr>
-          <p:cNvPr id="16" name="Rounded Rectangle 15"/>
+          <p:cNvPr id="17" name="Rounded Rectangle 16"/>
           <p:cNvSpPr/>
           <p:nvPr/>
         </p:nvSpPr>
         <p:spPr>
           <a:xfrm>
-            <a:off x="7680960" y="6396228"/>
+            <a:off x="8615476" y="6396228"/>
             <a:ext cx="754380" cy="265176"/>
           </a:xfrm>
           <a:prstGeom prst="roundRect">
@@ -5756,13 +5790,13 @@
       </p:sp>
       <p:sp>
         <p:nvSpPr>
-          <p:cNvPr id="17" name="TextBox 16"/>
-          <p:cNvSpPr txBox="1"/>
-          <p:nvPr/>
-        </p:nvSpPr>
-        <p:spPr>
-          <a:xfrm>
-            <a:off x="6793992" y="6460236"/>
+          <p:cNvPr id="18" name="TextBox 17"/>
+          <p:cNvSpPr txBox="1"/>
+          <p:nvPr/>
+        </p:nvSpPr>
+        <p:spPr>
+          <a:xfrm>
+            <a:off x="7728508" y="6460236"/>
             <a:ext cx="914400" cy="219456"/>
           </a:xfrm>
           <a:prstGeom prst="rect">
@@ -5791,13 +5825,13 @@
       </p:sp>
       <p:sp>
         <p:nvSpPr>
-          <p:cNvPr id="18" name="TextBox 17"/>
-          <p:cNvSpPr txBox="1"/>
-          <p:nvPr/>
-        </p:nvSpPr>
-        <p:spPr>
-          <a:xfrm>
-            <a:off x="7680960" y="6451092"/>
+          <p:cNvPr id="19" name="TextBox 18"/>
+          <p:cNvSpPr txBox="1"/>
+          <p:nvPr/>
+        </p:nvSpPr>
+        <p:spPr>
+          <a:xfrm>
+            <a:off x="8615476" y="6451092"/>
             <a:ext cx="754380" cy="219456"/>
           </a:xfrm>
           <a:prstGeom prst="rect">
@@ -5819,21 +5853,21 @@
                 </a:solidFill>
                 <a:latin typeface="Helvetica Neue"/>
               </a:rPr>
-              <a:t>STEP 16</a:t>
-            </a:r>
-          </a:p>
-        </p:txBody>
-      </p:sp>
-      <p:sp>
-        <p:nvSpPr>
-          <p:cNvPr id="19" name="TextBox 18"/>
-          <p:cNvSpPr txBox="1"/>
-          <p:nvPr/>
-        </p:nvSpPr>
-        <p:spPr>
-          <a:xfrm>
-            <a:off x="8554212" y="6460236"/>
-            <a:ext cx="2896819" cy="219456"/>
+              <a:t>STEP 18</a:t>
+            </a:r>
+          </a:p>
+        </p:txBody>
+      </p:sp>
+      <p:sp>
+        <p:nvSpPr>
+          <p:cNvPr id="20" name="TextBox 19"/>
+          <p:cNvSpPr txBox="1"/>
+          <p:nvPr/>
+        </p:nvSpPr>
+        <p:spPr>
+          <a:xfrm>
+            <a:off x="9488728" y="6460236"/>
+            <a:ext cx="1962302" cy="219456"/>
           </a:xfrm>
           <a:prstGeom prst="rect">
             <a:avLst/>
@@ -5854,7 +5888,42 @@
                 </a:solidFill>
                 <a:latin typeface="Helvetica Neue"/>
               </a:rPr>
-              <a:t>YOUR KNOB: rewrite the descriptions</a:t>
+              <a:t>Find the weak buckets</a:t>
+            </a:r>
+          </a:p>
+        </p:txBody>
+      </p:sp>
+      <p:sp>
+        <p:nvSpPr>
+          <p:cNvPr id="21" name="TextBox 20"/>
+          <p:cNvSpPr txBox="1"/>
+          <p:nvPr/>
+        </p:nvSpPr>
+        <p:spPr>
+          <a:xfrm>
+            <a:off x="640080" y="6080760"/>
+            <a:ext cx="10881360" cy="365760"/>
+          </a:xfrm>
+          <a:prstGeom prst="rect">
+            <a:avLst/>
+          </a:prstGeom>
+          <a:noFill/>
+        </p:spPr>
+        <p:txBody>
+          <a:bodyPr wrap="square" lIns="0" rIns="0" tIns="0" bIns="0">
+            <a:spAutoFit/>
+          </a:bodyPr>
+          <a:lstStyle/>
+          <a:p>
+            <a:pPr algn="ctr"/>
+            <a:r>
+              <a:rPr sz="1500" b="0" i="1">
+                <a:solidFill>
+                  <a:srgbClr val="475569"/>
+                </a:solidFill>
+                <a:latin typeface="Helvetica Neue"/>
+              </a:rPr>
+              <a:t>When a classifier underperforms, look at your taxonomy before you look at your model.</a:t>
             </a:r>
           </a:p>
         </p:txBody>
@@ -5936,55 +6005,20 @@
           <a:p>
             <a:pPr algn="l"/>
             <a:r>
-              <a:rPr sz="2650" b="1" i="0">
+              <a:rPr sz="2900" b="1" i="0">
                 <a:solidFill>
                   <a:srgbClr val="0F172A"/>
                 </a:solidFill>
                 <a:latin typeface="Helvetica Neue"/>
               </a:rPr>
-              <a:t>An average is a bad way to run a product.</a:t>
-            </a:r>
-          </a:p>
-        </p:txBody>
-      </p:sp>
-      <p:sp>
-        <p:nvSpPr>
-          <p:cNvPr id="4" name="TextBox 3"/>
-          <p:cNvSpPr txBox="1"/>
-          <p:nvPr/>
-        </p:nvSpPr>
-        <p:spPr>
-          <a:xfrm>
-            <a:off x="640080" y="1417320"/>
-            <a:ext cx="10424160" cy="457200"/>
-          </a:xfrm>
-          <a:prstGeom prst="rect">
-            <a:avLst/>
-          </a:prstGeom>
-          <a:noFill/>
-        </p:spPr>
-        <p:txBody>
-          <a:bodyPr wrap="square" lIns="0" rIns="0" tIns="0" bIns="0">
-            <a:spAutoFit/>
-          </a:bodyPr>
-          <a:lstStyle/>
-          <a:p>
-            <a:pPr algn="l"/>
-            <a:r>
-              <a:rPr sz="1500" b="0" i="0">
-                <a:solidFill>
-                  <a:srgbClr val="475569"/>
-                </a:solidFill>
-                <a:latin typeface="Helvetica Neue"/>
-              </a:rPr>
-              <a:t>Ask WHICH tickets it gets wrong. The weak buckets are the ones whose descriptions overlap.</a:t>
-            </a:r>
-          </a:p>
-        </p:txBody>
-      </p:sp>
-      <p:sp>
-        <p:nvSpPr>
-          <p:cNvPr id="5" name="Rounded Rectangle 4"/>
+              <a:t>Confident is not the same as correct.</a:t>
+            </a:r>
+          </a:p>
+        </p:txBody>
+      </p:sp>
+      <p:sp>
+        <p:nvSpPr>
+          <p:cNvPr id="4" name="Rounded Rectangle 3"/>
           <p:cNvSpPr/>
           <p:nvPr/>
         </p:nvSpPr>
@@ -6027,7 +6061,7 @@
       </p:sp>
       <p:sp>
         <p:nvSpPr>
-          <p:cNvPr id="6" name="Rounded Rectangle 5"/>
+          <p:cNvPr id="5" name="Rounded Rectangle 4"/>
           <p:cNvSpPr/>
           <p:nvPr/>
         </p:nvSpPr>
@@ -6072,7 +6106,7 @@
       </p:sp>
       <p:sp>
         <p:nvSpPr>
-          <p:cNvPr id="7" name="TextBox 6"/>
+          <p:cNvPr id="6" name="TextBox 5"/>
           <p:cNvSpPr txBox="1"/>
           <p:nvPr/>
         </p:nvSpPr>
@@ -6107,7 +6141,7 @@
       </p:sp>
       <p:sp>
         <p:nvSpPr>
-          <p:cNvPr id="8" name="Rounded Rectangle 7"/>
+          <p:cNvPr id="7" name="Rounded Rectangle 6"/>
           <p:cNvSpPr/>
           <p:nvPr/>
         </p:nvSpPr>
@@ -6152,7 +6186,7 @@
       </p:sp>
       <p:sp>
         <p:nvSpPr>
-          <p:cNvPr id="9" name="TextBox 8"/>
+          <p:cNvPr id="8" name="TextBox 7"/>
           <p:cNvSpPr txBox="1"/>
           <p:nvPr/>
         </p:nvSpPr>
@@ -6187,7 +6221,7 @@
       </p:sp>
       <p:sp>
         <p:nvSpPr>
-          <p:cNvPr id="10" name="Rounded Rectangle 9"/>
+          <p:cNvPr id="9" name="Rounded Rectangle 8"/>
           <p:cNvSpPr/>
           <p:nvPr/>
         </p:nvSpPr>
@@ -6232,7 +6266,7 @@
       </p:sp>
       <p:sp>
         <p:nvSpPr>
-          <p:cNvPr id="11" name="TextBox 10"/>
+          <p:cNvPr id="10" name="TextBox 9"/>
           <p:cNvSpPr txBox="1"/>
           <p:nvPr/>
         </p:nvSpPr>
@@ -6267,7 +6301,7 @@
       </p:sp>
       <p:sp>
         <p:nvSpPr>
-          <p:cNvPr id="12" name="Rounded Rectangle 11"/>
+          <p:cNvPr id="11" name="Rounded Rectangle 10"/>
           <p:cNvSpPr/>
           <p:nvPr/>
         </p:nvSpPr>
@@ -6312,7 +6346,7 @@
       </p:sp>
       <p:sp>
         <p:nvSpPr>
-          <p:cNvPr id="13" name="TextBox 12"/>
+          <p:cNvPr id="12" name="TextBox 11"/>
           <p:cNvSpPr txBox="1"/>
           <p:nvPr/>
         </p:nvSpPr>
@@ -6347,7 +6381,7 @@
       </p:sp>
       <p:sp>
         <p:nvSpPr>
-          <p:cNvPr id="14" name="TextBox 13"/>
+          <p:cNvPr id="13" name="TextBox 12"/>
           <p:cNvSpPr txBox="1"/>
           <p:nvPr/>
         </p:nvSpPr>
@@ -6382,7 +6416,7 @@
       </p:sp>
       <p:pic>
         <p:nvPicPr>
-          <p:cNvPr id="15" name="Picture 14" descr="fig_recall.png"/>
+          <p:cNvPr id="14" name="Picture 13" descr="d_softmax.png"/>
           <p:cNvPicPr>
             <a:picLocks noChangeAspect="1"/>
           </p:cNvPicPr>
@@ -6396,8 +6430,8 @@
         </p:blipFill>
         <p:spPr>
           <a:xfrm>
-            <a:off x="2205165" y="2057400"/>
-            <a:ext cx="7781363" cy="3977639"/>
+            <a:off x="518007" y="2197772"/>
+            <a:ext cx="11155680" cy="3834054"/>
           </a:xfrm>
           <a:prstGeom prst="rect">
             <a:avLst/>
@@ -6406,14 +6440,14 @@
       </p:pic>
       <p:sp>
         <p:nvSpPr>
-          <p:cNvPr id="16" name="Rounded Rectangle 15"/>
+          <p:cNvPr id="15" name="Rounded Rectangle 14"/>
           <p:cNvSpPr/>
           <p:nvPr/>
         </p:nvSpPr>
         <p:spPr>
           <a:xfrm>
-            <a:off x="7573060" y="6345936"/>
-            <a:ext cx="3978554" cy="365760"/>
+            <a:off x="7172553" y="6345936"/>
+            <a:ext cx="4379061" cy="365760"/>
           </a:xfrm>
           <a:prstGeom prst="roundRect">
             <a:avLst>
@@ -6451,13 +6485,13 @@
       </p:sp>
       <p:sp>
         <p:nvSpPr>
-          <p:cNvPr id="17" name="Rounded Rectangle 16"/>
+          <p:cNvPr id="16" name="Rounded Rectangle 15"/>
           <p:cNvSpPr/>
           <p:nvPr/>
         </p:nvSpPr>
         <p:spPr>
           <a:xfrm>
-            <a:off x="8615476" y="6396228"/>
+            <a:off x="8214969" y="6396228"/>
             <a:ext cx="754380" cy="265176"/>
           </a:xfrm>
           <a:prstGeom prst="roundRect">
@@ -6496,14 +6530,49 @@
       </p:sp>
       <p:sp>
         <p:nvSpPr>
+          <p:cNvPr id="17" name="TextBox 16"/>
+          <p:cNvSpPr txBox="1"/>
+          <p:nvPr/>
+        </p:nvSpPr>
+        <p:spPr>
+          <a:xfrm>
+            <a:off x="7328001" y="6460236"/>
+            <a:ext cx="914400" cy="219456"/>
+          </a:xfrm>
+          <a:prstGeom prst="rect">
+            <a:avLst/>
+          </a:prstGeom>
+          <a:noFill/>
+        </p:spPr>
+        <p:txBody>
+          <a:bodyPr wrap="none" lIns="0" rIns="0" tIns="0" bIns="0">
+            <a:spAutoFit/>
+          </a:bodyPr>
+          <a:lstStyle/>
+          <a:p>
+            <a:pPr algn="l"/>
+            <a:r>
+              <a:rPr sz="950" b="1" i="0">
+                <a:solidFill>
+                  <a:srgbClr val="A7F3D0"/>
+                </a:solidFill>
+                <a:latin typeface="Helvetica Neue"/>
+              </a:rPr>
+              <a:t>▶ NOTEBOOK</a:t>
+            </a:r>
+          </a:p>
+        </p:txBody>
+      </p:sp>
+      <p:sp>
+        <p:nvSpPr>
           <p:cNvPr id="18" name="TextBox 17"/>
           <p:cNvSpPr txBox="1"/>
           <p:nvPr/>
         </p:nvSpPr>
         <p:spPr>
           <a:xfrm>
-            <a:off x="7728508" y="6460236"/>
-            <a:ext cx="914400" cy="219456"/>
+            <a:off x="8214969" y="6451092"/>
+            <a:ext cx="754380" cy="219456"/>
           </a:xfrm>
           <a:prstGeom prst="rect">
             <a:avLst/>
@@ -6516,120 +6585,50 @@
           </a:bodyPr>
           <a:lstStyle/>
           <a:p>
+            <a:pPr algn="ctr"/>
+            <a:r>
+              <a:rPr sz="1100" b="1" i="0">
+                <a:solidFill>
+                  <a:srgbClr val="FFFFFF"/>
+                </a:solidFill>
+                <a:latin typeface="Helvetica Neue"/>
+              </a:rPr>
+              <a:t>STEP 19</a:t>
+            </a:r>
+          </a:p>
+        </p:txBody>
+      </p:sp>
+      <p:sp>
+        <p:nvSpPr>
+          <p:cNvPr id="19" name="TextBox 18"/>
+          <p:cNvSpPr txBox="1"/>
+          <p:nvPr/>
+        </p:nvSpPr>
+        <p:spPr>
+          <a:xfrm>
+            <a:off x="9088221" y="6460236"/>
+            <a:ext cx="2362809" cy="219456"/>
+          </a:xfrm>
+          <a:prstGeom prst="rect">
+            <a:avLst/>
+          </a:prstGeom>
+          <a:noFill/>
+        </p:spPr>
+        <p:txBody>
+          <a:bodyPr wrap="none" lIns="0" rIns="0" tIns="0" bIns="0">
+            <a:spAutoFit/>
+          </a:bodyPr>
+          <a:lstStyle/>
+          <a:p>
             <a:pPr algn="l"/>
             <a:r>
-              <a:rPr sz="950" b="1" i="0">
-                <a:solidFill>
-                  <a:srgbClr val="A7F3D0"/>
-                </a:solidFill>
-                <a:latin typeface="Helvetica Neue"/>
-              </a:rPr>
-              <a:t>▶ NOTEBOOK</a:t>
-            </a:r>
-          </a:p>
-        </p:txBody>
-      </p:sp>
-      <p:sp>
-        <p:nvSpPr>
-          <p:cNvPr id="19" name="TextBox 18"/>
-          <p:cNvSpPr txBox="1"/>
-          <p:nvPr/>
-        </p:nvSpPr>
-        <p:spPr>
-          <a:xfrm>
-            <a:off x="8615476" y="6451092"/>
-            <a:ext cx="754380" cy="219456"/>
-          </a:xfrm>
-          <a:prstGeom prst="rect">
-            <a:avLst/>
-          </a:prstGeom>
-          <a:noFill/>
-        </p:spPr>
-        <p:txBody>
-          <a:bodyPr wrap="none" lIns="0" rIns="0" tIns="0" bIns="0">
-            <a:spAutoFit/>
-          </a:bodyPr>
-          <a:lstStyle/>
-          <a:p>
-            <a:pPr algn="ctr"/>
-            <a:r>
-              <a:rPr sz="1100" b="1" i="0">
+              <a:rPr sz="1000" b="1" i="0">
                 <a:solidFill>
                   <a:srgbClr val="FFFFFF"/>
                 </a:solidFill>
                 <a:latin typeface="Helvetica Neue"/>
               </a:rPr>
-              <a:t>STEP 18</a:t>
-            </a:r>
-          </a:p>
-        </p:txBody>
-      </p:sp>
-      <p:sp>
-        <p:nvSpPr>
-          <p:cNvPr id="20" name="TextBox 19"/>
-          <p:cNvSpPr txBox="1"/>
-          <p:nvPr/>
-        </p:nvSpPr>
-        <p:spPr>
-          <a:xfrm>
-            <a:off x="9488728" y="6460236"/>
-            <a:ext cx="1962302" cy="219456"/>
-          </a:xfrm>
-          <a:prstGeom prst="rect">
-            <a:avLst/>
-          </a:prstGeom>
-          <a:noFill/>
-        </p:spPr>
-        <p:txBody>
-          <a:bodyPr wrap="none" lIns="0" rIns="0" tIns="0" bIns="0">
-            <a:spAutoFit/>
-          </a:bodyPr>
-          <a:lstStyle/>
-          <a:p>
-            <a:pPr algn="l"/>
-            <a:r>
-              <a:rPr sz="1000" b="1" i="0">
-                <a:solidFill>
-                  <a:srgbClr val="FFFFFF"/>
-                </a:solidFill>
-                <a:latin typeface="Helvetica Neue"/>
-              </a:rPr>
-              <a:t>Find the weak buckets</a:t>
-            </a:r>
-          </a:p>
-        </p:txBody>
-      </p:sp>
-      <p:sp>
-        <p:nvSpPr>
-          <p:cNvPr id="21" name="TextBox 20"/>
-          <p:cNvSpPr txBox="1"/>
-          <p:nvPr/>
-        </p:nvSpPr>
-        <p:spPr>
-          <a:xfrm>
-            <a:off x="640080" y="6080760"/>
-            <a:ext cx="10881360" cy="365760"/>
-          </a:xfrm>
-          <a:prstGeom prst="rect">
-            <a:avLst/>
-          </a:prstGeom>
-          <a:noFill/>
-        </p:spPr>
-        <p:txBody>
-          <a:bodyPr wrap="square" lIns="0" rIns="0" tIns="0" bIns="0">
-            <a:spAutoFit/>
-          </a:bodyPr>
-          <a:lstStyle/>
-          <a:p>
-            <a:pPr algn="ctr"/>
-            <a:r>
-              <a:rPr sz="1500" b="0" i="1">
-                <a:solidFill>
-                  <a:srgbClr val="475569"/>
-                </a:solidFill>
-                <a:latin typeface="Helvetica Neue"/>
-              </a:rPr>
-              <a:t>When a classifier underperforms, look at your taxonomy before you look at your model.</a:t>
+              <a:t>Feed it an off-topic ticket</a:t>
             </a:r>
           </a:p>
         </p:txBody>
@@ -6711,20 +6710,55 @@
           <a:p>
             <a:pPr algn="l"/>
             <a:r>
-              <a:rPr sz="2900" b="1" i="0">
+              <a:rPr sz="2650" b="1" i="0">
                 <a:solidFill>
                   <a:srgbClr val="0F172A"/>
                 </a:solidFill>
                 <a:latin typeface="Helvetica Neue"/>
               </a:rPr>
-              <a:t>Confident is not the same as correct.</a:t>
-            </a:r>
-          </a:p>
-        </p:txBody>
-      </p:sp>
-      <p:sp>
-        <p:nvSpPr>
-          <p:cNvPr id="4" name="Rounded Rectangle 3"/>
+              <a:t>What a mistake costs decides the setting.</a:t>
+            </a:r>
+          </a:p>
+        </p:txBody>
+      </p:sp>
+      <p:sp>
+        <p:nvSpPr>
+          <p:cNvPr id="4" name="TextBox 3"/>
+          <p:cNvSpPr txBox="1"/>
+          <p:nvPr/>
+        </p:nvSpPr>
+        <p:spPr>
+          <a:xfrm>
+            <a:off x="640080" y="1417320"/>
+            <a:ext cx="10424160" cy="457200"/>
+          </a:xfrm>
+          <a:prstGeom prst="rect">
+            <a:avLst/>
+          </a:prstGeom>
+          <a:noFill/>
+        </p:spPr>
+        <p:txBody>
+          <a:bodyPr wrap="square" lIns="0" rIns="0" tIns="0" bIns="0">
+            <a:spAutoFit/>
+          </a:bodyPr>
+          <a:lstStyle/>
+          <a:p>
+            <a:pPr algn="l"/>
+            <a:r>
+              <a:rPr sz="1500" b="0" i="0">
+                <a:solidFill>
+                  <a:srgbClr val="475569"/>
+                </a:solidFill>
+                <a:latin typeface="Helvetica Neue"/>
+              </a:rPr>
+              <a:t>Same copilot, same tickets, six companies. Ask your neighbour: for the hospital, high bar or low?</a:t>
+            </a:r>
+          </a:p>
+        </p:txBody>
+      </p:sp>
+      <p:sp>
+        <p:nvSpPr>
+          <p:cNvPr id="5" name="Rounded Rectangle 4"/>
           <p:cNvSpPr/>
           <p:nvPr/>
         </p:nvSpPr>
@@ -6767,7 +6801,7 @@
       </p:sp>
       <p:sp>
         <p:nvSpPr>
-          <p:cNvPr id="5" name="Rounded Rectangle 4"/>
+          <p:cNvPr id="6" name="Rounded Rectangle 5"/>
           <p:cNvSpPr/>
           <p:nvPr/>
         </p:nvSpPr>
@@ -6812,7 +6846,7 @@
       </p:sp>
       <p:sp>
         <p:nvSpPr>
-          <p:cNvPr id="6" name="TextBox 5"/>
+          <p:cNvPr id="7" name="TextBox 6"/>
           <p:cNvSpPr txBox="1"/>
           <p:nvPr/>
         </p:nvSpPr>
@@ -6847,7 +6881,7 @@
       </p:sp>
       <p:sp>
         <p:nvSpPr>
-          <p:cNvPr id="7" name="Rounded Rectangle 6"/>
+          <p:cNvPr id="8" name="Rounded Rectangle 7"/>
           <p:cNvSpPr/>
           <p:nvPr/>
         </p:nvSpPr>
@@ -6892,7 +6926,7 @@
       </p:sp>
       <p:sp>
         <p:nvSpPr>
-          <p:cNvPr id="8" name="TextBox 7"/>
+          <p:cNvPr id="9" name="TextBox 8"/>
           <p:cNvSpPr txBox="1"/>
           <p:nvPr/>
         </p:nvSpPr>
@@ -6927,14 +6961,14 @@
       </p:sp>
       <p:sp>
         <p:nvSpPr>
-          <p:cNvPr id="9" name="Rounded Rectangle 8"/>
+          <p:cNvPr id="10" name="Rounded Rectangle 9"/>
           <p:cNvSpPr/>
           <p:nvPr/>
         </p:nvSpPr>
         <p:spPr>
           <a:xfrm>
-            <a:off x="9866376" y="438912"/>
-            <a:ext cx="329184" cy="329184"/>
+            <a:off x="9902951" y="475488"/>
+            <a:ext cx="256032" cy="256032"/>
           </a:xfrm>
           <a:prstGeom prst="roundRect">
             <a:avLst>
@@ -6972,14 +7006,14 @@
       </p:sp>
       <p:sp>
         <p:nvSpPr>
-          <p:cNvPr id="10" name="TextBox 9"/>
-          <p:cNvSpPr txBox="1"/>
-          <p:nvPr/>
-        </p:nvSpPr>
-        <p:spPr>
-          <a:xfrm>
-            <a:off x="9811511" y="475488"/>
-            <a:ext cx="438912" cy="256032"/>
+          <p:cNvPr id="11" name="TextBox 10"/>
+          <p:cNvSpPr txBox="1"/>
+          <p:nvPr/>
+        </p:nvSpPr>
+        <p:spPr>
+          <a:xfrm>
+            <a:off x="9848087" y="475488"/>
+            <a:ext cx="365760" cy="256032"/>
           </a:xfrm>
           <a:prstGeom prst="rect">
             <a:avLst/>
@@ -6994,7 +7028,7 @@
           <a:p>
             <a:pPr algn="ctr"/>
             <a:r>
-              <a:rPr sz="1300" b="1" i="0">
+              <a:rPr sz="1050" b="1" i="0">
                 <a:solidFill>
                   <a:srgbClr val="FFFFFF"/>
                 </a:solidFill>
@@ -7007,14 +7041,14 @@
       </p:sp>
       <p:sp>
         <p:nvSpPr>
-          <p:cNvPr id="11" name="Rounded Rectangle 10"/>
+          <p:cNvPr id="12" name="Rounded Rectangle 11"/>
           <p:cNvSpPr/>
           <p:nvPr/>
         </p:nvSpPr>
         <p:spPr>
           <a:xfrm>
-            <a:off x="10561319" y="475488"/>
-            <a:ext cx="256032" cy="256032"/>
+            <a:off x="10524744" y="438912"/>
+            <a:ext cx="329184" cy="329184"/>
           </a:xfrm>
           <a:prstGeom prst="roundRect">
             <a:avLst>
@@ -7022,7 +7056,7 @@
             </a:avLst>
           </a:prstGeom>
           <a:solidFill>
-            <a:srgbClr val="E9EBF0"/>
+            <a:srgbClr val="059669"/>
           </a:solidFill>
           <a:ln>
             <a:noFill/>
@@ -7052,14 +7086,14 @@
       </p:sp>
       <p:sp>
         <p:nvSpPr>
-          <p:cNvPr id="12" name="TextBox 11"/>
-          <p:cNvSpPr txBox="1"/>
-          <p:nvPr/>
-        </p:nvSpPr>
-        <p:spPr>
-          <a:xfrm>
-            <a:off x="10506455" y="475488"/>
-            <a:ext cx="365760" cy="256032"/>
+          <p:cNvPr id="13" name="TextBox 12"/>
+          <p:cNvSpPr txBox="1"/>
+          <p:nvPr/>
+        </p:nvSpPr>
+        <p:spPr>
+          <a:xfrm>
+            <a:off x="10469880" y="475488"/>
+            <a:ext cx="438912" cy="256032"/>
           </a:xfrm>
           <a:prstGeom prst="rect">
             <a:avLst/>
@@ -7074,9 +7108,9 @@
           <a:p>
             <a:pPr algn="ctr"/>
             <a:r>
-              <a:rPr sz="1050" b="1" i="0">
-                <a:solidFill>
-                  <a:srgbClr val="AEB4BF"/>
+              <a:rPr sz="1300" b="1" i="0">
+                <a:solidFill>
+                  <a:srgbClr val="FFFFFF"/>
                 </a:solidFill>
                 <a:latin typeface="Helvetica Neue"/>
               </a:rPr>
@@ -7087,7 +7121,7 @@
       </p:sp>
       <p:sp>
         <p:nvSpPr>
-          <p:cNvPr id="13" name="TextBox 12"/>
+          <p:cNvPr id="14" name="TextBox 13"/>
           <p:cNvSpPr txBox="1"/>
           <p:nvPr/>
         </p:nvSpPr>
@@ -7122,7 +7156,7 @@
       </p:sp>
       <p:pic>
         <p:nvPicPr>
-          <p:cNvPr id="14" name="Picture 13" descr="d_softmax.png"/>
+          <p:cNvPr id="15" name="Picture 14" descr="fig_game.png"/>
           <p:cNvPicPr>
             <a:picLocks noChangeAspect="1"/>
           </p:cNvPicPr>
@@ -7136,8 +7170,8 @@
         </p:blipFill>
         <p:spPr>
           <a:xfrm>
-            <a:off x="518007" y="2197772"/>
-            <a:ext cx="11155680" cy="3834054"/>
+            <a:off x="2207847" y="2011680"/>
+            <a:ext cx="7775999" cy="3931920"/>
           </a:xfrm>
           <a:prstGeom prst="rect">
             <a:avLst/>
@@ -7146,14 +7180,14 @@
       </p:pic>
       <p:sp>
         <p:nvSpPr>
-          <p:cNvPr id="15" name="Rounded Rectangle 14"/>
+          <p:cNvPr id="16" name="Rounded Rectangle 15"/>
           <p:cNvSpPr/>
           <p:nvPr/>
         </p:nvSpPr>
         <p:spPr>
           <a:xfrm>
-            <a:off x="7172553" y="6345936"/>
-            <a:ext cx="4379061" cy="365760"/>
+            <a:off x="7105802" y="6345936"/>
+            <a:ext cx="4445812" cy="365760"/>
           </a:xfrm>
           <a:prstGeom prst="roundRect">
             <a:avLst>
@@ -7191,13 +7225,13 @@
       </p:sp>
       <p:sp>
         <p:nvSpPr>
-          <p:cNvPr id="16" name="Rounded Rectangle 15"/>
+          <p:cNvPr id="17" name="Rounded Rectangle 16"/>
           <p:cNvSpPr/>
           <p:nvPr/>
         </p:nvSpPr>
         <p:spPr>
           <a:xfrm>
-            <a:off x="8214969" y="6396228"/>
+            <a:off x="8148218" y="6396228"/>
             <a:ext cx="754380" cy="265176"/>
           </a:xfrm>
           <a:prstGeom prst="roundRect">
@@ -7236,13 +7270,13 @@
       </p:sp>
       <p:sp>
         <p:nvSpPr>
-          <p:cNvPr id="17" name="TextBox 16"/>
-          <p:cNvSpPr txBox="1"/>
-          <p:nvPr/>
-        </p:nvSpPr>
-        <p:spPr>
-          <a:xfrm>
-            <a:off x="7328001" y="6460236"/>
+          <p:cNvPr id="18" name="TextBox 17"/>
+          <p:cNvSpPr txBox="1"/>
+          <p:nvPr/>
+        </p:nvSpPr>
+        <p:spPr>
+          <a:xfrm>
+            <a:off x="7261250" y="6460236"/>
             <a:ext cx="914400" cy="219456"/>
           </a:xfrm>
           <a:prstGeom prst="rect">
@@ -7271,13 +7305,13 @@
       </p:sp>
       <p:sp>
         <p:nvSpPr>
-          <p:cNvPr id="18" name="TextBox 17"/>
-          <p:cNvSpPr txBox="1"/>
-          <p:nvPr/>
-        </p:nvSpPr>
-        <p:spPr>
-          <a:xfrm>
-            <a:off x="8214969" y="6451092"/>
+          <p:cNvPr id="19" name="TextBox 18"/>
+          <p:cNvSpPr txBox="1"/>
+          <p:nvPr/>
+        </p:nvSpPr>
+        <p:spPr>
+          <a:xfrm>
+            <a:off x="8148218" y="6451092"/>
             <a:ext cx="754380" cy="219456"/>
           </a:xfrm>
           <a:prstGeom prst="rect">
@@ -7299,21 +7333,21 @@
                 </a:solidFill>
                 <a:latin typeface="Helvetica Neue"/>
               </a:rPr>
-              <a:t>STEP 19</a:t>
-            </a:r>
-          </a:p>
-        </p:txBody>
-      </p:sp>
-      <p:sp>
-        <p:nvSpPr>
-          <p:cNvPr id="19" name="TextBox 18"/>
-          <p:cNvSpPr txBox="1"/>
-          <p:nvPr/>
-        </p:nvSpPr>
-        <p:spPr>
-          <a:xfrm>
-            <a:off x="9088221" y="6460236"/>
-            <a:ext cx="2362809" cy="219456"/>
+              <a:t>STEP 21</a:t>
+            </a:r>
+          </a:p>
+        </p:txBody>
+      </p:sp>
+      <p:sp>
+        <p:nvSpPr>
+          <p:cNvPr id="20" name="TextBox 19"/>
+          <p:cNvSpPr txBox="1"/>
+          <p:nvPr/>
+        </p:nvSpPr>
+        <p:spPr>
+          <a:xfrm>
+            <a:off x="9021470" y="6460236"/>
+            <a:ext cx="2429560" cy="219456"/>
           </a:xfrm>
           <a:prstGeom prst="rect">
             <a:avLst/>
@@ -7334,7 +7368,42 @@
                 </a:solidFill>
                 <a:latin typeface="Helvetica Neue"/>
               </a:rPr>
-              <a:t>Feed it an off-topic ticket</a:t>
+              <a:t>YOUR KNOB: set the threshold</a:t>
+            </a:r>
+          </a:p>
+        </p:txBody>
+      </p:sp>
+      <p:sp>
+        <p:nvSpPr>
+          <p:cNvPr id="21" name="TextBox 20"/>
+          <p:cNvSpPr txBox="1"/>
+          <p:nvPr/>
+        </p:nvSpPr>
+        <p:spPr>
+          <a:xfrm>
+            <a:off x="640080" y="6016752"/>
+            <a:ext cx="10881360" cy="365760"/>
+          </a:xfrm>
+          <a:prstGeom prst="rect">
+            <a:avLst/>
+          </a:prstGeom>
+          <a:noFill/>
+        </p:spPr>
+        <p:txBody>
+          <a:bodyPr wrap="square" lIns="0" rIns="0" tIns="0" bIns="0">
+            <a:spAutoFit/>
+          </a:bodyPr>
+          <a:lstStyle/>
+          <a:p>
+            <a:pPr algn="ctr"/>
+            <a:r>
+              <a:rPr sz="1500" b="0" i="1">
+                <a:solidFill>
+                  <a:srgbClr val="475569"/>
+                </a:solidFill>
+                <a:latin typeface="Helvetica Neue"/>
+              </a:rPr>
+              <a:t>Accuracy is a property of the model. The right threshold is a property of the business.</a:t>
             </a:r>
           </a:p>
         </p:txBody>
@@ -7383,11 +7452,11 @@
             <a:r>
               <a:rPr sz="1250" b="1" i="0" spc="220">
                 <a:solidFill>
-                  <a:srgbClr val="059669"/>
-                </a:solidFill>
-                <a:latin typeface="Helvetica Neue"/>
-              </a:rPr>
-              <a:t>DECIDE</a:t>
+                  <a:srgbClr val="4F46E5"/>
+                </a:solidFill>
+                <a:latin typeface="Helvetica Neue"/>
+              </a:rPr>
+              <a:t>FULL CIRCLE</a:t>
             </a:r>
           </a:p>
         </p:txBody>
@@ -7401,7 +7470,7 @@
         <p:spPr>
           <a:xfrm>
             <a:off x="640080" y="758952"/>
-            <a:ext cx="7680960" cy="704088"/>
+            <a:ext cx="10972800" cy="704088"/>
           </a:xfrm>
           <a:prstGeom prst="rect">
             <a:avLst/>
@@ -7416,13 +7485,13 @@
           <a:p>
             <a:pPr algn="l"/>
             <a:r>
-              <a:rPr sz="2650" b="1" i="0">
+              <a:rPr sz="2900" b="1" i="0">
                 <a:solidFill>
                   <a:srgbClr val="0F172A"/>
                 </a:solidFill>
                 <a:latin typeface="Helvetica Neue"/>
               </a:rPr>
-              <a:t>What a mistake costs decides the setting.</a:t>
+              <a:t>What we shipped today, for $0.</a:t>
             </a:r>
           </a:p>
         </p:txBody>
@@ -7457,377 +7526,14 @@
                 </a:solidFill>
                 <a:latin typeface="Helvetica Neue"/>
               </a:rPr>
-              <a:t>Same copilot, same tickets, six companies. Ask your neighbour: for the hospital, high bar or low?</a:t>
-            </a:r>
-          </a:p>
-        </p:txBody>
-      </p:sp>
-      <p:sp>
-        <p:nvSpPr>
-          <p:cNvPr id="5" name="Rounded Rectangle 4"/>
-          <p:cNvSpPr/>
-          <p:nvPr/>
-        </p:nvSpPr>
-        <p:spPr>
-          <a:xfrm>
-            <a:off x="8705088" y="591616"/>
-            <a:ext cx="1975104" cy="23774"/>
-          </a:xfrm>
-          <a:prstGeom prst="roundRect">
-            <a:avLst/>
-          </a:prstGeom>
-          <a:solidFill>
-            <a:srgbClr val="E9EBF0"/>
-          </a:solidFill>
-          <a:ln>
-            <a:noFill/>
-          </a:ln>
-        </p:spPr>
-        <p:style>
-          <a:lnRef idx="1">
-            <a:schemeClr val="accent1"/>
-          </a:lnRef>
-          <a:fillRef idx="3">
-            <a:schemeClr val="accent1"/>
-          </a:fillRef>
-          <a:effectRef idx="2">
-            <a:schemeClr val="accent1"/>
-          </a:effectRef>
-          <a:fontRef idx="minor">
-            <a:schemeClr val="lt1"/>
-          </a:fontRef>
-        </p:style>
-        <p:txBody>
-          <a:bodyPr rtlCol="0" anchor="ctr"/>
-          <a:lstStyle/>
-          <a:p>
-            <a:pPr algn="ctr"/>
-          </a:p>
-        </p:txBody>
-      </p:sp>
-      <p:sp>
-        <p:nvSpPr>
-          <p:cNvPr id="6" name="Rounded Rectangle 5"/>
-          <p:cNvSpPr/>
-          <p:nvPr/>
-        </p:nvSpPr>
-        <p:spPr>
-          <a:xfrm>
-            <a:off x="8586215" y="475488"/>
-            <a:ext cx="256032" cy="256032"/>
-          </a:xfrm>
-          <a:prstGeom prst="roundRect">
-            <a:avLst>
-              <a:gd name="adj" fmla="val 32000"/>
-            </a:avLst>
-          </a:prstGeom>
-          <a:solidFill>
-            <a:srgbClr val="0EA5E9"/>
-          </a:solidFill>
-          <a:ln>
-            <a:noFill/>
-          </a:ln>
-        </p:spPr>
-        <p:style>
-          <a:lnRef idx="1">
-            <a:schemeClr val="accent1"/>
-          </a:lnRef>
-          <a:fillRef idx="3">
-            <a:schemeClr val="accent1"/>
-          </a:fillRef>
-          <a:effectRef idx="2">
-            <a:schemeClr val="accent1"/>
-          </a:effectRef>
-          <a:fontRef idx="minor">
-            <a:schemeClr val="lt1"/>
-          </a:fontRef>
-        </p:style>
-        <p:txBody>
-          <a:bodyPr rtlCol="0" anchor="ctr"/>
-          <a:lstStyle/>
-          <a:p>
-            <a:pPr algn="ctr"/>
-          </a:p>
-        </p:txBody>
-      </p:sp>
-      <p:sp>
-        <p:nvSpPr>
-          <p:cNvPr id="7" name="TextBox 6"/>
-          <p:cNvSpPr txBox="1"/>
-          <p:nvPr/>
-        </p:nvSpPr>
-        <p:spPr>
-          <a:xfrm>
-            <a:off x="8531351" y="475488"/>
-            <a:ext cx="365760" cy="256032"/>
-          </a:xfrm>
-          <a:prstGeom prst="rect">
-            <a:avLst/>
-          </a:prstGeom>
-          <a:noFill/>
-        </p:spPr>
-        <p:txBody>
-          <a:bodyPr wrap="square" lIns="0" rIns="0" tIns="0" bIns="0">
-            <a:spAutoFit/>
-          </a:bodyPr>
-          <a:lstStyle/>
-          <a:p>
-            <a:pPr algn="ctr"/>
-            <a:r>
-              <a:rPr sz="1050" b="1" i="0">
-                <a:solidFill>
-                  <a:srgbClr val="FFFFFF"/>
-                </a:solidFill>
-                <a:latin typeface="Helvetica Neue"/>
-              </a:rPr>
-              <a:t>1</a:t>
-            </a:r>
-          </a:p>
-        </p:txBody>
-      </p:sp>
-      <p:sp>
-        <p:nvSpPr>
-          <p:cNvPr id="8" name="Rounded Rectangle 7"/>
-          <p:cNvSpPr/>
-          <p:nvPr/>
-        </p:nvSpPr>
-        <p:spPr>
-          <a:xfrm>
-            <a:off x="9244584" y="475488"/>
-            <a:ext cx="256032" cy="256032"/>
-          </a:xfrm>
-          <a:prstGeom prst="roundRect">
-            <a:avLst>
-              <a:gd name="adj" fmla="val 32000"/>
-            </a:avLst>
-          </a:prstGeom>
-          <a:solidFill>
-            <a:srgbClr val="D97706"/>
-          </a:solidFill>
-          <a:ln>
-            <a:noFill/>
-          </a:ln>
-        </p:spPr>
-        <p:style>
-          <a:lnRef idx="1">
-            <a:schemeClr val="accent1"/>
-          </a:lnRef>
-          <a:fillRef idx="3">
-            <a:schemeClr val="accent1"/>
-          </a:fillRef>
-          <a:effectRef idx="2">
-            <a:schemeClr val="accent1"/>
-          </a:effectRef>
-          <a:fontRef idx="minor">
-            <a:schemeClr val="lt1"/>
-          </a:fontRef>
-        </p:style>
-        <p:txBody>
-          <a:bodyPr rtlCol="0" anchor="ctr"/>
-          <a:lstStyle/>
-          <a:p>
-            <a:pPr algn="ctr"/>
-          </a:p>
-        </p:txBody>
-      </p:sp>
-      <p:sp>
-        <p:nvSpPr>
-          <p:cNvPr id="9" name="TextBox 8"/>
-          <p:cNvSpPr txBox="1"/>
-          <p:nvPr/>
-        </p:nvSpPr>
-        <p:spPr>
-          <a:xfrm>
-            <a:off x="9189719" y="475488"/>
-            <a:ext cx="365760" cy="256032"/>
-          </a:xfrm>
-          <a:prstGeom prst="rect">
-            <a:avLst/>
-          </a:prstGeom>
-          <a:noFill/>
-        </p:spPr>
-        <p:txBody>
-          <a:bodyPr wrap="square" lIns="0" rIns="0" tIns="0" bIns="0">
-            <a:spAutoFit/>
-          </a:bodyPr>
-          <a:lstStyle/>
-          <a:p>
-            <a:pPr algn="ctr"/>
-            <a:r>
-              <a:rPr sz="1050" b="1" i="0">
-                <a:solidFill>
-                  <a:srgbClr val="FFFFFF"/>
-                </a:solidFill>
-                <a:latin typeface="Helvetica Neue"/>
-              </a:rPr>
-              <a:t>2</a:t>
-            </a:r>
-          </a:p>
-        </p:txBody>
-      </p:sp>
-      <p:sp>
-        <p:nvSpPr>
-          <p:cNvPr id="10" name="Rounded Rectangle 9"/>
-          <p:cNvSpPr/>
-          <p:nvPr/>
-        </p:nvSpPr>
-        <p:spPr>
-          <a:xfrm>
-            <a:off x="9902951" y="475488"/>
-            <a:ext cx="256032" cy="256032"/>
-          </a:xfrm>
-          <a:prstGeom prst="roundRect">
-            <a:avLst>
-              <a:gd name="adj" fmla="val 32000"/>
-            </a:avLst>
-          </a:prstGeom>
-          <a:solidFill>
-            <a:srgbClr val="7C3AED"/>
-          </a:solidFill>
-          <a:ln>
-            <a:noFill/>
-          </a:ln>
-        </p:spPr>
-        <p:style>
-          <a:lnRef idx="1">
-            <a:schemeClr val="accent1"/>
-          </a:lnRef>
-          <a:fillRef idx="3">
-            <a:schemeClr val="accent1"/>
-          </a:fillRef>
-          <a:effectRef idx="2">
-            <a:schemeClr val="accent1"/>
-          </a:effectRef>
-          <a:fontRef idx="minor">
-            <a:schemeClr val="lt1"/>
-          </a:fontRef>
-        </p:style>
-        <p:txBody>
-          <a:bodyPr rtlCol="0" anchor="ctr"/>
-          <a:lstStyle/>
-          <a:p>
-            <a:pPr algn="ctr"/>
-          </a:p>
-        </p:txBody>
-      </p:sp>
-      <p:sp>
-        <p:nvSpPr>
-          <p:cNvPr id="11" name="TextBox 10"/>
-          <p:cNvSpPr txBox="1"/>
-          <p:nvPr/>
-        </p:nvSpPr>
-        <p:spPr>
-          <a:xfrm>
-            <a:off x="9848087" y="475488"/>
-            <a:ext cx="365760" cy="256032"/>
-          </a:xfrm>
-          <a:prstGeom prst="rect">
-            <a:avLst/>
-          </a:prstGeom>
-          <a:noFill/>
-        </p:spPr>
-        <p:txBody>
-          <a:bodyPr wrap="square" lIns="0" rIns="0" tIns="0" bIns="0">
-            <a:spAutoFit/>
-          </a:bodyPr>
-          <a:lstStyle/>
-          <a:p>
-            <a:pPr algn="ctr"/>
-            <a:r>
-              <a:rPr sz="1050" b="1" i="0">
-                <a:solidFill>
-                  <a:srgbClr val="FFFFFF"/>
-                </a:solidFill>
-                <a:latin typeface="Helvetica Neue"/>
-              </a:rPr>
-              <a:t>3</a:t>
-            </a:r>
-          </a:p>
-        </p:txBody>
-      </p:sp>
-      <p:sp>
-        <p:nvSpPr>
-          <p:cNvPr id="12" name="Rounded Rectangle 11"/>
-          <p:cNvSpPr/>
-          <p:nvPr/>
-        </p:nvSpPr>
-        <p:spPr>
-          <a:xfrm>
-            <a:off x="10524744" y="438912"/>
-            <a:ext cx="329184" cy="329184"/>
-          </a:xfrm>
-          <a:prstGeom prst="roundRect">
-            <a:avLst>
-              <a:gd name="adj" fmla="val 32000"/>
-            </a:avLst>
-          </a:prstGeom>
-          <a:solidFill>
-            <a:srgbClr val="059669"/>
-          </a:solidFill>
-          <a:ln>
-            <a:noFill/>
-          </a:ln>
-        </p:spPr>
-        <p:style>
-          <a:lnRef idx="1">
-            <a:schemeClr val="accent1"/>
-          </a:lnRef>
-          <a:fillRef idx="3">
-            <a:schemeClr val="accent1"/>
-          </a:fillRef>
-          <a:effectRef idx="2">
-            <a:schemeClr val="accent1"/>
-          </a:effectRef>
-          <a:fontRef idx="minor">
-            <a:schemeClr val="lt1"/>
-          </a:fontRef>
-        </p:style>
-        <p:txBody>
-          <a:bodyPr rtlCol="0" anchor="ctr"/>
-          <a:lstStyle/>
-          <a:p>
-            <a:pPr algn="ctr"/>
-          </a:p>
-        </p:txBody>
-      </p:sp>
-      <p:sp>
-        <p:nvSpPr>
-          <p:cNvPr id="13" name="TextBox 12"/>
-          <p:cNvSpPr txBox="1"/>
-          <p:nvPr/>
-        </p:nvSpPr>
-        <p:spPr>
-          <a:xfrm>
-            <a:off x="10469880" y="475488"/>
-            <a:ext cx="438912" cy="256032"/>
-          </a:xfrm>
-          <a:prstGeom prst="rect">
-            <a:avLst/>
-          </a:prstGeom>
-          <a:noFill/>
-        </p:spPr>
-        <p:txBody>
-          <a:bodyPr wrap="square" lIns="0" rIns="0" tIns="0" bIns="0">
-            <a:spAutoFit/>
-          </a:bodyPr>
-          <a:lstStyle/>
-          <a:p>
-            <a:pPr algn="ctr"/>
-            <a:r>
-              <a:rPr sz="1300" b="1" i="0">
-                <a:solidFill>
-                  <a:srgbClr val="FFFFFF"/>
-                </a:solidFill>
-                <a:latin typeface="Helvetica Neue"/>
-              </a:rPr>
-              <a:t>4</a:t>
-            </a:r>
-          </a:p>
-        </p:txBody>
-      </p:sp>
-      <p:sp>
-        <p:nvSpPr>
-          <p:cNvPr id="14" name="TextBox 13"/>
+              <a:t>No training data. No training run. No GPU bill. One afternoon.</a:t>
+            </a:r>
+          </a:p>
+        </p:txBody>
+      </p:sp>
+      <p:sp>
+        <p:nvSpPr>
+          <p:cNvPr id="5" name="TextBox 4"/>
           <p:cNvSpPr txBox="1"/>
           <p:nvPr/>
         </p:nvSpPr>
@@ -7862,7 +7568,7 @@
       </p:sp>
       <p:pic>
         <p:nvPicPr>
-          <p:cNvPr id="15" name="Picture 14" descr="fig_game.png"/>
+          <p:cNvPr id="6" name="Picture 5" descr="d_shipped.png"/>
           <p:cNvPicPr>
             <a:picLocks noChangeAspect="1"/>
           </p:cNvPicPr>
@@ -7876,8 +7582,8 @@
         </p:blipFill>
         <p:spPr>
           <a:xfrm>
-            <a:off x="2207847" y="2011680"/>
-            <a:ext cx="7775999" cy="3931920"/>
+            <a:off x="518007" y="2943310"/>
+            <a:ext cx="11155680" cy="1885778"/>
           </a:xfrm>
           <a:prstGeom prst="rect">
             <a:avLst/>
@@ -7886,230 +7592,35 @@
       </p:pic>
       <p:sp>
         <p:nvSpPr>
-          <p:cNvPr id="16" name="Rounded Rectangle 15"/>
-          <p:cNvSpPr/>
-          <p:nvPr/>
-        </p:nvSpPr>
-        <p:spPr>
-          <a:xfrm>
-            <a:off x="7105802" y="6345936"/>
-            <a:ext cx="4445812" cy="365760"/>
-          </a:xfrm>
-          <a:prstGeom prst="roundRect">
-            <a:avLst>
-              <a:gd name="adj" fmla="val 44000"/>
-            </a:avLst>
-          </a:prstGeom>
-          <a:solidFill>
-            <a:srgbClr val="059669"/>
-          </a:solidFill>
-          <a:ln>
-            <a:noFill/>
-          </a:ln>
-        </p:spPr>
-        <p:style>
-          <a:lnRef idx="1">
-            <a:schemeClr val="accent1"/>
-          </a:lnRef>
-          <a:fillRef idx="3">
-            <a:schemeClr val="accent1"/>
-          </a:fillRef>
-          <a:effectRef idx="2">
-            <a:schemeClr val="accent1"/>
-          </a:effectRef>
-          <a:fontRef idx="minor">
-            <a:schemeClr val="lt1"/>
-          </a:fontRef>
-        </p:style>
-        <p:txBody>
-          <a:bodyPr rtlCol="0" anchor="ctr"/>
+          <p:cNvPr id="7" name="TextBox 6"/>
+          <p:cNvSpPr txBox="1"/>
+          <p:nvPr/>
+        </p:nvSpPr>
+        <p:spPr>
+          <a:xfrm>
+            <a:off x="640080" y="5760720"/>
+            <a:ext cx="10881360" cy="457200"/>
+          </a:xfrm>
+          <a:prstGeom prst="rect">
+            <a:avLst/>
+          </a:prstGeom>
+          <a:noFill/>
+        </p:spPr>
+        <p:txBody>
+          <a:bodyPr wrap="square" lIns="0" rIns="0" tIns="0" bIns="0">
+            <a:spAutoFit/>
+          </a:bodyPr>
           <a:lstStyle/>
           <a:p>
             <a:pPr algn="ctr"/>
-          </a:p>
-        </p:txBody>
-      </p:sp>
-      <p:sp>
-        <p:nvSpPr>
-          <p:cNvPr id="17" name="Rounded Rectangle 16"/>
-          <p:cNvSpPr/>
-          <p:nvPr/>
-        </p:nvSpPr>
-        <p:spPr>
-          <a:xfrm>
-            <a:off x="8148218" y="6396228"/>
-            <a:ext cx="754380" cy="265176"/>
-          </a:xfrm>
-          <a:prstGeom prst="roundRect">
-            <a:avLst>
-              <a:gd name="adj" fmla="val 44000"/>
-            </a:avLst>
-          </a:prstGeom>
-          <a:solidFill>
-            <a:srgbClr val="064E3B"/>
-          </a:solidFill>
-          <a:ln>
-            <a:noFill/>
-          </a:ln>
-        </p:spPr>
-        <p:style>
-          <a:lnRef idx="1">
-            <a:schemeClr val="accent1"/>
-          </a:lnRef>
-          <a:fillRef idx="3">
-            <a:schemeClr val="accent1"/>
-          </a:fillRef>
-          <a:effectRef idx="2">
-            <a:schemeClr val="accent1"/>
-          </a:effectRef>
-          <a:fontRef idx="minor">
-            <a:schemeClr val="lt1"/>
-          </a:fontRef>
-        </p:style>
-        <p:txBody>
-          <a:bodyPr rtlCol="0" anchor="ctr"/>
-          <a:lstStyle/>
-          <a:p>
-            <a:pPr algn="ctr"/>
-          </a:p>
-        </p:txBody>
-      </p:sp>
-      <p:sp>
-        <p:nvSpPr>
-          <p:cNvPr id="18" name="TextBox 17"/>
-          <p:cNvSpPr txBox="1"/>
-          <p:nvPr/>
-        </p:nvSpPr>
-        <p:spPr>
-          <a:xfrm>
-            <a:off x="7261250" y="6460236"/>
-            <a:ext cx="914400" cy="219456"/>
-          </a:xfrm>
-          <a:prstGeom prst="rect">
-            <a:avLst/>
-          </a:prstGeom>
-          <a:noFill/>
-        </p:spPr>
-        <p:txBody>
-          <a:bodyPr wrap="none" lIns="0" rIns="0" tIns="0" bIns="0">
-            <a:spAutoFit/>
-          </a:bodyPr>
-          <a:lstStyle/>
-          <a:p>
-            <a:pPr algn="l"/>
-            <a:r>
-              <a:rPr sz="950" b="1" i="0">
-                <a:solidFill>
-                  <a:srgbClr val="A7F3D0"/>
-                </a:solidFill>
-                <a:latin typeface="Helvetica Neue"/>
-              </a:rPr>
-              <a:t>▶ NOTEBOOK</a:t>
-            </a:r>
-          </a:p>
-        </p:txBody>
-      </p:sp>
-      <p:sp>
-        <p:nvSpPr>
-          <p:cNvPr id="19" name="TextBox 18"/>
-          <p:cNvSpPr txBox="1"/>
-          <p:nvPr/>
-        </p:nvSpPr>
-        <p:spPr>
-          <a:xfrm>
-            <a:off x="8148218" y="6451092"/>
-            <a:ext cx="754380" cy="219456"/>
-          </a:xfrm>
-          <a:prstGeom prst="rect">
-            <a:avLst/>
-          </a:prstGeom>
-          <a:noFill/>
-        </p:spPr>
-        <p:txBody>
-          <a:bodyPr wrap="none" lIns="0" rIns="0" tIns="0" bIns="0">
-            <a:spAutoFit/>
-          </a:bodyPr>
-          <a:lstStyle/>
-          <a:p>
-            <a:pPr algn="ctr"/>
-            <a:r>
-              <a:rPr sz="1100" b="1" i="0">
-                <a:solidFill>
-                  <a:srgbClr val="FFFFFF"/>
-                </a:solidFill>
-                <a:latin typeface="Helvetica Neue"/>
-              </a:rPr>
-              <a:t>STEP 21</a:t>
-            </a:r>
-          </a:p>
-        </p:txBody>
-      </p:sp>
-      <p:sp>
-        <p:nvSpPr>
-          <p:cNvPr id="20" name="TextBox 19"/>
-          <p:cNvSpPr txBox="1"/>
-          <p:nvPr/>
-        </p:nvSpPr>
-        <p:spPr>
-          <a:xfrm>
-            <a:off x="9021470" y="6460236"/>
-            <a:ext cx="2429560" cy="219456"/>
-          </a:xfrm>
-          <a:prstGeom prst="rect">
-            <a:avLst/>
-          </a:prstGeom>
-          <a:noFill/>
-        </p:spPr>
-        <p:txBody>
-          <a:bodyPr wrap="none" lIns="0" rIns="0" tIns="0" bIns="0">
-            <a:spAutoFit/>
-          </a:bodyPr>
-          <a:lstStyle/>
-          <a:p>
-            <a:pPr algn="l"/>
-            <a:r>
-              <a:rPr sz="1000" b="1" i="0">
-                <a:solidFill>
-                  <a:srgbClr val="FFFFFF"/>
-                </a:solidFill>
-                <a:latin typeface="Helvetica Neue"/>
-              </a:rPr>
-              <a:t>YOUR KNOB: set the threshold</a:t>
-            </a:r>
-          </a:p>
-        </p:txBody>
-      </p:sp>
-      <p:sp>
-        <p:nvSpPr>
-          <p:cNvPr id="21" name="TextBox 20"/>
-          <p:cNvSpPr txBox="1"/>
-          <p:nvPr/>
-        </p:nvSpPr>
-        <p:spPr>
-          <a:xfrm>
-            <a:off x="640080" y="6016752"/>
-            <a:ext cx="10881360" cy="365760"/>
-          </a:xfrm>
-          <a:prstGeom prst="rect">
-            <a:avLst/>
-          </a:prstGeom>
-          <a:noFill/>
-        </p:spPr>
-        <p:txBody>
-          <a:bodyPr wrap="square" lIns="0" rIns="0" tIns="0" bIns="0">
-            <a:spAutoFit/>
-          </a:bodyPr>
-          <a:lstStyle/>
-          <a:p>
-            <a:pPr algn="ctr"/>
-            <a:r>
-              <a:rPr sz="1500" b="0" i="1">
-                <a:solidFill>
-                  <a:srgbClr val="475569"/>
-                </a:solidFill>
-                <a:latin typeface="Helvetica Neue"/>
-              </a:rPr>
-              <a:t>Accuracy is a property of the model. The right threshold is a property of the business.</a:t>
+            <a:r>
+              <a:rPr sz="1600" b="0" i="1">
+                <a:solidFill>
+                  <a:srgbClr val="0F172A"/>
+                </a:solidFill>
+                <a:latin typeface="Helvetica Neue"/>
+              </a:rPr>
+              <a:t>Someone else already spent millions teaching a model to read English. Your job is to point it at your problem, cheaply, and know where it breaks.</a:t>
             </a:r>
           </a:p>
         </p:txBody>
@@ -8162,7 +7673,7 @@
                 </a:solidFill>
                 <a:latin typeface="Helvetica Neue"/>
               </a:rPr>
-              <a:t>FULL CIRCLE</a:t>
+              <a:t>BEFORE WE OPEN IT UP</a:t>
             </a:r>
           </a:p>
         </p:txBody>
@@ -8197,7 +7708,7 @@
                 </a:solidFill>
                 <a:latin typeface="Helvetica Neue"/>
               </a:rPr>
-              <a:t>What we shipped today, for $0.</a:t>
+              <a:t>What you actually saw tonight.</a:t>
             </a:r>
           </a:p>
         </p:txBody>
@@ -8232,7 +7743,7 @@
                 </a:solidFill>
                 <a:latin typeface="Helvetica Neue"/>
               </a:rPr>
-              <a:t>No training data. No training run. No GPU bill. One afternoon.</a:t>
+              <a:t>Hold both columns in your head. We are about to need them.</a:t>
             </a:r>
           </a:p>
         </p:txBody>
@@ -8274,7 +7785,7 @@
       </p:sp>
       <p:pic>
         <p:nvPicPr>
-          <p:cNvPr id="6" name="Picture 5" descr="d_shipped.png"/>
+          <p:cNvPr id="6" name="Picture 5" descr="d_saw.png"/>
           <p:cNvPicPr>
             <a:picLocks noChangeAspect="1"/>
           </p:cNvPicPr>
@@ -8288,49 +7799,14 @@
         </p:blipFill>
         <p:spPr>
           <a:xfrm>
-            <a:off x="518007" y="2943310"/>
-            <a:ext cx="11155680" cy="1885778"/>
+            <a:off x="518007" y="3252244"/>
+            <a:ext cx="11155680" cy="1862271"/>
           </a:xfrm>
           <a:prstGeom prst="rect">
             <a:avLst/>
           </a:prstGeom>
         </p:spPr>
       </p:pic>
-      <p:sp>
-        <p:nvSpPr>
-          <p:cNvPr id="7" name="TextBox 6"/>
-          <p:cNvSpPr txBox="1"/>
-          <p:nvPr/>
-        </p:nvSpPr>
-        <p:spPr>
-          <a:xfrm>
-            <a:off x="640080" y="5760720"/>
-            <a:ext cx="10881360" cy="457200"/>
-          </a:xfrm>
-          <a:prstGeom prst="rect">
-            <a:avLst/>
-          </a:prstGeom>
-          <a:noFill/>
-        </p:spPr>
-        <p:txBody>
-          <a:bodyPr wrap="square" lIns="0" rIns="0" tIns="0" bIns="0">
-            <a:spAutoFit/>
-          </a:bodyPr>
-          <a:lstStyle/>
-          <a:p>
-            <a:pPr algn="ctr"/>
-            <a:r>
-              <a:rPr sz="1600" b="0" i="1">
-                <a:solidFill>
-                  <a:srgbClr val="0F172A"/>
-                </a:solidFill>
-                <a:latin typeface="Helvetica Neue"/>
-              </a:rPr>
-              <a:t>Someone else already spent millions teaching a model to read English. Your job is to point it at your problem, cheaply, and know where it breaks.</a:t>
-            </a:r>
-          </a:p>
-        </p:txBody>
-      </p:sp>
     </p:spTree>
   </p:cSld>
   <p:clrMapOvr>
@@ -8375,11 +7851,11 @@
             <a:r>
               <a:rPr sz="1250" b="1" i="0" spc="220">
                 <a:solidFill>
-                  <a:srgbClr val="4F46E5"/>
-                </a:solidFill>
-                <a:latin typeface="Helvetica Neue"/>
-              </a:rPr>
-              <a:t>BEFORE WE OPEN IT UP</a:t>
+                  <a:srgbClr val="E11D48"/>
+                </a:solidFill>
+                <a:latin typeface="Helvetica Neue"/>
+              </a:rPr>
+              <a:t>DISCUSSION</a:t>
             </a:r>
           </a:p>
         </p:txBody>
@@ -8414,7 +7890,7 @@
                 </a:solidFill>
                 <a:latin typeface="Helvetica Neue"/>
               </a:rPr>
-              <a:t>What you actually saw tonight.</a:t>
+              <a:t>Last week, a model did this on its own.</a:t>
             </a:r>
           </a:p>
         </p:txBody>
@@ -8449,7 +7925,7 @@
                 </a:solidFill>
                 <a:latin typeface="Helvetica Neue"/>
               </a:rPr>
-              <a:t>Hold both columns in your head. We are about to need them.</a:t>
+              <a:t>Not a thought experiment. This happened between the 16th and the 21st of July, six days ago.</a:t>
             </a:r>
           </a:p>
         </p:txBody>
@@ -8491,7 +7967,7 @@
       </p:sp>
       <p:pic>
         <p:nvPicPr>
-          <p:cNvPr id="6" name="Picture 5" descr="d_saw.png"/>
+          <p:cNvPr id="6" name="Picture 5" descr="d_incident.png"/>
           <p:cNvPicPr>
             <a:picLocks noChangeAspect="1"/>
           </p:cNvPicPr>
@@ -8505,14 +7981,49 @@
         </p:blipFill>
         <p:spPr>
           <a:xfrm>
-            <a:off x="518007" y="3252244"/>
-            <a:ext cx="11155680" cy="1862271"/>
+            <a:off x="518007" y="2056061"/>
+            <a:ext cx="11155680" cy="3934597"/>
           </a:xfrm>
           <a:prstGeom prst="rect">
             <a:avLst/>
           </a:prstGeom>
         </p:spPr>
       </p:pic>
+      <p:sp>
+        <p:nvSpPr>
+          <p:cNvPr id="7" name="TextBox 6"/>
+          <p:cNvSpPr txBox="1"/>
+          <p:nvPr/>
+        </p:nvSpPr>
+        <p:spPr>
+          <a:xfrm>
+            <a:off x="640080" y="6108192"/>
+            <a:ext cx="10881360" cy="365760"/>
+          </a:xfrm>
+          <a:prstGeom prst="rect">
+            <a:avLst/>
+          </a:prstGeom>
+          <a:noFill/>
+        </p:spPr>
+        <p:txBody>
+          <a:bodyPr wrap="square" lIns="0" rIns="0" tIns="0" bIns="0">
+            <a:spAutoFit/>
+          </a:bodyPr>
+          <a:lstStyle/>
+          <a:p>
+            <a:pPr algn="ctr"/>
+            <a:r>
+              <a:rPr sz="1100" b="0" i="0">
+                <a:solidFill>
+                  <a:srgbClr val="BCC1CC"/>
+                </a:solidFill>
+                <a:latin typeface="Helvetica Neue"/>
+              </a:rPr>
+              <a:t>Sources: OpenAI incident report - Hugging Face disclosure - CNBC, Axios, The Hacker News, 21-22 July 2026</a:t>
+            </a:r>
+          </a:p>
+        </p:txBody>
+      </p:sp>
     </p:spTree>
   </p:cSld>
   <p:clrMapOvr>
@@ -8522,223 +8033,6 @@
 </file>
 
 <file path=ppt/slides/slide18.xml><?xml version="1.0" encoding="utf-8"?>
-<p:sld xmlns:a="http://schemas.openxmlformats.org/drawingml/2006/main" xmlns:p="http://schemas.openxmlformats.org/presentationml/2006/main" xmlns:r="http://schemas.openxmlformats.org/officeDocument/2006/relationships">
-  <p:cSld>
-    <p:spTree>
-      <p:nvGrpSpPr>
-        <p:cNvPr id="1" name=""/>
-        <p:cNvGrpSpPr/>
-        <p:nvPr/>
-      </p:nvGrpSpPr>
-      <p:grpSpPr/>
-      <p:sp>
-        <p:nvSpPr>
-          <p:cNvPr id="2" name="TextBox 1"/>
-          <p:cNvSpPr txBox="1"/>
-          <p:nvPr/>
-        </p:nvSpPr>
-        <p:spPr>
-          <a:xfrm>
-            <a:off x="640080" y="457200"/>
-            <a:ext cx="6766560" cy="274320"/>
-          </a:xfrm>
-          <a:prstGeom prst="rect">
-            <a:avLst/>
-          </a:prstGeom>
-          <a:noFill/>
-        </p:spPr>
-        <p:txBody>
-          <a:bodyPr wrap="square" lIns="0" rIns="0" tIns="0" bIns="0">
-            <a:spAutoFit/>
-          </a:bodyPr>
-          <a:lstStyle/>
-          <a:p>
-            <a:pPr algn="l"/>
-            <a:r>
-              <a:rPr sz="1250" b="1" i="0" spc="220">
-                <a:solidFill>
-                  <a:srgbClr val="E11D48"/>
-                </a:solidFill>
-                <a:latin typeface="Helvetica Neue"/>
-              </a:rPr>
-              <a:t>DISCUSSION</a:t>
-            </a:r>
-          </a:p>
-        </p:txBody>
-      </p:sp>
-      <p:sp>
-        <p:nvSpPr>
-          <p:cNvPr id="3" name="TextBox 2"/>
-          <p:cNvSpPr txBox="1"/>
-          <p:nvPr/>
-        </p:nvSpPr>
-        <p:spPr>
-          <a:xfrm>
-            <a:off x="640080" y="758952"/>
-            <a:ext cx="10972800" cy="704088"/>
-          </a:xfrm>
-          <a:prstGeom prst="rect">
-            <a:avLst/>
-          </a:prstGeom>
-          <a:noFill/>
-        </p:spPr>
-        <p:txBody>
-          <a:bodyPr wrap="square" lIns="0" rIns="0" tIns="0" bIns="0">
-            <a:spAutoFit/>
-          </a:bodyPr>
-          <a:lstStyle/>
-          <a:p>
-            <a:pPr algn="l"/>
-            <a:r>
-              <a:rPr sz="2900" b="1" i="0">
-                <a:solidFill>
-                  <a:srgbClr val="0F172A"/>
-                </a:solidFill>
-                <a:latin typeface="Helvetica Neue"/>
-              </a:rPr>
-              <a:t>Last week, a model did this on its own.</a:t>
-            </a:r>
-          </a:p>
-        </p:txBody>
-      </p:sp>
-      <p:sp>
-        <p:nvSpPr>
-          <p:cNvPr id="4" name="TextBox 3"/>
-          <p:cNvSpPr txBox="1"/>
-          <p:nvPr/>
-        </p:nvSpPr>
-        <p:spPr>
-          <a:xfrm>
-            <a:off x="640080" y="1417320"/>
-            <a:ext cx="10424160" cy="457200"/>
-          </a:xfrm>
-          <a:prstGeom prst="rect">
-            <a:avLst/>
-          </a:prstGeom>
-          <a:noFill/>
-        </p:spPr>
-        <p:txBody>
-          <a:bodyPr wrap="square" lIns="0" rIns="0" tIns="0" bIns="0">
-            <a:spAutoFit/>
-          </a:bodyPr>
-          <a:lstStyle/>
-          <a:p>
-            <a:pPr algn="l"/>
-            <a:r>
-              <a:rPr sz="1500" b="0" i="0">
-                <a:solidFill>
-                  <a:srgbClr val="475569"/>
-                </a:solidFill>
-                <a:latin typeface="Helvetica Neue"/>
-              </a:rPr>
-              <a:t>Not a thought experiment. This happened between the 16th and the 21st of July, six days ago.</a:t>
-            </a:r>
-          </a:p>
-        </p:txBody>
-      </p:sp>
-      <p:sp>
-        <p:nvSpPr>
-          <p:cNvPr id="5" name="TextBox 4"/>
-          <p:cNvSpPr txBox="1"/>
-          <p:nvPr/>
-        </p:nvSpPr>
-        <p:spPr>
-          <a:xfrm>
-            <a:off x="640080" y="6492240"/>
-            <a:ext cx="8229600" cy="274320"/>
-          </a:xfrm>
-          <a:prstGeom prst="rect">
-            <a:avLst/>
-          </a:prstGeom>
-          <a:noFill/>
-        </p:spPr>
-        <p:txBody>
-          <a:bodyPr wrap="square" lIns="0" rIns="0" tIns="0" bIns="0">
-            <a:spAutoFit/>
-          </a:bodyPr>
-          <a:lstStyle/>
-          <a:p>
-            <a:pPr algn="l"/>
-            <a:r>
-              <a:rPr sz="900" b="0" i="0">
-                <a:solidFill>
-                  <a:srgbClr val="BCC1CC"/>
-                </a:solidFill>
-                <a:latin typeface="Helvetica Neue"/>
-              </a:rPr>
-              <a:t>ISBA 2411 · Natural Language Processing &amp; AI · Summer 2026</a:t>
-            </a:r>
-          </a:p>
-        </p:txBody>
-      </p:sp>
-      <p:pic>
-        <p:nvPicPr>
-          <p:cNvPr id="6" name="Picture 5" descr="d_incident.png"/>
-          <p:cNvPicPr>
-            <a:picLocks noChangeAspect="1"/>
-          </p:cNvPicPr>
-          <p:nvPr/>
-        </p:nvPicPr>
-        <p:blipFill>
-          <a:blip r:embed="rId2"/>
-          <a:stretch>
-            <a:fillRect/>
-          </a:stretch>
-        </p:blipFill>
-        <p:spPr>
-          <a:xfrm>
-            <a:off x="518007" y="2056061"/>
-            <a:ext cx="11155680" cy="3934597"/>
-          </a:xfrm>
-          <a:prstGeom prst="rect">
-            <a:avLst/>
-          </a:prstGeom>
-        </p:spPr>
-      </p:pic>
-      <p:sp>
-        <p:nvSpPr>
-          <p:cNvPr id="7" name="TextBox 6"/>
-          <p:cNvSpPr txBox="1"/>
-          <p:nvPr/>
-        </p:nvSpPr>
-        <p:spPr>
-          <a:xfrm>
-            <a:off x="640080" y="6108192"/>
-            <a:ext cx="10881360" cy="365760"/>
-          </a:xfrm>
-          <a:prstGeom prst="rect">
-            <a:avLst/>
-          </a:prstGeom>
-          <a:noFill/>
-        </p:spPr>
-        <p:txBody>
-          <a:bodyPr wrap="square" lIns="0" rIns="0" tIns="0" bIns="0">
-            <a:spAutoFit/>
-          </a:bodyPr>
-          <a:lstStyle/>
-          <a:p>
-            <a:pPr algn="ctr"/>
-            <a:r>
-              <a:rPr sz="1100" b="0" i="0">
-                <a:solidFill>
-                  <a:srgbClr val="BCC1CC"/>
-                </a:solidFill>
-                <a:latin typeface="Helvetica Neue"/>
-              </a:rPr>
-              <a:t>Sources: OpenAI incident report - Hugging Face disclosure - CNBC, Axios, The Hacker News, 21-22 July 2026</a:t>
-            </a:r>
-          </a:p>
-        </p:txBody>
-      </p:sp>
-    </p:spTree>
-  </p:cSld>
-  <p:clrMapOvr>
-    <a:masterClrMapping/>
-  </p:clrMapOvr>
-</p:sld>
-</file>
-
-<file path=ppt/slides/slide19.xml><?xml version="1.0" encoding="utf-8"?>
 <p:sld xmlns:a="http://schemas.openxmlformats.org/drawingml/2006/main" xmlns:p="http://schemas.openxmlformats.org/presentationml/2006/main" xmlns:r="http://schemas.openxmlformats.org/officeDocument/2006/relationships">
   <p:cSld>
     <p:spTree>
@@ -11466,13 +10760,13 @@
           <a:p>
             <a:pPr algn="l"/>
             <a:r>
-              <a:rPr sz="2900" b="1" i="0">
+              <a:rPr sz="2300" b="1" i="0">
                 <a:solidFill>
                   <a:srgbClr val="0F172A"/>
                 </a:solidFill>
                 <a:latin typeface="Helvetica Neue"/>
               </a:rPr>
-              <a:t>Structure was already in the text.</a:t>
+              <a:t>One gotcha before you promise anyone this works.</a:t>
             </a:r>
           </a:p>
         </p:txBody>
@@ -11507,7 +10801,7 @@
                 </a:solidFill>
                 <a:latin typeface="Helvetica Neue"/>
               </a:rPr>
-              <a:t>Nobody sorted these. Plot the tickets and the neighbourhoods appear on their own.</a:t>
+              <a:t>The model turns text into numbers by splitting it into chunks. Watch what that does to your product vocabulary.</a:t>
             </a:r>
           </a:p>
         </p:txBody>
@@ -11912,7 +11206,7 @@
       </p:sp>
       <p:pic>
         <p:nvPicPr>
-          <p:cNvPr id="15" name="Picture 14" descr="fig_map.png"/>
+          <p:cNvPr id="15" name="Picture 14" descr="d_jargon.png"/>
           <p:cNvPicPr>
             <a:picLocks noChangeAspect="1"/>
           </p:cNvPicPr>
@@ -11926,8 +11220,8 @@
         </p:blipFill>
         <p:spPr>
           <a:xfrm>
-            <a:off x="3290383" y="1965960"/>
-            <a:ext cx="5610928" cy="4251960"/>
+            <a:off x="518007" y="2436196"/>
+            <a:ext cx="11155680" cy="3311487"/>
           </a:xfrm>
           <a:prstGeom prst="rect">
             <a:avLst/>
@@ -11942,8 +11236,8 @@
         </p:nvSpPr>
         <p:spPr>
           <a:xfrm>
-            <a:off x="7773314" y="6345936"/>
-            <a:ext cx="3778300" cy="365760"/>
+            <a:off x="7172553" y="6345936"/>
+            <a:ext cx="4379061" cy="365760"/>
           </a:xfrm>
           <a:prstGeom prst="roundRect">
             <a:avLst>
@@ -11987,7 +11281,7 @@
         </p:nvSpPr>
         <p:spPr>
           <a:xfrm>
-            <a:off x="8815730" y="6396228"/>
+            <a:off x="8214969" y="6396228"/>
             <a:ext cx="685800" cy="265176"/>
           </a:xfrm>
           <a:prstGeom prst="roundRect">
@@ -12032,7 +11326,7 @@
         </p:nvSpPr>
         <p:spPr>
           <a:xfrm>
-            <a:off x="7928762" y="6460236"/>
+            <a:off x="7328001" y="6460236"/>
             <a:ext cx="914400" cy="219456"/>
           </a:xfrm>
           <a:prstGeom prst="rect">
@@ -12067,7 +11361,7 @@
         </p:nvSpPr>
         <p:spPr>
           <a:xfrm>
-            <a:off x="8815730" y="6451092"/>
+            <a:off x="8214969" y="6451092"/>
             <a:ext cx="685800" cy="219456"/>
           </a:xfrm>
           <a:prstGeom prst="rect">
@@ -12089,7 +11383,7 @@
                 </a:solidFill>
                 <a:latin typeface="Helvetica Neue"/>
               </a:rPr>
-              <a:t>STEP 5</a:t>
+              <a:t>STEP 7</a:t>
             </a:r>
           </a:p>
         </p:txBody>
@@ -12102,8 +11396,8 @@
         </p:nvSpPr>
         <p:spPr>
           <a:xfrm>
-            <a:off x="9620402" y="6460236"/>
-            <a:ext cx="1830628" cy="219456"/>
+            <a:off x="9019641" y="6460236"/>
+            <a:ext cx="2431389" cy="219456"/>
           </a:xfrm>
           <a:prstGeom prst="rect">
             <a:avLst/>
@@ -12124,7 +11418,7 @@
                 </a:solidFill>
                 <a:latin typeface="Helvetica Neue"/>
               </a:rPr>
-              <a:t>Map the whole inbox</a:t>
+              <a:t>Test your product vocabulary</a:t>
             </a:r>
           </a:p>
         </p:txBody>
@@ -12206,13 +11500,13 @@
           <a:p>
             <a:pPr algn="l"/>
             <a:r>
-              <a:rPr sz="2300" b="1" i="0">
+              <a:rPr sz="2900" b="1" i="0">
                 <a:solidFill>
                   <a:srgbClr val="0F172A"/>
                 </a:solidFill>
                 <a:latin typeface="Helvetica Neue"/>
               </a:rPr>
-              <a:t>One gotcha before you promise anyone this works.</a:t>
+              <a:t>How the meaning gets in there.</a:t>
             </a:r>
           </a:p>
         </p:txBody>
@@ -12247,7 +11541,7 @@
                 </a:solidFill>
                 <a:latin typeface="Helvetica Neue"/>
               </a:rPr>
-              <a:t>The model turns text into numbers by splitting it into chunks. Watch what that does to your product vocabulary.</a:t>
+              <a:t>We are going to watch the first eight minutes of this together, then come back to this picture.</a:t>
             </a:r>
           </a:p>
         </p:txBody>
@@ -12652,7 +11946,7 @@
       </p:sp>
       <p:pic>
         <p:nvPicPr>
-          <p:cNvPr id="15" name="Picture 14" descr="d_jargon.png"/>
+          <p:cNvPr id="15" name="Picture 14" descr="fig_blockflow.png"/>
           <p:cNvPicPr>
             <a:picLocks noChangeAspect="1"/>
           </p:cNvPicPr>
@@ -12666,8 +11960,8 @@
         </p:blipFill>
         <p:spPr>
           <a:xfrm>
-            <a:off x="518007" y="2436196"/>
-            <a:ext cx="11155680" cy="3311487"/>
+            <a:off x="956034" y="1906524"/>
+            <a:ext cx="10279625" cy="4041648"/>
           </a:xfrm>
           <a:prstGeom prst="rect">
             <a:avLst/>
@@ -12676,14 +11970,59 @@
       </p:pic>
       <p:sp>
         <p:nvSpPr>
-          <p:cNvPr id="16" name="Rounded Rectangle 15"/>
+          <p:cNvPr id="16" name="TextBox 15"/>
+          <p:cNvSpPr txBox="1"/>
+          <p:nvPr/>
+        </p:nvSpPr>
+        <p:spPr>
+          <a:xfrm>
+            <a:off x="640080" y="6053328"/>
+            <a:ext cx="10881360" cy="310896"/>
+          </a:xfrm>
+          <a:prstGeom prst="rect">
+            <a:avLst/>
+          </a:prstGeom>
+          <a:noFill/>
+        </p:spPr>
+        <p:txBody>
+          <a:bodyPr wrap="square">
+            <a:spAutoFit/>
+          </a:bodyPr>
+          <a:lstStyle/>
+          <a:p>
+            <a:pPr algn="ctr"/>
+            <a:r>
+              <a:rPr sz="1350" i="1">
+                <a:solidFill>
+                  <a:srgbClr val="475569"/>
+                </a:solidFill>
+                <a:latin typeface="Helvetica Neue"/>
+              </a:rPr>
+              <a:t>Watch 0:00 to 8:00, stop at the end of Queries.     </a:t>
+            </a:r>
+            <a:r>
+              <a:rPr sz="1350" b="1" u="sng">
+                <a:solidFill>
+                  <a:srgbClr val="1D4ED8"/>
+                </a:solidFill>
+                <a:latin typeface="Helvetica Neue"/>
+                <a:hlinkClick r:id="rId3"/>
+              </a:rPr>
+              <a:t>3Blue1Brown, Attention in transformers</a:t>
+            </a:r>
+          </a:p>
+        </p:txBody>
+      </p:sp>
+      <p:sp>
+        <p:nvSpPr>
+          <p:cNvPr id="17" name="Rounded Rectangle 16"/>
           <p:cNvSpPr/>
           <p:nvPr/>
         </p:nvSpPr>
         <p:spPr>
           <a:xfrm>
-            <a:off x="7172553" y="6345936"/>
-            <a:ext cx="4379061" cy="365760"/>
+            <a:off x="7105802" y="6345936"/>
+            <a:ext cx="4445812" cy="365760"/>
           </a:xfrm>
           <a:prstGeom prst="roundRect">
             <a:avLst>
@@ -12721,13 +12060,13 @@
       </p:sp>
       <p:sp>
         <p:nvSpPr>
-          <p:cNvPr id="17" name="Rounded Rectangle 16"/>
+          <p:cNvPr id="18" name="Rounded Rectangle 17"/>
           <p:cNvSpPr/>
           <p:nvPr/>
         </p:nvSpPr>
         <p:spPr>
           <a:xfrm>
-            <a:off x="8214969" y="6396228"/>
+            <a:off x="8148218" y="6396228"/>
             <a:ext cx="685800" cy="265176"/>
           </a:xfrm>
           <a:prstGeom prst="roundRect">
@@ -12766,13 +12105,13 @@
       </p:sp>
       <p:sp>
         <p:nvSpPr>
-          <p:cNvPr id="18" name="TextBox 17"/>
-          <p:cNvSpPr txBox="1"/>
-          <p:nvPr/>
-        </p:nvSpPr>
-        <p:spPr>
-          <a:xfrm>
-            <a:off x="7328001" y="6460236"/>
+          <p:cNvPr id="19" name="TextBox 18"/>
+          <p:cNvSpPr txBox="1"/>
+          <p:nvPr/>
+        </p:nvSpPr>
+        <p:spPr>
+          <a:xfrm>
+            <a:off x="7261250" y="6460236"/>
             <a:ext cx="914400" cy="219456"/>
           </a:xfrm>
           <a:prstGeom prst="rect">
@@ -12801,13 +12140,13 @@
       </p:sp>
       <p:sp>
         <p:nvSpPr>
-          <p:cNvPr id="19" name="TextBox 18"/>
-          <p:cNvSpPr txBox="1"/>
-          <p:nvPr/>
-        </p:nvSpPr>
-        <p:spPr>
-          <a:xfrm>
-            <a:off x="8214969" y="6451092"/>
+          <p:cNvPr id="20" name="TextBox 19"/>
+          <p:cNvSpPr txBox="1"/>
+          <p:nvPr/>
+        </p:nvSpPr>
+        <p:spPr>
+          <a:xfrm>
+            <a:off x="8148218" y="6451092"/>
             <a:ext cx="685800" cy="219456"/>
           </a:xfrm>
           <a:prstGeom prst="rect">
@@ -12829,21 +12168,21 @@
                 </a:solidFill>
                 <a:latin typeface="Helvetica Neue"/>
               </a:rPr>
-              <a:t>STEP 7</a:t>
-            </a:r>
-          </a:p>
-        </p:txBody>
-      </p:sp>
-      <p:sp>
-        <p:nvSpPr>
-          <p:cNvPr id="20" name="TextBox 19"/>
-          <p:cNvSpPr txBox="1"/>
-          <p:nvPr/>
-        </p:nvSpPr>
-        <p:spPr>
-          <a:xfrm>
-            <a:off x="9019641" y="6460236"/>
-            <a:ext cx="2431389" cy="219456"/>
+              <a:t>STEP 9</a:t>
+            </a:r>
+          </a:p>
+        </p:txBody>
+      </p:sp>
+      <p:sp>
+        <p:nvSpPr>
+          <p:cNvPr id="21" name="TextBox 20"/>
+          <p:cNvSpPr txBox="1"/>
+          <p:nvPr/>
+        </p:nvSpPr>
+        <p:spPr>
+          <a:xfrm>
+            <a:off x="8952890" y="6460236"/>
+            <a:ext cx="2498140" cy="219456"/>
           </a:xfrm>
           <a:prstGeom prst="rect">
             <a:avLst/>
@@ -12864,7 +12203,7 @@
                 </a:solidFill>
                 <a:latin typeface="Helvetica Neue"/>
               </a:rPr>
-              <a:t>Test your product vocabulary</a:t>
+              <a:t>Watch attention change a word</a:t>
             </a:r>
           </a:p>
         </p:txBody>
@@ -12913,11 +12252,11 @@
             <a:r>
               <a:rPr sz="1250" b="1" i="0" spc="220">
                 <a:solidFill>
-                  <a:srgbClr val="0EA5E9"/>
-                </a:solidFill>
-                <a:latin typeface="Helvetica Neue"/>
-              </a:rPr>
-              <a:t>RETRIEVE</a:t>
+                  <a:srgbClr val="7C3AED"/>
+                </a:solidFill>
+                <a:latin typeface="Helvetica Neue"/>
+              </a:rPr>
+              <a:t>ROUTE</a:t>
             </a:r>
           </a:p>
         </p:txBody>
@@ -12931,7 +12270,7 @@
         <p:spPr>
           <a:xfrm>
             <a:off x="640080" y="758952"/>
-            <a:ext cx="7680960" cy="704088"/>
+            <a:ext cx="7680960" cy="1179576"/>
           </a:xfrm>
           <a:prstGeom prst="rect">
             <a:avLst/>
@@ -12952,7 +12291,7 @@
                 </a:solidFill>
                 <a:latin typeface="Helvetica Neue"/>
               </a:rPr>
-              <a:t>How the meaning gets in there.</a:t>
+              <a:t>Sort the inbox with no training data at all.</a:t>
             </a:r>
           </a:p>
         </p:txBody>
@@ -13008,8 +12347,8 @@
         </p:nvSpPr>
         <p:spPr>
           <a:xfrm>
-            <a:off x="8549640" y="438912"/>
-            <a:ext cx="329184" cy="329184"/>
+            <a:off x="8586215" y="475488"/>
+            <a:ext cx="256032" cy="256032"/>
           </a:xfrm>
           <a:prstGeom prst="roundRect">
             <a:avLst>
@@ -13053,8 +12392,8 @@
         </p:nvSpPr>
         <p:spPr>
           <a:xfrm>
-            <a:off x="8494776" y="475488"/>
-            <a:ext cx="438912" cy="256032"/>
+            <a:off x="8531351" y="475488"/>
+            <a:ext cx="365760" cy="256032"/>
           </a:xfrm>
           <a:prstGeom prst="rect">
             <a:avLst/>
@@ -13069,7 +12408,7 @@
           <a:p>
             <a:pPr algn="ctr"/>
             <a:r>
-              <a:rPr sz="1300" b="1" i="0">
+              <a:rPr sz="1050" b="1" i="0">
                 <a:solidFill>
                   <a:srgbClr val="FFFFFF"/>
                 </a:solidFill>
@@ -13088,7 +12427,87 @@
         </p:nvSpPr>
         <p:spPr>
           <a:xfrm>
-            <a:off x="9244584" y="475488"/>
+            <a:off x="9208008" y="438912"/>
+            <a:ext cx="329184" cy="329184"/>
+          </a:xfrm>
+          <a:prstGeom prst="roundRect">
+            <a:avLst>
+              <a:gd name="adj" fmla="val 32000"/>
+            </a:avLst>
+          </a:prstGeom>
+          <a:solidFill>
+            <a:srgbClr val="D97706"/>
+          </a:solidFill>
+          <a:ln>
+            <a:noFill/>
+          </a:ln>
+        </p:spPr>
+        <p:style>
+          <a:lnRef idx="1">
+            <a:schemeClr val="accent1"/>
+          </a:lnRef>
+          <a:fillRef idx="3">
+            <a:schemeClr val="accent1"/>
+          </a:fillRef>
+          <a:effectRef idx="2">
+            <a:schemeClr val="accent1"/>
+          </a:effectRef>
+          <a:fontRef idx="minor">
+            <a:schemeClr val="lt1"/>
+          </a:fontRef>
+        </p:style>
+        <p:txBody>
+          <a:bodyPr rtlCol="0" anchor="ctr"/>
+          <a:lstStyle/>
+          <a:p>
+            <a:pPr algn="ctr"/>
+          </a:p>
+        </p:txBody>
+      </p:sp>
+      <p:sp>
+        <p:nvSpPr>
+          <p:cNvPr id="8" name="TextBox 7"/>
+          <p:cNvSpPr txBox="1"/>
+          <p:nvPr/>
+        </p:nvSpPr>
+        <p:spPr>
+          <a:xfrm>
+            <a:off x="9153144" y="475488"/>
+            <a:ext cx="438912" cy="256032"/>
+          </a:xfrm>
+          <a:prstGeom prst="rect">
+            <a:avLst/>
+          </a:prstGeom>
+          <a:noFill/>
+        </p:spPr>
+        <p:txBody>
+          <a:bodyPr wrap="square" lIns="0" rIns="0" tIns="0" bIns="0">
+            <a:spAutoFit/>
+          </a:bodyPr>
+          <a:lstStyle/>
+          <a:p>
+            <a:pPr algn="ctr"/>
+            <a:r>
+              <a:rPr sz="1300" b="1" i="0">
+                <a:solidFill>
+                  <a:srgbClr val="FFFFFF"/>
+                </a:solidFill>
+                <a:latin typeface="Helvetica Neue"/>
+              </a:rPr>
+              <a:t>2</a:t>
+            </a:r>
+          </a:p>
+        </p:txBody>
+      </p:sp>
+      <p:sp>
+        <p:nvSpPr>
+          <p:cNvPr id="9" name="Rounded Rectangle 8"/>
+          <p:cNvSpPr/>
+          <p:nvPr/>
+        </p:nvSpPr>
+        <p:spPr>
+          <a:xfrm>
+            <a:off x="9902951" y="475488"/>
             <a:ext cx="256032" cy="256032"/>
           </a:xfrm>
           <a:prstGeom prst="roundRect">
@@ -13127,13 +12546,13 @@
       </p:sp>
       <p:sp>
         <p:nvSpPr>
-          <p:cNvPr id="8" name="TextBox 7"/>
-          <p:cNvSpPr txBox="1"/>
-          <p:nvPr/>
-        </p:nvSpPr>
-        <p:spPr>
-          <a:xfrm>
-            <a:off x="9189719" y="475488"/>
+          <p:cNvPr id="10" name="TextBox 9"/>
+          <p:cNvSpPr txBox="1"/>
+          <p:nvPr/>
+        </p:nvSpPr>
+        <p:spPr>
+          <a:xfrm>
+            <a:off x="9848087" y="475488"/>
             <a:ext cx="365760" cy="256032"/>
           </a:xfrm>
           <a:prstGeom prst="rect">
@@ -13155,20 +12574,20 @@
                 </a:solidFill>
                 <a:latin typeface="Helvetica Neue"/>
               </a:rPr>
-              <a:t>2</a:t>
-            </a:r>
-          </a:p>
-        </p:txBody>
-      </p:sp>
-      <p:sp>
-        <p:nvSpPr>
-          <p:cNvPr id="9" name="Rounded Rectangle 8"/>
+              <a:t>3</a:t>
+            </a:r>
+          </a:p>
+        </p:txBody>
+      </p:sp>
+      <p:sp>
+        <p:nvSpPr>
+          <p:cNvPr id="11" name="Rounded Rectangle 10"/>
           <p:cNvSpPr/>
           <p:nvPr/>
         </p:nvSpPr>
         <p:spPr>
           <a:xfrm>
-            <a:off x="9902951" y="475488"/>
+            <a:off x="10561319" y="475488"/>
             <a:ext cx="256032" cy="256032"/>
           </a:xfrm>
           <a:prstGeom prst="roundRect">
@@ -13207,86 +12626,6 @@
       </p:sp>
       <p:sp>
         <p:nvSpPr>
-          <p:cNvPr id="10" name="TextBox 9"/>
-          <p:cNvSpPr txBox="1"/>
-          <p:nvPr/>
-        </p:nvSpPr>
-        <p:spPr>
-          <a:xfrm>
-            <a:off x="9848087" y="475488"/>
-            <a:ext cx="365760" cy="256032"/>
-          </a:xfrm>
-          <a:prstGeom prst="rect">
-            <a:avLst/>
-          </a:prstGeom>
-          <a:noFill/>
-        </p:spPr>
-        <p:txBody>
-          <a:bodyPr wrap="square" lIns="0" rIns="0" tIns="0" bIns="0">
-            <a:spAutoFit/>
-          </a:bodyPr>
-          <a:lstStyle/>
-          <a:p>
-            <a:pPr algn="ctr"/>
-            <a:r>
-              <a:rPr sz="1050" b="1" i="0">
-                <a:solidFill>
-                  <a:srgbClr val="AEB4BF"/>
-                </a:solidFill>
-                <a:latin typeface="Helvetica Neue"/>
-              </a:rPr>
-              <a:t>3</a:t>
-            </a:r>
-          </a:p>
-        </p:txBody>
-      </p:sp>
-      <p:sp>
-        <p:nvSpPr>
-          <p:cNvPr id="11" name="Rounded Rectangle 10"/>
-          <p:cNvSpPr/>
-          <p:nvPr/>
-        </p:nvSpPr>
-        <p:spPr>
-          <a:xfrm>
-            <a:off x="10561319" y="475488"/>
-            <a:ext cx="256032" cy="256032"/>
-          </a:xfrm>
-          <a:prstGeom prst="roundRect">
-            <a:avLst>
-              <a:gd name="adj" fmla="val 32000"/>
-            </a:avLst>
-          </a:prstGeom>
-          <a:solidFill>
-            <a:srgbClr val="E9EBF0"/>
-          </a:solidFill>
-          <a:ln>
-            <a:noFill/>
-          </a:ln>
-        </p:spPr>
-        <p:style>
-          <a:lnRef idx="1">
-            <a:schemeClr val="accent1"/>
-          </a:lnRef>
-          <a:fillRef idx="3">
-            <a:schemeClr val="accent1"/>
-          </a:fillRef>
-          <a:effectRef idx="2">
-            <a:schemeClr val="accent1"/>
-          </a:effectRef>
-          <a:fontRef idx="minor">
-            <a:schemeClr val="lt1"/>
-          </a:fontRef>
-        </p:style>
-        <p:txBody>
-          <a:bodyPr rtlCol="0" anchor="ctr"/>
-          <a:lstStyle/>
-          <a:p>
-            <a:pPr algn="ctr"/>
-          </a:p>
-        </p:txBody>
-      </p:sp>
-      <p:sp>
-        <p:nvSpPr>
           <p:cNvPr id="12" name="TextBox 11"/>
           <p:cNvSpPr txBox="1"/>
           <p:nvPr/>
@@ -13357,7 +12696,7 @@
       </p:sp>
       <p:pic>
         <p:nvPicPr>
-          <p:cNvPr id="14" name="Picture 13" descr="fig_blockflow.png"/>
+          <p:cNvPr id="14" name="Picture 13" descr="d_zs.png"/>
           <p:cNvPicPr>
             <a:picLocks noChangeAspect="1"/>
           </p:cNvPicPr>
@@ -13371,8 +12710,8 @@
         </p:blipFill>
         <p:spPr>
           <a:xfrm>
-            <a:off x="607178" y="1632204"/>
-            <a:ext cx="10977337" cy="4315968"/>
+            <a:off x="1473370" y="1965960"/>
+            <a:ext cx="9244954" cy="4297679"/>
           </a:xfrm>
           <a:prstGeom prst="rect">
             <a:avLst/>
@@ -13381,59 +12720,14 @@
       </p:pic>
       <p:sp>
         <p:nvSpPr>
-          <p:cNvPr id="15" name="TextBox 14"/>
-          <p:cNvSpPr txBox="1"/>
-          <p:nvPr/>
-        </p:nvSpPr>
-        <p:spPr>
-          <a:xfrm>
-            <a:off x="640080" y="6035040"/>
-            <a:ext cx="10881360" cy="310896"/>
-          </a:xfrm>
-          <a:prstGeom prst="rect">
-            <a:avLst/>
-          </a:prstGeom>
-          <a:noFill/>
-        </p:spPr>
-        <p:txBody>
-          <a:bodyPr wrap="square">
-            <a:spAutoFit/>
-          </a:bodyPr>
-          <a:lstStyle/>
-          <a:p>
-            <a:pPr algn="ctr"/>
-            <a:r>
-              <a:rPr sz="1350" i="1">
-                <a:solidFill>
-                  <a:srgbClr val="475569"/>
-                </a:solidFill>
-                <a:latin typeface="Helvetica Neue"/>
-              </a:rPr>
-              <a:t>You built this in Lecture 11.     Go deeper:  </a:t>
-            </a:r>
-            <a:r>
-              <a:rPr sz="1350" b="1" u="sng">
-                <a:solidFill>
-                  <a:srgbClr val="1D4ED8"/>
-                </a:solidFill>
-                <a:latin typeface="Helvetica Neue"/>
-                <a:hlinkClick r:id="rId3"/>
-              </a:rPr>
-              <a:t>3Blue1Brown, Attention in transformers (26 min)</a:t>
-            </a:r>
-          </a:p>
-        </p:txBody>
-      </p:sp>
-      <p:sp>
-        <p:nvSpPr>
-          <p:cNvPr id="16" name="Rounded Rectangle 15"/>
+          <p:cNvPr id="15" name="Rounded Rectangle 14"/>
           <p:cNvSpPr/>
           <p:nvPr/>
         </p:nvSpPr>
         <p:spPr>
           <a:xfrm>
-            <a:off x="7105802" y="6345936"/>
-            <a:ext cx="4445812" cy="365760"/>
+            <a:off x="6505041" y="6345936"/>
+            <a:ext cx="5046573" cy="365760"/>
           </a:xfrm>
           <a:prstGeom prst="roundRect">
             <a:avLst>
@@ -13471,14 +12765,14 @@
       </p:sp>
       <p:sp>
         <p:nvSpPr>
-          <p:cNvPr id="17" name="Rounded Rectangle 16"/>
+          <p:cNvPr id="16" name="Rounded Rectangle 15"/>
           <p:cNvSpPr/>
           <p:nvPr/>
         </p:nvSpPr>
         <p:spPr>
           <a:xfrm>
-            <a:off x="8148218" y="6396228"/>
-            <a:ext cx="685800" cy="265176"/>
+            <a:off x="7547457" y="6396228"/>
+            <a:ext cx="754380" cy="265176"/>
           </a:xfrm>
           <a:prstGeom prst="roundRect">
             <a:avLst>
@@ -13516,14 +12810,49 @@
       </p:sp>
       <p:sp>
         <p:nvSpPr>
+          <p:cNvPr id="17" name="TextBox 16"/>
+          <p:cNvSpPr txBox="1"/>
+          <p:nvPr/>
+        </p:nvSpPr>
+        <p:spPr>
+          <a:xfrm>
+            <a:off x="6660489" y="6460236"/>
+            <a:ext cx="914400" cy="219456"/>
+          </a:xfrm>
+          <a:prstGeom prst="rect">
+            <a:avLst/>
+          </a:prstGeom>
+          <a:noFill/>
+        </p:spPr>
+        <p:txBody>
+          <a:bodyPr wrap="none" lIns="0" rIns="0" tIns="0" bIns="0">
+            <a:spAutoFit/>
+          </a:bodyPr>
+          <a:lstStyle/>
+          <a:p>
+            <a:pPr algn="l"/>
+            <a:r>
+              <a:rPr sz="950" b="1" i="0">
+                <a:solidFill>
+                  <a:srgbClr val="A7F3D0"/>
+                </a:solidFill>
+                <a:latin typeface="Helvetica Neue"/>
+              </a:rPr>
+              <a:t>▶ NOTEBOOK</a:t>
+            </a:r>
+          </a:p>
+        </p:txBody>
+      </p:sp>
+      <p:sp>
+        <p:nvSpPr>
           <p:cNvPr id="18" name="TextBox 17"/>
           <p:cNvSpPr txBox="1"/>
           <p:nvPr/>
         </p:nvSpPr>
         <p:spPr>
           <a:xfrm>
-            <a:off x="7261250" y="6460236"/>
-            <a:ext cx="914400" cy="219456"/>
+            <a:off x="7547457" y="6451092"/>
+            <a:ext cx="754380" cy="219456"/>
           </a:xfrm>
           <a:prstGeom prst="rect">
             <a:avLst/>
@@ -13536,85 +12865,50 @@
           </a:bodyPr>
           <a:lstStyle/>
           <a:p>
+            <a:pPr algn="ctr"/>
+            <a:r>
+              <a:rPr sz="1100" b="1" i="0">
+                <a:solidFill>
+                  <a:srgbClr val="FFFFFF"/>
+                </a:solidFill>
+                <a:latin typeface="Helvetica Neue"/>
+              </a:rPr>
+              <a:t>STEP 13</a:t>
+            </a:r>
+          </a:p>
+        </p:txBody>
+      </p:sp>
+      <p:sp>
+        <p:nvSpPr>
+          <p:cNvPr id="19" name="TextBox 18"/>
+          <p:cNvSpPr txBox="1"/>
+          <p:nvPr/>
+        </p:nvSpPr>
+        <p:spPr>
+          <a:xfrm>
+            <a:off x="8420709" y="6460236"/>
+            <a:ext cx="3030321" cy="219456"/>
+          </a:xfrm>
+          <a:prstGeom prst="rect">
+            <a:avLst/>
+          </a:prstGeom>
+          <a:noFill/>
+        </p:spPr>
+        <p:txBody>
+          <a:bodyPr wrap="none" lIns="0" rIns="0" tIns="0" bIns="0">
+            <a:spAutoFit/>
+          </a:bodyPr>
+          <a:lstStyle/>
+          <a:p>
             <a:pPr algn="l"/>
             <a:r>
-              <a:rPr sz="950" b="1" i="0">
-                <a:solidFill>
-                  <a:srgbClr val="A7F3D0"/>
-                </a:solidFill>
-                <a:latin typeface="Helvetica Neue"/>
-              </a:rPr>
-              <a:t>▶ NOTEBOOK</a:t>
-            </a:r>
-          </a:p>
-        </p:txBody>
-      </p:sp>
-      <p:sp>
-        <p:nvSpPr>
-          <p:cNvPr id="19" name="TextBox 18"/>
-          <p:cNvSpPr txBox="1"/>
-          <p:nvPr/>
-        </p:nvSpPr>
-        <p:spPr>
-          <a:xfrm>
-            <a:off x="8148218" y="6451092"/>
-            <a:ext cx="685800" cy="219456"/>
-          </a:xfrm>
-          <a:prstGeom prst="rect">
-            <a:avLst/>
-          </a:prstGeom>
-          <a:noFill/>
-        </p:spPr>
-        <p:txBody>
-          <a:bodyPr wrap="none" lIns="0" rIns="0" tIns="0" bIns="0">
-            <a:spAutoFit/>
-          </a:bodyPr>
-          <a:lstStyle/>
-          <a:p>
-            <a:pPr algn="ctr"/>
-            <a:r>
-              <a:rPr sz="1100" b="1" i="0">
+              <a:rPr sz="1000" b="1" i="0">
                 <a:solidFill>
                   <a:srgbClr val="FFFFFF"/>
                 </a:solidFill>
                 <a:latin typeface="Helvetica Neue"/>
               </a:rPr>
-              <a:t>STEP 9</a:t>
-            </a:r>
-          </a:p>
-        </p:txBody>
-      </p:sp>
-      <p:sp>
-        <p:nvSpPr>
-          <p:cNvPr id="20" name="TextBox 19"/>
-          <p:cNvSpPr txBox="1"/>
-          <p:nvPr/>
-        </p:nvSpPr>
-        <p:spPr>
-          <a:xfrm>
-            <a:off x="8952890" y="6460236"/>
-            <a:ext cx="2498140" cy="219456"/>
-          </a:xfrm>
-          <a:prstGeom prst="rect">
-            <a:avLst/>
-          </a:prstGeom>
-          <a:noFill/>
-        </p:spPr>
-        <p:txBody>
-          <a:bodyPr wrap="none" lIns="0" rIns="0" tIns="0" bIns="0">
-            <a:spAutoFit/>
-          </a:bodyPr>
-          <a:lstStyle/>
-          <a:p>
-            <a:pPr algn="l"/>
-            <a:r>
-              <a:rPr sz="1000" b="1" i="0">
-                <a:solidFill>
-                  <a:srgbClr val="FFFFFF"/>
-                </a:solidFill>
-                <a:latin typeface="Helvetica Neue"/>
-              </a:rPr>
-              <a:t>Watch attention change a word</a:t>
+              <a:t>Route the inbox with no training data</a:t>
             </a:r>
           </a:p>
         </p:txBody>

</xml_diff>

<commit_message>
Week 7: replace the semantic-search example with one that actually holds up
The old example searched for 'we are being charged wrong' and claimed the hits
shared no words with the query, but two of the three said 'charged'. The keyword
baseline was also rigged: it returned 0 only because it matched the whole phrase
as a substring.

New query: 'staff cannot access anything'. A FAIR keyword search (any of those
words) returns 5 hits, 4 of them junk that matched on 'anything', and misses both
locked-out tickets entirely. Semantic search finds them, and none of the three
results contains staff, access or anything. Verified against the real data.

Co-Authored-By: Claude Opus 4.8 <noreply@anthropic.com>
</commit_message>
<xml_diff>
--- a/Week 7/L13_Support_Copilot_v3_discussion.pptx
+++ b/Week 7/L13_Support_Copilot_v3_discussion.pptx
@@ -3633,7 +3633,7 @@
                 </a:solidFill>
                 <a:latin typeface="Helvetica Neue"/>
               </a:rPr>
-              <a:t>5,000 tickets a week, three agents, and nothing in the queue has ever been sorted. Let's ship anyway.</a:t>
+              <a:t>5,000 tickets a week, three support reps, and nothing in the queue has ever been sorted. Let's ship anyway.</a:t>
             </a:r>
           </a:p>
         </p:txBody>
@@ -9109,7 +9109,7 @@
                 </a:solidFill>
                 <a:latin typeface="Helvetica Neue"/>
               </a:rPr>
-              <a:t>And that reading is where the three agents lose their day.</a:t>
+              <a:t>And that reading is where the three support reps lose their day.</a:t>
             </a:r>
           </a:p>
         </p:txBody>
@@ -10480,8 +10480,8 @@
         </p:blipFill>
         <p:spPr>
           <a:xfrm>
-            <a:off x="518007" y="2013030"/>
-            <a:ext cx="11155680" cy="4157819"/>
+            <a:off x="1986177" y="1965960"/>
+            <a:ext cx="8219340" cy="4251960"/>
           </a:xfrm>
           <a:prstGeom prst="rect">
             <a:avLst/>

</xml_diff>

<commit_message>
L13: cost comparison on slide 9, swap slides 10/11 to match notebook step order (L13_Support_Copilot_v3_discussion.pptx)
</commit_message>
<xml_diff>
--- a/Week 7/L13_Support_Copilot_v3_discussion.pptx
+++ b/Week 7/L13_Support_Copilot_v3_discussion.pptx
@@ -3735,7 +3735,7 @@
         <p:spPr>
           <a:xfrm>
             <a:off x="640080" y="758952"/>
-            <a:ext cx="7680960" cy="704088"/>
+            <a:ext cx="7680960" cy="1179576"/>
           </a:xfrm>
           <a:prstGeom prst="rect">
             <a:avLst/>
@@ -3750,55 +3750,20 @@
           <a:p>
             <a:pPr algn="l"/>
             <a:r>
-              <a:rPr sz="2450" b="1" i="0">
+              <a:rPr sz="2900" b="1" i="0">
                 <a:solidFill>
                   <a:srgbClr val="0F172A"/>
                 </a:solidFill>
                 <a:latin typeface="Helvetica Neue"/>
               </a:rPr>
-              <a:t>It is not a classifier. It is a fact-checker.</a:t>
-            </a:r>
-          </a:p>
-        </p:txBody>
-      </p:sp>
-      <p:sp>
-        <p:nvSpPr>
-          <p:cNvPr id="4" name="TextBox 3"/>
-          <p:cNvSpPr txBox="1"/>
-          <p:nvPr/>
-        </p:nvSpPr>
-        <p:spPr>
-          <a:xfrm>
-            <a:off x="640080" y="1417320"/>
-            <a:ext cx="10424160" cy="457200"/>
-          </a:xfrm>
-          <a:prstGeom prst="rect">
-            <a:avLst/>
-          </a:prstGeom>
-          <a:noFill/>
-        </p:spPr>
-        <p:txBody>
-          <a:bodyPr wrap="square" lIns="0" rIns="0" tIns="0" bIns="0">
-            <a:spAutoFit/>
-          </a:bodyPr>
-          <a:lstStyle/>
-          <a:p>
-            <a:pPr algn="l"/>
-            <a:r>
-              <a:rPr sz="1500" b="0" i="0">
-                <a:solidFill>
-                  <a:srgbClr val="475569"/>
-                </a:solidFill>
-                <a:latin typeface="Helvetica Neue"/>
-              </a:rPr>
-              <a:t>The model judges whether a sentence YOU wrote is true of the ticket.</a:t>
-            </a:r>
-          </a:p>
-        </p:txBody>
-      </p:sp>
-      <p:sp>
-        <p:nvSpPr>
-          <p:cNvPr id="5" name="Rounded Rectangle 4"/>
+              <a:t>The descriptions you write ARE the program.</a:t>
+            </a:r>
+          </a:p>
+        </p:txBody>
+      </p:sp>
+      <p:sp>
+        <p:nvSpPr>
+          <p:cNvPr id="4" name="Rounded Rectangle 3"/>
           <p:cNvSpPr/>
           <p:nvPr/>
         </p:nvSpPr>
@@ -3841,7 +3806,7 @@
       </p:sp>
       <p:sp>
         <p:nvSpPr>
-          <p:cNvPr id="6" name="Rounded Rectangle 5"/>
+          <p:cNvPr id="5" name="Rounded Rectangle 4"/>
           <p:cNvSpPr/>
           <p:nvPr/>
         </p:nvSpPr>
@@ -3886,7 +3851,7 @@
       </p:sp>
       <p:sp>
         <p:nvSpPr>
-          <p:cNvPr id="7" name="TextBox 6"/>
+          <p:cNvPr id="6" name="TextBox 5"/>
           <p:cNvSpPr txBox="1"/>
           <p:nvPr/>
         </p:nvSpPr>
@@ -3921,7 +3886,7 @@
       </p:sp>
       <p:sp>
         <p:nvSpPr>
-          <p:cNvPr id="8" name="Rounded Rectangle 7"/>
+          <p:cNvPr id="7" name="Rounded Rectangle 6"/>
           <p:cNvSpPr/>
           <p:nvPr/>
         </p:nvSpPr>
@@ -3966,7 +3931,7 @@
       </p:sp>
       <p:sp>
         <p:nvSpPr>
-          <p:cNvPr id="9" name="TextBox 8"/>
+          <p:cNvPr id="8" name="TextBox 7"/>
           <p:cNvSpPr txBox="1"/>
           <p:nvPr/>
         </p:nvSpPr>
@@ -4001,7 +3966,7 @@
       </p:sp>
       <p:sp>
         <p:nvSpPr>
-          <p:cNvPr id="10" name="Rounded Rectangle 9"/>
+          <p:cNvPr id="9" name="Rounded Rectangle 8"/>
           <p:cNvSpPr/>
           <p:nvPr/>
         </p:nvSpPr>
@@ -4046,7 +4011,7 @@
       </p:sp>
       <p:sp>
         <p:nvSpPr>
-          <p:cNvPr id="11" name="TextBox 10"/>
+          <p:cNvPr id="10" name="TextBox 9"/>
           <p:cNvSpPr txBox="1"/>
           <p:nvPr/>
         </p:nvSpPr>
@@ -4081,7 +4046,7 @@
       </p:sp>
       <p:sp>
         <p:nvSpPr>
-          <p:cNvPr id="12" name="Rounded Rectangle 11"/>
+          <p:cNvPr id="11" name="Rounded Rectangle 10"/>
           <p:cNvSpPr/>
           <p:nvPr/>
         </p:nvSpPr>
@@ -4126,7 +4091,7 @@
       </p:sp>
       <p:sp>
         <p:nvSpPr>
-          <p:cNvPr id="13" name="TextBox 12"/>
+          <p:cNvPr id="12" name="TextBox 11"/>
           <p:cNvSpPr txBox="1"/>
           <p:nvPr/>
         </p:nvSpPr>
@@ -4161,7 +4126,7 @@
       </p:sp>
       <p:sp>
         <p:nvSpPr>
-          <p:cNvPr id="14" name="TextBox 13"/>
+          <p:cNvPr id="13" name="TextBox 12"/>
           <p:cNvSpPr txBox="1"/>
           <p:nvPr/>
         </p:nvSpPr>
@@ -4196,7 +4161,7 @@
       </p:sp>
       <p:pic>
         <p:nvPicPr>
-          <p:cNvPr id="15" name="Picture 14" descr="d_nli.png"/>
+          <p:cNvPr id="14" name="Picture 13" descr="d_wording.png"/>
           <p:cNvPicPr>
             <a:picLocks noChangeAspect="1"/>
           </p:cNvPicPr>
@@ -4210,8 +4175,8 @@
         </p:blipFill>
         <p:spPr>
           <a:xfrm>
-            <a:off x="518007" y="2596680"/>
-            <a:ext cx="11155680" cy="2350438"/>
+            <a:off x="518007" y="2769342"/>
+            <a:ext cx="11155680" cy="2599474"/>
           </a:xfrm>
           <a:prstGeom prst="rect">
             <a:avLst/>
@@ -4220,14 +4185,14 @@
       </p:pic>
       <p:sp>
         <p:nvSpPr>
-          <p:cNvPr id="16" name="Rounded Rectangle 15"/>
+          <p:cNvPr id="15" name="Rounded Rectangle 14"/>
           <p:cNvSpPr/>
           <p:nvPr/>
         </p:nvSpPr>
         <p:spPr>
           <a:xfrm>
-            <a:off x="7306056" y="6345936"/>
-            <a:ext cx="4245559" cy="365760"/>
+            <a:off x="6638544" y="6345936"/>
+            <a:ext cx="4913071" cy="365760"/>
           </a:xfrm>
           <a:prstGeom prst="roundRect">
             <a:avLst>
@@ -4265,13 +4230,13 @@
       </p:sp>
       <p:sp>
         <p:nvSpPr>
-          <p:cNvPr id="17" name="Rounded Rectangle 16"/>
+          <p:cNvPr id="16" name="Rounded Rectangle 15"/>
           <p:cNvSpPr/>
           <p:nvPr/>
         </p:nvSpPr>
         <p:spPr>
           <a:xfrm>
-            <a:off x="8348472" y="6396228"/>
+            <a:off x="7680960" y="6396228"/>
             <a:ext cx="754380" cy="265176"/>
           </a:xfrm>
           <a:prstGeom prst="roundRect">
@@ -4310,14 +4275,49 @@
       </p:sp>
       <p:sp>
         <p:nvSpPr>
+          <p:cNvPr id="17" name="TextBox 16"/>
+          <p:cNvSpPr txBox="1"/>
+          <p:nvPr/>
+        </p:nvSpPr>
+        <p:spPr>
+          <a:xfrm>
+            <a:off x="6793992" y="6460236"/>
+            <a:ext cx="914400" cy="219456"/>
+          </a:xfrm>
+          <a:prstGeom prst="rect">
+            <a:avLst/>
+          </a:prstGeom>
+          <a:noFill/>
+        </p:spPr>
+        <p:txBody>
+          <a:bodyPr wrap="none" lIns="0" rIns="0" tIns="0" bIns="0">
+            <a:spAutoFit/>
+          </a:bodyPr>
+          <a:lstStyle/>
+          <a:p>
+            <a:pPr algn="l"/>
+            <a:r>
+              <a:rPr sz="950" b="1" i="0">
+                <a:solidFill>
+                  <a:srgbClr val="A7F3D0"/>
+                </a:solidFill>
+                <a:latin typeface="Helvetica Neue"/>
+              </a:rPr>
+              <a:t>▶ NOTEBOOK</a:t>
+            </a:r>
+          </a:p>
+        </p:txBody>
+      </p:sp>
+      <p:sp>
+        <p:nvSpPr>
           <p:cNvPr id="18" name="TextBox 17"/>
           <p:cNvSpPr txBox="1"/>
           <p:nvPr/>
         </p:nvSpPr>
         <p:spPr>
           <a:xfrm>
-            <a:off x="7461504" y="6460236"/>
-            <a:ext cx="914400" cy="219456"/>
+            <a:off x="7680960" y="6451092"/>
+            <a:ext cx="754380" cy="219456"/>
           </a:xfrm>
           <a:prstGeom prst="rect">
             <a:avLst/>
@@ -4330,120 +4330,50 @@
           </a:bodyPr>
           <a:lstStyle/>
           <a:p>
+            <a:pPr algn="ctr"/>
+            <a:r>
+              <a:rPr sz="1100" b="1" i="0">
+                <a:solidFill>
+                  <a:srgbClr val="FFFFFF"/>
+                </a:solidFill>
+                <a:latin typeface="Helvetica Neue"/>
+              </a:rPr>
+              <a:t>STEP 16</a:t>
+            </a:r>
+          </a:p>
+        </p:txBody>
+      </p:sp>
+      <p:sp>
+        <p:nvSpPr>
+          <p:cNvPr id="19" name="TextBox 18"/>
+          <p:cNvSpPr txBox="1"/>
+          <p:nvPr/>
+        </p:nvSpPr>
+        <p:spPr>
+          <a:xfrm>
+            <a:off x="8554212" y="6460236"/>
+            <a:ext cx="2896819" cy="219456"/>
+          </a:xfrm>
+          <a:prstGeom prst="rect">
+            <a:avLst/>
+          </a:prstGeom>
+          <a:noFill/>
+        </p:spPr>
+        <p:txBody>
+          <a:bodyPr wrap="none" lIns="0" rIns="0" tIns="0" bIns="0">
+            <a:spAutoFit/>
+          </a:bodyPr>
+          <a:lstStyle/>
+          <a:p>
             <a:pPr algn="l"/>
             <a:r>
-              <a:rPr sz="950" b="1" i="0">
-                <a:solidFill>
-                  <a:srgbClr val="A7F3D0"/>
-                </a:solidFill>
-                <a:latin typeface="Helvetica Neue"/>
-              </a:rPr>
-              <a:t>▶ NOTEBOOK</a:t>
-            </a:r>
-          </a:p>
-        </p:txBody>
-      </p:sp>
-      <p:sp>
-        <p:nvSpPr>
-          <p:cNvPr id="19" name="TextBox 18"/>
-          <p:cNvSpPr txBox="1"/>
-          <p:nvPr/>
-        </p:nvSpPr>
-        <p:spPr>
-          <a:xfrm>
-            <a:off x="8348472" y="6451092"/>
-            <a:ext cx="754380" cy="219456"/>
-          </a:xfrm>
-          <a:prstGeom prst="rect">
-            <a:avLst/>
-          </a:prstGeom>
-          <a:noFill/>
-        </p:spPr>
-        <p:txBody>
-          <a:bodyPr wrap="none" lIns="0" rIns="0" tIns="0" bIns="0">
-            <a:spAutoFit/>
-          </a:bodyPr>
-          <a:lstStyle/>
-          <a:p>
-            <a:pPr algn="ctr"/>
-            <a:r>
-              <a:rPr sz="1100" b="1" i="0">
+              <a:rPr sz="1000" b="1" i="0">
                 <a:solidFill>
                   <a:srgbClr val="FFFFFF"/>
                 </a:solidFill>
                 <a:latin typeface="Helvetica Neue"/>
               </a:rPr>
-              <a:t>STEP 17</a:t>
-            </a:r>
-          </a:p>
-        </p:txBody>
-      </p:sp>
-      <p:sp>
-        <p:nvSpPr>
-          <p:cNvPr id="20" name="TextBox 19"/>
-          <p:cNvSpPr txBox="1"/>
-          <p:nvPr/>
-        </p:nvSpPr>
-        <p:spPr>
-          <a:xfrm>
-            <a:off x="9221724" y="6460236"/>
-            <a:ext cx="2229307" cy="219456"/>
-          </a:xfrm>
-          <a:prstGeom prst="rect">
-            <a:avLst/>
-          </a:prstGeom>
-          <a:noFill/>
-        </p:spPr>
-        <p:txBody>
-          <a:bodyPr wrap="none" lIns="0" rIns="0" tIns="0" bIns="0">
-            <a:spAutoFit/>
-          </a:bodyPr>
-          <a:lstStyle/>
-          <a:p>
-            <a:pPr algn="l"/>
-            <a:r>
-              <a:rPr sz="1000" b="1" i="0">
-                <a:solidFill>
-                  <a:srgbClr val="FFFFFF"/>
-                </a:solidFill>
-                <a:latin typeface="Helvetica Neue"/>
-              </a:rPr>
-              <a:t>See the entailment scores</a:t>
-            </a:r>
-          </a:p>
-        </p:txBody>
-      </p:sp>
-      <p:sp>
-        <p:nvSpPr>
-          <p:cNvPr id="21" name="TextBox 20"/>
-          <p:cNvSpPr txBox="1"/>
-          <p:nvPr/>
-        </p:nvSpPr>
-        <p:spPr>
-          <a:xfrm>
-            <a:off x="640080" y="5532120"/>
-            <a:ext cx="10881360" cy="640080"/>
-          </a:xfrm>
-          <a:prstGeom prst="rect">
-            <a:avLst/>
-          </a:prstGeom>
-          <a:noFill/>
-        </p:spPr>
-        <p:txBody>
-          <a:bodyPr wrap="square" lIns="0" rIns="0" tIns="0" bIns="0">
-            <a:spAutoFit/>
-          </a:bodyPr>
-          <a:lstStyle/>
-          <a:p>
-            <a:pPr algn="ctr"/>
-            <a:r>
-              <a:rPr sz="1500" b="0" i="1">
-                <a:solidFill>
-                  <a:srgbClr val="475569"/>
-                </a:solidFill>
-                <a:latin typeface="Helvetica Neue"/>
-              </a:rPr>
-              <a:t>Every category becomes a sentence: "This example is {your description}." The model scores all eight and picks whichever it most believes.</a:t>
+              <a:t>YOUR KNOB: rewrite the descriptions</a:t>
             </a:r>
           </a:p>
         </p:txBody>
@@ -4510,7 +4440,7 @@
         <p:spPr>
           <a:xfrm>
             <a:off x="640080" y="758952"/>
-            <a:ext cx="7680960" cy="1179576"/>
+            <a:ext cx="7680960" cy="704088"/>
           </a:xfrm>
           <a:prstGeom prst="rect">
             <a:avLst/>
@@ -4525,20 +4455,55 @@
           <a:p>
             <a:pPr algn="l"/>
             <a:r>
-              <a:rPr sz="2900" b="1" i="0">
+              <a:rPr sz="2450" b="1" i="0">
                 <a:solidFill>
                   <a:srgbClr val="0F172A"/>
                 </a:solidFill>
                 <a:latin typeface="Helvetica Neue"/>
               </a:rPr>
-              <a:t>The descriptions you write ARE the program.</a:t>
-            </a:r>
-          </a:p>
-        </p:txBody>
-      </p:sp>
-      <p:sp>
-        <p:nvSpPr>
-          <p:cNvPr id="4" name="Rounded Rectangle 3"/>
+              <a:t>It is not a classifier. It is a fact-checker.</a:t>
+            </a:r>
+          </a:p>
+        </p:txBody>
+      </p:sp>
+      <p:sp>
+        <p:nvSpPr>
+          <p:cNvPr id="4" name="TextBox 3"/>
+          <p:cNvSpPr txBox="1"/>
+          <p:nvPr/>
+        </p:nvSpPr>
+        <p:spPr>
+          <a:xfrm>
+            <a:off x="640080" y="1417320"/>
+            <a:ext cx="10424160" cy="457200"/>
+          </a:xfrm>
+          <a:prstGeom prst="rect">
+            <a:avLst/>
+          </a:prstGeom>
+          <a:noFill/>
+        </p:spPr>
+        <p:txBody>
+          <a:bodyPr wrap="square" lIns="0" rIns="0" tIns="0" bIns="0">
+            <a:spAutoFit/>
+          </a:bodyPr>
+          <a:lstStyle/>
+          <a:p>
+            <a:pPr algn="l"/>
+            <a:r>
+              <a:rPr sz="1500" b="0" i="0">
+                <a:solidFill>
+                  <a:srgbClr val="475569"/>
+                </a:solidFill>
+                <a:latin typeface="Helvetica Neue"/>
+              </a:rPr>
+              <a:t>The model judges whether a sentence YOU wrote is true of the ticket.</a:t>
+            </a:r>
+          </a:p>
+        </p:txBody>
+      </p:sp>
+      <p:sp>
+        <p:nvSpPr>
+          <p:cNvPr id="5" name="Rounded Rectangle 4"/>
           <p:cNvSpPr/>
           <p:nvPr/>
         </p:nvSpPr>
@@ -4581,7 +4546,7 @@
       </p:sp>
       <p:sp>
         <p:nvSpPr>
-          <p:cNvPr id="5" name="Rounded Rectangle 4"/>
+          <p:cNvPr id="6" name="Rounded Rectangle 5"/>
           <p:cNvSpPr/>
           <p:nvPr/>
         </p:nvSpPr>
@@ -4626,7 +4591,7 @@
       </p:sp>
       <p:sp>
         <p:nvSpPr>
-          <p:cNvPr id="6" name="TextBox 5"/>
+          <p:cNvPr id="7" name="TextBox 6"/>
           <p:cNvSpPr txBox="1"/>
           <p:nvPr/>
         </p:nvSpPr>
@@ -4661,7 +4626,7 @@
       </p:sp>
       <p:sp>
         <p:nvSpPr>
-          <p:cNvPr id="7" name="Rounded Rectangle 6"/>
+          <p:cNvPr id="8" name="Rounded Rectangle 7"/>
           <p:cNvSpPr/>
           <p:nvPr/>
         </p:nvSpPr>
@@ -4706,7 +4671,7 @@
       </p:sp>
       <p:sp>
         <p:nvSpPr>
-          <p:cNvPr id="8" name="TextBox 7"/>
+          <p:cNvPr id="9" name="TextBox 8"/>
           <p:cNvSpPr txBox="1"/>
           <p:nvPr/>
         </p:nvSpPr>
@@ -4741,7 +4706,7 @@
       </p:sp>
       <p:sp>
         <p:nvSpPr>
-          <p:cNvPr id="9" name="Rounded Rectangle 8"/>
+          <p:cNvPr id="10" name="Rounded Rectangle 9"/>
           <p:cNvSpPr/>
           <p:nvPr/>
         </p:nvSpPr>
@@ -4786,7 +4751,7 @@
       </p:sp>
       <p:sp>
         <p:nvSpPr>
-          <p:cNvPr id="10" name="TextBox 9"/>
+          <p:cNvPr id="11" name="TextBox 10"/>
           <p:cNvSpPr txBox="1"/>
           <p:nvPr/>
         </p:nvSpPr>
@@ -4821,7 +4786,7 @@
       </p:sp>
       <p:sp>
         <p:nvSpPr>
-          <p:cNvPr id="11" name="Rounded Rectangle 10"/>
+          <p:cNvPr id="12" name="Rounded Rectangle 11"/>
           <p:cNvSpPr/>
           <p:nvPr/>
         </p:nvSpPr>
@@ -4866,7 +4831,7 @@
       </p:sp>
       <p:sp>
         <p:nvSpPr>
-          <p:cNvPr id="12" name="TextBox 11"/>
+          <p:cNvPr id="13" name="TextBox 12"/>
           <p:cNvSpPr txBox="1"/>
           <p:nvPr/>
         </p:nvSpPr>
@@ -4901,7 +4866,7 @@
       </p:sp>
       <p:sp>
         <p:nvSpPr>
-          <p:cNvPr id="13" name="TextBox 12"/>
+          <p:cNvPr id="14" name="TextBox 13"/>
           <p:cNvSpPr txBox="1"/>
           <p:nvPr/>
         </p:nvSpPr>
@@ -4936,7 +4901,7 @@
       </p:sp>
       <p:pic>
         <p:nvPicPr>
-          <p:cNvPr id="14" name="Picture 13" descr="d_wording.png"/>
+          <p:cNvPr id="15" name="Picture 14" descr="d_nli.png"/>
           <p:cNvPicPr>
             <a:picLocks noChangeAspect="1"/>
           </p:cNvPicPr>
@@ -4950,8 +4915,8 @@
         </p:blipFill>
         <p:spPr>
           <a:xfrm>
-            <a:off x="518007" y="2769342"/>
-            <a:ext cx="11155680" cy="2599474"/>
+            <a:off x="518007" y="2596680"/>
+            <a:ext cx="11155680" cy="2350438"/>
           </a:xfrm>
           <a:prstGeom prst="rect">
             <a:avLst/>
@@ -4960,14 +4925,14 @@
       </p:pic>
       <p:sp>
         <p:nvSpPr>
-          <p:cNvPr id="15" name="Rounded Rectangle 14"/>
+          <p:cNvPr id="16" name="Rounded Rectangle 15"/>
           <p:cNvSpPr/>
           <p:nvPr/>
         </p:nvSpPr>
         <p:spPr>
           <a:xfrm>
-            <a:off x="6638544" y="6345936"/>
-            <a:ext cx="4913071" cy="365760"/>
+            <a:off x="7306056" y="6345936"/>
+            <a:ext cx="4245559" cy="365760"/>
           </a:xfrm>
           <a:prstGeom prst="roundRect">
             <a:avLst>
@@ -5005,13 +4970,13 @@
       </p:sp>
       <p:sp>
         <p:nvSpPr>
-          <p:cNvPr id="16" name="Rounded Rectangle 15"/>
+          <p:cNvPr id="17" name="Rounded Rectangle 16"/>
           <p:cNvSpPr/>
           <p:nvPr/>
         </p:nvSpPr>
         <p:spPr>
           <a:xfrm>
-            <a:off x="7680960" y="6396228"/>
+            <a:off x="8348472" y="6396228"/>
             <a:ext cx="754380" cy="265176"/>
           </a:xfrm>
           <a:prstGeom prst="roundRect">
@@ -5050,13 +5015,13 @@
       </p:sp>
       <p:sp>
         <p:nvSpPr>
-          <p:cNvPr id="17" name="TextBox 16"/>
-          <p:cNvSpPr txBox="1"/>
-          <p:nvPr/>
-        </p:nvSpPr>
-        <p:spPr>
-          <a:xfrm>
-            <a:off x="6793992" y="6460236"/>
+          <p:cNvPr id="18" name="TextBox 17"/>
+          <p:cNvSpPr txBox="1"/>
+          <p:nvPr/>
+        </p:nvSpPr>
+        <p:spPr>
+          <a:xfrm>
+            <a:off x="7461504" y="6460236"/>
             <a:ext cx="914400" cy="219456"/>
           </a:xfrm>
           <a:prstGeom prst="rect">
@@ -5085,13 +5050,13 @@
       </p:sp>
       <p:sp>
         <p:nvSpPr>
-          <p:cNvPr id="18" name="TextBox 17"/>
-          <p:cNvSpPr txBox="1"/>
-          <p:nvPr/>
-        </p:nvSpPr>
-        <p:spPr>
-          <a:xfrm>
-            <a:off x="7680960" y="6451092"/>
+          <p:cNvPr id="19" name="TextBox 18"/>
+          <p:cNvSpPr txBox="1"/>
+          <p:nvPr/>
+        </p:nvSpPr>
+        <p:spPr>
+          <a:xfrm>
+            <a:off x="8348472" y="6451092"/>
             <a:ext cx="754380" cy="219456"/>
           </a:xfrm>
           <a:prstGeom prst="rect">
@@ -5113,21 +5078,21 @@
                 </a:solidFill>
                 <a:latin typeface="Helvetica Neue"/>
               </a:rPr>
-              <a:t>STEP 16</a:t>
-            </a:r>
-          </a:p>
-        </p:txBody>
-      </p:sp>
-      <p:sp>
-        <p:nvSpPr>
-          <p:cNvPr id="19" name="TextBox 18"/>
-          <p:cNvSpPr txBox="1"/>
-          <p:nvPr/>
-        </p:nvSpPr>
-        <p:spPr>
-          <a:xfrm>
-            <a:off x="8554212" y="6460236"/>
-            <a:ext cx="2896819" cy="219456"/>
+              <a:t>STEP 17</a:t>
+            </a:r>
+          </a:p>
+        </p:txBody>
+      </p:sp>
+      <p:sp>
+        <p:nvSpPr>
+          <p:cNvPr id="20" name="TextBox 19"/>
+          <p:cNvSpPr txBox="1"/>
+          <p:nvPr/>
+        </p:nvSpPr>
+        <p:spPr>
+          <a:xfrm>
+            <a:off x="9221724" y="6460236"/>
+            <a:ext cx="2229307" cy="219456"/>
           </a:xfrm>
           <a:prstGeom prst="rect">
             <a:avLst/>
@@ -5148,7 +5113,42 @@
                 </a:solidFill>
                 <a:latin typeface="Helvetica Neue"/>
               </a:rPr>
-              <a:t>YOUR KNOB: rewrite the descriptions</a:t>
+              <a:t>See the entailment scores</a:t>
+            </a:r>
+          </a:p>
+        </p:txBody>
+      </p:sp>
+      <p:sp>
+        <p:nvSpPr>
+          <p:cNvPr id="21" name="TextBox 20"/>
+          <p:cNvSpPr txBox="1"/>
+          <p:nvPr/>
+        </p:nvSpPr>
+        <p:spPr>
+          <a:xfrm>
+            <a:off x="640080" y="5532120"/>
+            <a:ext cx="10881360" cy="640080"/>
+          </a:xfrm>
+          <a:prstGeom prst="rect">
+            <a:avLst/>
+          </a:prstGeom>
+          <a:noFill/>
+        </p:spPr>
+        <p:txBody>
+          <a:bodyPr wrap="square" lIns="0" rIns="0" tIns="0" bIns="0">
+            <a:spAutoFit/>
+          </a:bodyPr>
+          <a:lstStyle/>
+          <a:p>
+            <a:pPr algn="ctr"/>
+            <a:r>
+              <a:rPr sz="1500" b="0" i="1">
+                <a:solidFill>
+                  <a:srgbClr val="475569"/>
+                </a:solidFill>
+                <a:latin typeface="Helvetica Neue"/>
+              </a:rPr>
+              <a:t>Every category becomes a sentence: "This example is {your description}." The model scores all eight and picks whichever it most believes.</a:t>
             </a:r>
           </a:p>
         </p:txBody>
@@ -12726,8 +12726,8 @@
         </p:nvSpPr>
         <p:spPr>
           <a:xfrm>
-            <a:off x="6505041" y="6345936"/>
-            <a:ext cx="5046573" cy="365760"/>
+            <a:off x="6772046" y="6345936"/>
+            <a:ext cx="4779568" cy="365760"/>
           </a:xfrm>
           <a:prstGeom prst="roundRect">
             <a:avLst>
@@ -12771,8 +12771,8 @@
         </p:nvSpPr>
         <p:spPr>
           <a:xfrm>
-            <a:off x="7547457" y="6396228"/>
-            <a:ext cx="754380" cy="265176"/>
+            <a:off x="7814462" y="6396228"/>
+            <a:ext cx="960120" cy="265176"/>
           </a:xfrm>
           <a:prstGeom prst="roundRect">
             <a:avLst>
@@ -12816,7 +12816,7 @@
         </p:nvSpPr>
         <p:spPr>
           <a:xfrm>
-            <a:off x="6660489" y="6460236"/>
+            <a:off x="6927494" y="6460236"/>
             <a:ext cx="914400" cy="219456"/>
           </a:xfrm>
           <a:prstGeom prst="rect">
@@ -12851,8 +12851,8 @@
         </p:nvSpPr>
         <p:spPr>
           <a:xfrm>
-            <a:off x="7547457" y="6451092"/>
-            <a:ext cx="754380" cy="219456"/>
+            <a:off x="7814462" y="6451092"/>
+            <a:ext cx="960120" cy="219456"/>
           </a:xfrm>
           <a:prstGeom prst="rect">
             <a:avLst/>
@@ -12873,7 +12873,7 @@
                 </a:solidFill>
                 <a:latin typeface="Helvetica Neue"/>
               </a:rPr>
-              <a:t>STEP 13</a:t>
+              <a:t>STEP 13-15</a:t>
             </a:r>
           </a:p>
         </p:txBody>
@@ -12886,8 +12886,8 @@
         </p:nvSpPr>
         <p:spPr>
           <a:xfrm>
-            <a:off x="8420709" y="6460236"/>
-            <a:ext cx="3030321" cy="219456"/>
+            <a:off x="8893454" y="6460236"/>
+            <a:ext cx="2557576" cy="219456"/>
           </a:xfrm>
           <a:prstGeom prst="rect">
             <a:avLst/>
@@ -12908,7 +12908,7 @@
                 </a:solidFill>
                 <a:latin typeface="Helvetica Neue"/>
               </a:rPr>
-              <a:t>Route the inbox with no training data</a:t>
+              <a:t>Route the inbox, then grade it</a:t>
             </a:r>
           </a:p>
         </p:txBody>

</xml_diff>